<commit_message>
Add Fraud Agent, human-in-the-loop review, vendor memory and PDF upload
- Fraud Agent: lookalike vendor names, bank-account changes, amount spikes
  vs vendor history and round totals, with a 0-100 risk score and reasons
- Human in the loop: escalations pause at a LangGraph interrupt with a
  checkpointer (plain-Python runner mirrors it); review queue in the app,
  --hitl in the CLI, audit trail
- Vendor memory: JSON profiles the Fraud Agent reads and reviewer
  decisions update (e.g. an approved bank change becomes the account on file)
- PDF upload and sample-PDF export; re-uploads are caught as duplicates
- Critic also checks the extracted total appears in the document
- Seeded fraud cases in the data generator; 15 pytest end-to-end tests
- Report, slides, PDFs and README updated

Co-Authored-By: Claude Opus 5.5 <noreply@anthropic.com>
Claude-Session: https://claude.ai/code/session_01FNCCHJM4a9NtCwN3j6hQhR
</commit_message>
<xml_diff>
--- a/docs/FAAISaafalyaSengupta158.pptx
+++ b/docs/FAAISaafalyaSengupta158.pptx
@@ -10,6 +10,8 @@
     <p:sldId id="258" r:id="rId4"/>
     <p:sldId id="259" r:id="rId5"/>
     <p:sldId id="260" r:id="rId6"/>
+    <p:sldId id="266" r:id="rId17"/>
+    <p:sldId id="267" r:id="rId18"/>
     <p:sldId id="261" r:id="rId7"/>
     <p:sldId id="262" r:id="rId8"/>
     <p:sldId id="263" r:id="rId9"/>
@@ -672,6 +674,182 @@
 </p:notes>
 </file>
 
+<file path=ppt/notesSlides/notesSlide11.xml><?xml version="1.0" encoding="utf-8"?>
+<p:notes xmlns:a="http://schemas.openxmlformats.org/drawingml/2006/main" xmlns:r="http://schemas.openxmlformats.org/officeDocument/2006/relationships" xmlns:p="http://schemas.openxmlformats.org/presentationml/2006/main">
+  <p:cSld>
+    <p:spTree>
+      <p:nvGrpSpPr>
+        <p:cNvPr id="1" name=""/>
+        <p:cNvGrpSpPr/>
+        <p:nvPr/>
+      </p:nvGrpSpPr>
+      <p:grpSpPr>
+        <a:xfrm>
+          <a:off x="0" y="0"/>
+          <a:ext cx="0" cy="0"/>
+          <a:chOff x="0" y="0"/>
+          <a:chExt cx="0" cy="0"/>
+        </a:xfrm>
+      </p:grpSpPr>
+      <p:sp>
+        <p:nvSpPr>
+          <p:cNvPr id="2" name="Slide Image Placeholder 1"/>
+          <p:cNvSpPr>
+            <a:spLocks noGrp="1" noRot="1" noChangeAspect="1"/>
+          </p:cNvSpPr>
+          <p:nvPr>
+            <p:ph type="sldImg"/>
+          </p:nvPr>
+        </p:nvSpPr>
+        <p:spPr/>
+      </p:sp>
+      <p:sp>
+        <p:nvSpPr>
+          <p:cNvPr id="3" name="Notes Placeholder 2"/>
+          <p:cNvSpPr>
+            <a:spLocks noGrp="1"/>
+          </p:cNvSpPr>
+          <p:nvPr>
+            <p:ph type="body" idx="1"/>
+          </p:nvPr>
+        </p:nvSpPr>
+        <p:spPr/>
+        <p:txBody>
+          <a:bodyPr/>
+          <a:lstStyle/>
+          <a:p>
+            <a:r>
+              <a:rPr lang="en-US" dirty="0"/>
+              <a:t>A three-way match only checks that the documents agree. Fraud often passes that: a fake vendor copying a real PO, or a real vendor's invoice asking to be paid into a new account. The Fraud Agent adds up risk points and shows the reason for each one.</a:t>
+            </a:r>
+            <a:endParaRPr lang="en-US" dirty="0"/>
+          </a:p>
+        </p:txBody>
+      </p:sp>
+      <p:sp>
+        <p:nvSpPr>
+          <p:cNvPr id="4" name="Slide Number Placeholder 3"/>
+          <p:cNvSpPr>
+            <a:spLocks noGrp="1"/>
+          </p:cNvSpPr>
+          <p:nvPr>
+            <p:ph type="sldNum" sz="quarter" idx="10"/>
+          </p:nvPr>
+        </p:nvSpPr>
+        <p:spPr/>
+        <p:txBody>
+          <a:bodyPr/>
+          <a:lstStyle/>
+          <a:p>
+            <a:fld id="{F7021451-1387-4CA6-816F-3879F97B5CBC}" type="slidenum">
+              <a:rPr lang="en-US"/>
+              <a:t>8</a:t>
+            </a:fld>
+            <a:endParaRPr lang="en-US"/>
+          </a:p>
+        </p:txBody>
+      </p:sp>
+    </p:spTree>
+    <p:extLst>
+      <p:ext uri="{BB962C8B-B14F-4D97-AF65-F5344CB8AC3E}">
+        <p14:creationId xmlns:p14="http://schemas.microsoft.com/office/powerpoint/2010/main" val="1024086991"/>
+      </p:ext>
+    </p:extLst>
+  </p:cSld>
+  <p:clrMapOvr>
+    <a:masterClrMapping/>
+  </p:clrMapOvr>
+</p:notes>
+</file>
+
+<file path=ppt/notesSlides/notesSlide12.xml><?xml version="1.0" encoding="utf-8"?>
+<p:notes xmlns:a="http://schemas.openxmlformats.org/drawingml/2006/main" xmlns:r="http://schemas.openxmlformats.org/officeDocument/2006/relationships" xmlns:p="http://schemas.openxmlformats.org/presentationml/2006/main">
+  <p:cSld>
+    <p:spTree>
+      <p:nvGrpSpPr>
+        <p:cNvPr id="1" name=""/>
+        <p:cNvGrpSpPr/>
+        <p:nvPr/>
+      </p:nvGrpSpPr>
+      <p:grpSpPr>
+        <a:xfrm>
+          <a:off x="0" y="0"/>
+          <a:ext cx="0" cy="0"/>
+          <a:chOff x="0" y="0"/>
+          <a:chExt cx="0" cy="0"/>
+        </a:xfrm>
+      </p:grpSpPr>
+      <p:sp>
+        <p:nvSpPr>
+          <p:cNvPr id="2" name="Slide Image Placeholder 1"/>
+          <p:cNvSpPr>
+            <a:spLocks noGrp="1" noRot="1" noChangeAspect="1"/>
+          </p:cNvSpPr>
+          <p:nvPr>
+            <p:ph type="sldImg"/>
+          </p:nvPr>
+        </p:nvSpPr>
+        <p:spPr/>
+      </p:sp>
+      <p:sp>
+        <p:nvSpPr>
+          <p:cNvPr id="3" name="Notes Placeholder 2"/>
+          <p:cNvSpPr>
+            <a:spLocks noGrp="1"/>
+          </p:cNvSpPr>
+          <p:nvPr>
+            <p:ph type="body" idx="1"/>
+          </p:nvPr>
+        </p:nvSpPr>
+        <p:spPr/>
+        <p:txBody>
+          <a:bodyPr/>
+          <a:lstStyle/>
+          <a:p>
+            <a:r>
+              <a:rPr lang="en-US" dirty="0"/>
+              <a:t>This is LangGraph's interrupt with a checkpointer: the graph really stops and resumes later from saved state. Show the bank-change example: once a reviewer approves it, the memory updates and the same vendor is not flagged again. That is the system learning from people.</a:t>
+            </a:r>
+            <a:endParaRPr lang="en-US" dirty="0"/>
+          </a:p>
+        </p:txBody>
+      </p:sp>
+      <p:sp>
+        <p:nvSpPr>
+          <p:cNvPr id="4" name="Slide Number Placeholder 3"/>
+          <p:cNvSpPr>
+            <a:spLocks noGrp="1"/>
+          </p:cNvSpPr>
+          <p:nvPr>
+            <p:ph type="sldNum" sz="quarter" idx="10"/>
+          </p:nvPr>
+        </p:nvSpPr>
+        <p:spPr/>
+        <p:txBody>
+          <a:bodyPr/>
+          <a:lstStyle/>
+          <a:p>
+            <a:fld id="{F7021451-1387-4CA6-816F-3879F97B5CBC}" type="slidenum">
+              <a:rPr lang="en-US"/>
+              <a:t>8</a:t>
+            </a:fld>
+            <a:endParaRPr lang="en-US"/>
+          </a:p>
+        </p:txBody>
+      </p:sp>
+    </p:spTree>
+    <p:extLst>
+      <p:ext uri="{BB962C8B-B14F-4D97-AF65-F5344CB8AC3E}">
+        <p14:creationId xmlns:p14="http://schemas.microsoft.com/office/powerpoint/2010/main" val="1024086991"/>
+      </p:ext>
+    </p:extLst>
+  </p:cSld>
+  <p:clrMapOvr>
+    <a:masterClrMapping/>
+  </p:clrMapOvr>
+</p:notes>
+</file>
+
 <file path=ppt/notesSlides/notesSlide2.xml><?xml version="1.0" encoding="utf-8"?>
 <p:notes xmlns:a="http://schemas.openxmlformats.org/drawingml/2006/main" xmlns:r="http://schemas.openxmlformats.org/officeDocument/2006/relationships" xmlns:p="http://schemas.openxmlformats.org/presentationml/2006/main">
   <p:cSld>
@@ -894,7 +1072,7 @@
           <a:p>
             <a:r>
               <a:rPr lang="en-US" dirty="0"/>
-              <a:t>Walk down the list. Each agent has one responsibility; the Critic appears twice in the workflow.</a:t>
+              <a:t>Walk down the list. Each agent has one job; the Critic appears twice. The two new ones are the Fraud Agent and the Human Review step.</a:t>
             </a:r>
             <a:endParaRPr lang="en-US" dirty="0"/>
           </a:p>
@@ -982,7 +1160,7 @@
           <a:p>
             <a:r>
               <a:rPr lang="en-US" dirty="0"/>
-              <a:t>The retry loop is the key agentic behaviour: the Critic rejects bad extractions and the Extraction Agent tries again. If it still fails, the invoice is escalated.</a:t>
+              <a:t>The retry loop is still the key agentic behaviour: the Critic rejects bad extractions and the Extraction Agent tries again. New: the Fraud Agent sits after matching, and escalations now pause for a human instead of just ending.</a:t>
             </a:r>
             <a:endParaRPr lang="en-US" dirty="0"/>
           </a:p>
@@ -1070,7 +1248,7 @@
           <a:p>
             <a:r>
               <a:rPr lang="en-US" dirty="0"/>
-              <a:t>Top to bottom: UI, orchestration, agents, then the tools and data and the LLM they call. Decision-making is rule-based in tools.decide, with the LLM only writing the explanation.</a:t>
+              <a:t>Top to bottom: UI, orchestration, agents, then tools, data and memory. Decisions are rule-based in tools.decide; the LLM only extracts and explains. Escalations pause in the graph until a reviewer answers.</a:t>
             </a:r>
             <a:endParaRPr lang="en-US" dirty="0"/>
           </a:p>
@@ -1158,7 +1336,7 @@
           <a:p>
             <a:r>
               <a:rPr lang="en-US" dirty="0"/>
-              <a:t>Run the live app here. Point out the Critic rejecting the first extraction and the retry fixing it. Add app screenshots to this slide if you like.</a:t>
+              <a:t>Run the live app. Show the Critic retry, then open the Review queue and approve or reject an invoice. Finish by downloading a sample PDF and uploading it: the agents catch it as a duplicate.</a:t>
             </a:r>
             <a:endParaRPr lang="en-US" dirty="0"/>
           </a:p>
@@ -1246,7 +1424,7 @@
           <a:p>
             <a:r>
               <a:rPr lang="en-US" dirty="0"/>
-              <a:t>Be upfront: the answer key is known because the data is synthetic, and the matching rules are deterministic, so these numbers show the pipeline works rather than how it would score on messy real invoices.</a:t>
+              <a:t>Be upfront: the answer key is known because the data is synthetic, and the rules are deterministic, so these numbers show the pipeline works, not how it would score on messy real invoices. The 37,200-invoice run shows the fraud rules rarely misfire.</a:t>
             </a:r>
             <a:endParaRPr lang="en-US" dirty="0"/>
           </a:p>
@@ -1334,7 +1512,7 @@
           <a:p>
             <a:r>
               <a:rPr lang="en-US" dirty="0"/>
-              <a:t>Be honest about limitations; it shows judgement. Future scope: the biggest step is real invoices via OCR plus an LLM extractor.</a:t>
+              <a:t>Be honest about limitations; it shows judgement. The biggest next step is real invoices via OCR plus an LLM extractor, then learning the fraud weights from reviewer decisions.</a:t>
             </a:r>
             <a:endParaRPr lang="en-US" dirty="0"/>
           </a:p>
@@ -2845,6 +3023,1476 @@
 </p:sld>
 </file>
 
+<file path=ppt/slides/slide11.xml><?xml version="1.0" encoding="utf-8"?>
+<p:sld xmlns:a="http://schemas.openxmlformats.org/drawingml/2006/main" xmlns:r="http://schemas.openxmlformats.org/officeDocument/2006/relationships" xmlns:p="http://schemas.openxmlformats.org/presentationml/2006/main">
+  <p:cSld name="Slide 8">
+    <p:spTree>
+      <p:nvGrpSpPr>
+        <p:cNvPr id="2" name=""/>
+        <p:cNvGrpSpPr/>
+        <p:nvPr/>
+      </p:nvGrpSpPr>
+      <p:grpSpPr>
+        <a:xfrm>
+          <a:off x="0" y="0"/>
+          <a:ext cx="0" cy="0"/>
+          <a:chOff x="0" y="0"/>
+          <a:chExt cx="0" cy="0"/>
+        </a:xfrm>
+      </p:grpSpPr>
+      <p:sp>
+        <p:nvSpPr>
+          <p:cNvPr id="3" name="Text 0"/>
+          <p:cNvSpPr/>
+          <p:nvPr>
+            <p:ph idx="100" type="title" hasCustomPrompt="1"/>
+          </p:nvPr>
+        </p:nvSpPr>
+        <p:spPr>
+          <a:xfrm>
+            <a:off x="457200" y="274320"/>
+            <a:ext cx="8229600" cy="731520"/>
+          </a:xfrm>
+          <a:prstGeom prst="rect">
+            <a:avLst/>
+          </a:prstGeom>
+          <a:noFill/>
+          <a:ln/>
+        </p:spPr>
+        <p:txBody>
+          <a:bodyPr wrap="square" lIns="0" tIns="0" rIns="0" bIns="0" rtlCol="0" anchor="ctr"/>
+          <a:lstStyle/>
+          <a:p>
+            <a:pPr algn="l" indent="0" marL="0">
+              <a:buNone/>
+            </a:pPr>
+            <a:r>
+              <a:rPr lang="en-US" sz="3400" b="1" dirty="0">
+                <a:solidFill>
+                  <a:schemeClr val="tx2"/>
+                </a:solidFill>
+              </a:rPr>
+              <a:t>Fraud Agent: what matching misses</a:t>
+            </a:r>
+            <a:endParaRPr lang="en-US" sz="3400" dirty="0"/>
+          </a:p>
+        </p:txBody>
+      </p:sp>
+      <p:sp>
+        <p:nvSpPr>
+          <p:cNvPr id="4" name="stat card"/>
+          <p:cNvSpPr/>
+          <p:nvPr/>
+        </p:nvSpPr>
+        <p:spPr>
+          <a:xfrm>
+            <a:off x="457200" y="1188720"/>
+            <a:ext cx="1920240" cy="1874520"/>
+          </a:xfrm>
+          <a:prstGeom prst="roundRect">
+            <a:avLst>
+              <a:gd name="adj" fmla="val 3902"/>
+            </a:avLst>
+          </a:prstGeom>
+          <a:solidFill>
+            <a:schemeClr val="bg2"/>
+          </a:solidFill>
+          <a:ln/>
+        </p:spPr>
+      </p:sp>
+      <p:sp>
+        <p:nvSpPr>
+          <p:cNvPr id="5" name="Text 2"/>
+          <p:cNvSpPr txBox="1"/>
+          <p:nvPr/>
+        </p:nvSpPr>
+        <p:spPr>
+          <a:xfrm>
+            <a:off x="548640" y="1280160"/>
+            <a:ext cx="1737360" cy="731520"/>
+          </a:xfrm>
+          <a:prstGeom prst="rect">
+            <a:avLst/>
+          </a:prstGeom>
+          <a:noFill/>
+          <a:ln/>
+        </p:spPr>
+        <p:txBody>
+          <a:bodyPr wrap="square" lIns="0" tIns="0" rIns="0" bIns="0" rtlCol="0" anchor="ctr"/>
+          <a:lstStyle/>
+          <a:p>
+            <a:pPr algn="ctr" indent="0" marL="0">
+              <a:buNone/>
+            </a:pPr>
+            <a:r>
+              <a:rPr lang="en-US" sz="4000" b="1" dirty="0">
+                <a:solidFill>
+                  <a:schemeClr val="accent1"/>
+                </a:solidFill>
+              </a:rPr>
+              <a:t>+70</a:t>
+            </a:r>
+            <a:endParaRPr lang="en-US" sz="4000" dirty="0"/>
+          </a:p>
+        </p:txBody>
+      </p:sp>
+      <p:sp>
+        <p:nvSpPr>
+          <p:cNvPr id="6" name="Text 3"/>
+          <p:cNvSpPr txBox="1"/>
+          <p:nvPr/>
+        </p:nvSpPr>
+        <p:spPr>
+          <a:xfrm>
+            <a:off x="594360" y="2103120"/>
+            <a:ext cx="1645920" cy="868680"/>
+          </a:xfrm>
+          <a:prstGeom prst="rect">
+            <a:avLst/>
+          </a:prstGeom>
+          <a:noFill/>
+          <a:ln/>
+        </p:spPr>
+        <p:txBody>
+          <a:bodyPr wrap="square" lIns="0" tIns="0" rIns="0" bIns="0" rtlCol="0" anchor="t"/>
+          <a:lstStyle/>
+          <a:p>
+            <a:pPr algn="ctr" indent="0" marL="0">
+              <a:buNone/>
+            </a:pPr>
+            <a:r>
+              <a:rPr lang="en-US" sz="1400" dirty="0">
+                <a:solidFill>
+                  <a:schemeClr val="tx1"/>
+                </a:solidFill>
+              </a:rPr>
+              <a:t>pay-to bank account differs from the one on file</a:t>
+            </a:r>
+            <a:endParaRPr lang="en-US" sz="1400" dirty="0"/>
+          </a:p>
+        </p:txBody>
+      </p:sp>
+      <p:sp>
+        <p:nvSpPr>
+          <p:cNvPr id="7" name="stat card"/>
+          <p:cNvSpPr/>
+          <p:nvPr/>
+        </p:nvSpPr>
+        <p:spPr>
+          <a:xfrm>
+            <a:off x="2560320" y="1188720"/>
+            <a:ext cx="1920240" cy="1874520"/>
+          </a:xfrm>
+          <a:prstGeom prst="roundRect">
+            <a:avLst>
+              <a:gd name="adj" fmla="val 3902"/>
+            </a:avLst>
+          </a:prstGeom>
+          <a:solidFill>
+            <a:schemeClr val="bg2"/>
+          </a:solidFill>
+          <a:ln/>
+        </p:spPr>
+      </p:sp>
+      <p:sp>
+        <p:nvSpPr>
+          <p:cNvPr id="8" name="Text 5"/>
+          <p:cNvSpPr txBox="1"/>
+          <p:nvPr/>
+        </p:nvSpPr>
+        <p:spPr>
+          <a:xfrm>
+            <a:off x="2651760" y="1280160"/>
+            <a:ext cx="1737360" cy="731520"/>
+          </a:xfrm>
+          <a:prstGeom prst="rect">
+            <a:avLst/>
+          </a:prstGeom>
+          <a:noFill/>
+          <a:ln/>
+        </p:spPr>
+        <p:txBody>
+          <a:bodyPr wrap="square" lIns="0" tIns="0" rIns="0" bIns="0" rtlCol="0" anchor="ctr"/>
+          <a:lstStyle/>
+          <a:p>
+            <a:pPr algn="ctr" indent="0" marL="0">
+              <a:buNone/>
+            </a:pPr>
+            <a:r>
+              <a:rPr lang="en-US" sz="4000" b="1" dirty="0">
+                <a:solidFill>
+                  <a:schemeClr val="accent1"/>
+                </a:solidFill>
+              </a:rPr>
+              <a:t>+60</a:t>
+            </a:r>
+            <a:endParaRPr lang="en-US" sz="4000" dirty="0"/>
+          </a:p>
+        </p:txBody>
+      </p:sp>
+      <p:sp>
+        <p:nvSpPr>
+          <p:cNvPr id="9" name="Text 6"/>
+          <p:cNvSpPr txBox="1"/>
+          <p:nvPr/>
+        </p:nvSpPr>
+        <p:spPr>
+          <a:xfrm>
+            <a:off x="2697480" y="2103120"/>
+            <a:ext cx="1645920" cy="868680"/>
+          </a:xfrm>
+          <a:prstGeom prst="rect">
+            <a:avLst/>
+          </a:prstGeom>
+          <a:noFill/>
+          <a:ln/>
+        </p:spPr>
+        <p:txBody>
+          <a:bodyPr wrap="square" lIns="0" tIns="0" rIns="0" bIns="0" rtlCol="0" anchor="t"/>
+          <a:lstStyle/>
+          <a:p>
+            <a:pPr algn="ctr" indent="0" marL="0">
+              <a:buNone/>
+            </a:pPr>
+            <a:r>
+              <a:rPr lang="en-US" sz="1400" dirty="0">
+                <a:solidFill>
+                  <a:schemeClr val="tx1"/>
+                </a:solidFill>
+              </a:rPr>
+              <a:t>vendor name one letter off an approved vendor</a:t>
+            </a:r>
+            <a:endParaRPr lang="en-US" sz="1400" dirty="0"/>
+          </a:p>
+        </p:txBody>
+      </p:sp>
+      <p:sp>
+        <p:nvSpPr>
+          <p:cNvPr id="10" name="stat card"/>
+          <p:cNvSpPr/>
+          <p:nvPr/>
+        </p:nvSpPr>
+        <p:spPr>
+          <a:xfrm>
+            <a:off x="4663440" y="1188720"/>
+            <a:ext cx="1920240" cy="1874520"/>
+          </a:xfrm>
+          <a:prstGeom prst="roundRect">
+            <a:avLst>
+              <a:gd name="adj" fmla="val 3902"/>
+            </a:avLst>
+          </a:prstGeom>
+          <a:solidFill>
+            <a:schemeClr val="bg2"/>
+          </a:solidFill>
+          <a:ln/>
+        </p:spPr>
+      </p:sp>
+      <p:sp>
+        <p:nvSpPr>
+          <p:cNvPr id="11" name="Text 8"/>
+          <p:cNvSpPr txBox="1"/>
+          <p:nvPr/>
+        </p:nvSpPr>
+        <p:spPr>
+          <a:xfrm>
+            <a:off x="4754880" y="1280160"/>
+            <a:ext cx="1737360" cy="731520"/>
+          </a:xfrm>
+          <a:prstGeom prst="rect">
+            <a:avLst/>
+          </a:prstGeom>
+          <a:noFill/>
+          <a:ln/>
+        </p:spPr>
+        <p:txBody>
+          <a:bodyPr wrap="square" lIns="0" tIns="0" rIns="0" bIns="0" rtlCol="0" anchor="ctr"/>
+          <a:lstStyle/>
+          <a:p>
+            <a:pPr algn="ctr" indent="0" marL="0">
+              <a:buNone/>
+            </a:pPr>
+            <a:r>
+              <a:rPr lang="en-US" sz="4000" b="1" dirty="0">
+                <a:solidFill>
+                  <a:schemeClr val="accent1"/>
+                </a:solidFill>
+              </a:rPr>
+              <a:t>+40</a:t>
+            </a:r>
+            <a:endParaRPr lang="en-US" sz="4000" dirty="0"/>
+          </a:p>
+        </p:txBody>
+      </p:sp>
+      <p:sp>
+        <p:nvSpPr>
+          <p:cNvPr id="12" name="Text 9"/>
+          <p:cNvSpPr txBox="1"/>
+          <p:nvPr/>
+        </p:nvSpPr>
+        <p:spPr>
+          <a:xfrm>
+            <a:off x="4800600" y="2103120"/>
+            <a:ext cx="1645920" cy="868680"/>
+          </a:xfrm>
+          <a:prstGeom prst="rect">
+            <a:avLst/>
+          </a:prstGeom>
+          <a:noFill/>
+          <a:ln/>
+        </p:spPr>
+        <p:txBody>
+          <a:bodyPr wrap="square" lIns="0" tIns="0" rIns="0" bIns="0" rtlCol="0" anchor="t"/>
+          <a:lstStyle/>
+          <a:p>
+            <a:pPr algn="ctr" indent="0" marL="0">
+              <a:buNone/>
+            </a:pPr>
+            <a:r>
+              <a:rPr lang="en-US" sz="1400" dirty="0">
+                <a:solidFill>
+                  <a:schemeClr val="tx1"/>
+                </a:solidFill>
+              </a:rPr>
+              <a:t>total above 3x the vendor's largest past invoice</a:t>
+            </a:r>
+            <a:endParaRPr lang="en-US" sz="1400" dirty="0"/>
+          </a:p>
+        </p:txBody>
+      </p:sp>
+      <p:sp>
+        <p:nvSpPr>
+          <p:cNvPr id="13" name="stat card"/>
+          <p:cNvSpPr/>
+          <p:nvPr/>
+        </p:nvSpPr>
+        <p:spPr>
+          <a:xfrm>
+            <a:off x="6766560" y="1188720"/>
+            <a:ext cx="1920240" cy="1874520"/>
+          </a:xfrm>
+          <a:prstGeom prst="roundRect">
+            <a:avLst>
+              <a:gd name="adj" fmla="val 3902"/>
+            </a:avLst>
+          </a:prstGeom>
+          <a:solidFill>
+            <a:schemeClr val="bg2"/>
+          </a:solidFill>
+          <a:ln/>
+        </p:spPr>
+      </p:sp>
+      <p:sp>
+        <p:nvSpPr>
+          <p:cNvPr id="14" name="Text 11"/>
+          <p:cNvSpPr txBox="1"/>
+          <p:nvPr/>
+        </p:nvSpPr>
+        <p:spPr>
+          <a:xfrm>
+            <a:off x="6858000" y="1280160"/>
+            <a:ext cx="1737360" cy="731520"/>
+          </a:xfrm>
+          <a:prstGeom prst="rect">
+            <a:avLst/>
+          </a:prstGeom>
+          <a:noFill/>
+          <a:ln/>
+        </p:spPr>
+        <p:txBody>
+          <a:bodyPr wrap="square" lIns="0" tIns="0" rIns="0" bIns="0" rtlCol="0" anchor="ctr"/>
+          <a:lstStyle/>
+          <a:p>
+            <a:pPr algn="ctr" indent="0" marL="0">
+              <a:buNone/>
+            </a:pPr>
+            <a:r>
+              <a:rPr lang="en-US" sz="4000" b="1" dirty="0">
+                <a:solidFill>
+                  <a:schemeClr val="accent1"/>
+                </a:solidFill>
+              </a:rPr>
+              <a:t>+15</a:t>
+            </a:r>
+            <a:endParaRPr lang="en-US" sz="4000" dirty="0"/>
+          </a:p>
+        </p:txBody>
+      </p:sp>
+      <p:sp>
+        <p:nvSpPr>
+          <p:cNvPr id="15" name="Text 12"/>
+          <p:cNvSpPr txBox="1"/>
+          <p:nvPr/>
+        </p:nvSpPr>
+        <p:spPr>
+          <a:xfrm>
+            <a:off x="6903720" y="2103120"/>
+            <a:ext cx="1645920" cy="868680"/>
+          </a:xfrm>
+          <a:prstGeom prst="rect">
+            <a:avLst/>
+          </a:prstGeom>
+          <a:noFill/>
+          <a:ln/>
+        </p:spPr>
+        <p:txBody>
+          <a:bodyPr wrap="square" lIns="0" tIns="0" rIns="0" bIns="0" rtlCol="0" anchor="t"/>
+          <a:lstStyle/>
+          <a:p>
+            <a:pPr algn="ctr" indent="0" marL="0">
+              <a:buNone/>
+            </a:pPr>
+            <a:r>
+              <a:rPr lang="en-US" sz="1400" dirty="0">
+                <a:solidFill>
+                  <a:schemeClr val="tx1"/>
+                </a:solidFill>
+              </a:rPr>
+              <a:t>suspiciously round total</a:t>
+            </a:r>
+            <a:endParaRPr lang="en-US" sz="1400" dirty="0"/>
+          </a:p>
+        </p:txBody>
+      </p:sp>
+      <p:sp>
+        <p:nvSpPr>
+          <p:cNvPr id="16" name="notes panel"/>
+          <p:cNvSpPr/>
+          <p:nvPr/>
+        </p:nvSpPr>
+        <p:spPr>
+          <a:xfrm>
+            <a:off x="457200" y="3291840"/>
+            <a:ext cx="8229600" cy="1417320"/>
+          </a:xfrm>
+          <a:prstGeom prst="roundRect">
+            <a:avLst>
+              <a:gd name="adj" fmla="val 5161"/>
+            </a:avLst>
+          </a:prstGeom>
+          <a:solidFill>
+            <a:schemeClr val="bg2"/>
+          </a:solidFill>
+          <a:ln/>
+        </p:spPr>
+      </p:sp>
+      <p:sp>
+        <p:nvSpPr>
+          <p:cNvPr id="17" name="Text 14"/>
+          <p:cNvSpPr txBox="1"/>
+          <p:nvPr/>
+        </p:nvSpPr>
+        <p:spPr>
+          <a:xfrm>
+            <a:off x="685800" y="3383280"/>
+            <a:ext cx="7772400" cy="1234440"/>
+          </a:xfrm>
+          <a:prstGeom prst="rect">
+            <a:avLst/>
+          </a:prstGeom>
+          <a:noFill/>
+          <a:ln/>
+        </p:spPr>
+        <p:txBody>
+          <a:bodyPr wrap="square" lIns="0" tIns="0" rIns="0" bIns="0" rtlCol="0" anchor="ctr"/>
+          <a:lstStyle/>
+          <a:p>
+            <a:pPr marL="342900" indent="-342900">
+              <a:spcAft>
+                <a:spcPts val="600"/>
+              </a:spcAft>
+              <a:buSzPct val="100000"/>
+              <a:buChar char="•"/>
+            </a:pPr>
+            <a:r>
+              <a:rPr lang="en-US" sz="1400" dirty="0">
+                <a:solidFill>
+                  <a:schemeClr val="tx1"/>
+                </a:solidFill>
+              </a:rPr>
+              <a:t>Risk score 0-100: these points, plus up to 20 for a vendor whose invoices were often escalated. 40 or more escalates.</a:t>
+            </a:r>
+            <a:endParaRPr lang="en-US" sz="1400" dirty="0"/>
+          </a:p>
+          <a:p>
+            <a:pPr marL="342900" indent="-342900">
+              <a:spcAft>
+                <a:spcPts val="600"/>
+              </a:spcAft>
+              <a:buSzPct val="100000"/>
+              <a:buChar char="•"/>
+            </a:pPr>
+            <a:r>
+              <a:rPr lang="en-US" sz="1400" dirty="0">
+                <a:solidFill>
+                  <a:schemeClr val="tx1"/>
+                </a:solidFill>
+              </a:rPr>
+              <a:t>Every point comes with its reason, so the reviewer sees exactly why an invoice was stopped.</a:t>
+            </a:r>
+            <a:endParaRPr lang="en-US" sz="1400" dirty="0"/>
+          </a:p>
+          <a:p>
+            <a:pPr marL="342900" indent="-342900">
+              <a:spcAft>
+                <a:spcPts val="600"/>
+              </a:spcAft>
+              <a:buSzPct val="100000"/>
+              <a:buChar char="•"/>
+            </a:pPr>
+            <a:r>
+              <a:rPr lang="en-US" sz="1400" dirty="0">
+                <a:solidFill>
+                  <a:schemeClr val="tx1"/>
+                </a:solidFill>
+              </a:rPr>
+              <a:t>The spike rule was tuned on 200,000 simulated invoices: about 0.02% false alarms.</a:t>
+            </a:r>
+            <a:endParaRPr lang="en-US" sz="1400" dirty="0"/>
+          </a:p>
+        </p:txBody>
+      </p:sp>
+      <p:sp>
+        <p:nvSpPr>
+          <p:cNvPr id="18" name="Slide Number Placeholder 0"/>
+          <p:cNvSpPr>
+            <a:spLocks noGrp="1"/>
+          </p:cNvSpPr>
+          <p:nvPr>
+            <p:ph type="sldNum" sz="quarter" idx="4294967295"/>
+          </p:nvPr>
+        </p:nvSpPr>
+        <p:spPr>
+          <a:xfrm>
+            <a:off x="8321040" y="4754880"/>
+            <a:ext cx="457200" cy="274320"/>
+          </a:xfrm>
+          <a:prstGeom prst="rect">
+            <a:avLst/>
+          </a:prstGeom>
+          <a:extLst>
+            <a:ext uri="{C572A759-6A51-4108-AA02-DFA0A04FC94B}">
+              <ma14:wrappingTextBoxFlag xmlns:ma14="http://schemas.microsoft.com/office/mac/drawingml/2011/main" val="0"/>
+            </a:ext>
+          </a:extLst>
+        </p:spPr>
+        <p:txBody>
+          <a:bodyPr/>
+          <a:lstStyle>
+            <a:lvl1pPr>
+              <a:defRPr sz="1000">
+                <a:solidFill>
+                  <a:schemeClr val="accent5"/>
+                </a:solidFill>
+              </a:defRPr>
+            </a:lvl1pPr>
+          </a:lstStyle>
+          <a:p>
+            <a:pPr algn="l"/>
+            <a:fld id="{F7021451-1387-4CA6-816F-3879F97B5CBC}" type="slidenum">
+              <a:rPr b="0" lang="en-US"/>
+              <a:t>8</a:t>
+            </a:fld>
+            <a:endParaRPr lang="en-US"/>
+          </a:p>
+        </p:txBody>
+      </p:sp>
+    </p:spTree>
+  </p:cSld>
+  <p:clrMapOvr>
+    <a:masterClrMapping/>
+  </p:clrMapOvr>
+</p:sld>
+</file>
+
+<file path=ppt/slides/slide12.xml><?xml version="1.0" encoding="utf-8"?>
+<p:sld xmlns:a="http://schemas.openxmlformats.org/drawingml/2006/main" xmlns:r="http://schemas.openxmlformats.org/officeDocument/2006/relationships" xmlns:p="http://schemas.openxmlformats.org/presentationml/2006/main">
+  <p:cSld name="Slide 7">
+    <p:spTree>
+      <p:nvGrpSpPr>
+        <p:cNvPr id="2" name=""/>
+        <p:cNvGrpSpPr/>
+        <p:nvPr/>
+      </p:nvGrpSpPr>
+      <p:grpSpPr>
+        <a:xfrm>
+          <a:off x="0" y="0"/>
+          <a:ext cx="0" cy="0"/>
+          <a:chOff x="0" y="0"/>
+          <a:chExt cx="0" cy="0"/>
+        </a:xfrm>
+      </p:grpSpPr>
+      <p:sp>
+        <p:nvSpPr>
+          <p:cNvPr id="3" name="Text 0"/>
+          <p:cNvSpPr/>
+          <p:nvPr>
+            <p:ph idx="100" type="title" hasCustomPrompt="1"/>
+          </p:nvPr>
+        </p:nvSpPr>
+        <p:spPr>
+          <a:xfrm>
+            <a:off x="457200" y="274320"/>
+            <a:ext cx="8229600" cy="731520"/>
+          </a:xfrm>
+          <a:prstGeom prst="rect">
+            <a:avLst/>
+          </a:prstGeom>
+          <a:noFill/>
+          <a:ln/>
+        </p:spPr>
+        <p:txBody>
+          <a:bodyPr wrap="square" lIns="0" tIns="0" rIns="0" bIns="0" rtlCol="0" anchor="ctr"/>
+          <a:lstStyle/>
+          <a:p>
+            <a:pPr algn="l" indent="0" marL="0">
+              <a:buNone/>
+            </a:pPr>
+            <a:r>
+              <a:rPr lang="en-US" sz="3400" b="1" dirty="0">
+                <a:solidFill>
+                  <a:schemeClr val="tx2"/>
+                </a:solidFill>
+              </a:rPr>
+              <a:t>Human in the loop, with memory</a:t>
+            </a:r>
+            <a:endParaRPr lang="en-US" sz="3400" dirty="0"/>
+          </a:p>
+        </p:txBody>
+      </p:sp>
+      <p:sp>
+        <p:nvSpPr>
+          <p:cNvPr id="4" name="step card"/>
+          <p:cNvSpPr/>
+          <p:nvPr/>
+        </p:nvSpPr>
+        <p:spPr>
+          <a:xfrm>
+            <a:off x="457200" y="1188720"/>
+            <a:ext cx="1920240" cy="1371600"/>
+          </a:xfrm>
+          <a:prstGeom prst="roundRect">
+            <a:avLst>
+              <a:gd name="adj" fmla="val 5333"/>
+            </a:avLst>
+          </a:prstGeom>
+          <a:solidFill>
+            <a:schemeClr val="bg2"/>
+          </a:solidFill>
+          <a:ln/>
+        </p:spPr>
+      </p:sp>
+      <p:sp>
+        <p:nvSpPr>
+          <p:cNvPr id="5" name="badge"/>
+          <p:cNvSpPr/>
+          <p:nvPr/>
+        </p:nvSpPr>
+        <p:spPr>
+          <a:xfrm>
+            <a:off x="594360" y="1325880"/>
+            <a:ext cx="347472" cy="347472"/>
+          </a:xfrm>
+          <a:prstGeom prst="ellipse">
+            <a:avLst/>
+          </a:prstGeom>
+          <a:solidFill>
+            <a:schemeClr val="accent1"/>
+          </a:solidFill>
+          <a:ln/>
+        </p:spPr>
+      </p:sp>
+      <p:sp>
+        <p:nvSpPr>
+          <p:cNvPr id="6" name="Text 3"/>
+          <p:cNvSpPr txBox="1"/>
+          <p:nvPr/>
+        </p:nvSpPr>
+        <p:spPr>
+          <a:xfrm>
+            <a:off x="594360" y="1325880"/>
+            <a:ext cx="347472" cy="347472"/>
+          </a:xfrm>
+          <a:prstGeom prst="rect">
+            <a:avLst/>
+          </a:prstGeom>
+          <a:noFill/>
+          <a:ln/>
+        </p:spPr>
+        <p:txBody>
+          <a:bodyPr wrap="square" lIns="0" tIns="0" rIns="0" bIns="0" rtlCol="0" anchor="ctr"/>
+          <a:lstStyle/>
+          <a:p>
+            <a:pPr algn="ctr" indent="0" marL="0">
+              <a:buNone/>
+            </a:pPr>
+            <a:r>
+              <a:rPr lang="en-US" sz="1400" b="1" dirty="0">
+                <a:solidFill>
+                  <a:schemeClr val="bg1"/>
+                </a:solidFill>
+              </a:rPr>
+              <a:t>1</a:t>
+            </a:r>
+            <a:endParaRPr lang="en-US" sz="1400" dirty="0"/>
+          </a:p>
+        </p:txBody>
+      </p:sp>
+      <p:sp>
+        <p:nvSpPr>
+          <p:cNvPr id="7" name="Text 4"/>
+          <p:cNvSpPr txBox="1"/>
+          <p:nvPr/>
+        </p:nvSpPr>
+        <p:spPr>
+          <a:xfrm>
+            <a:off x="1051560" y="1307592"/>
+            <a:ext cx="1234440" cy="384048"/>
+          </a:xfrm>
+          <a:prstGeom prst="rect">
+            <a:avLst/>
+          </a:prstGeom>
+          <a:noFill/>
+          <a:ln/>
+        </p:spPr>
+        <p:txBody>
+          <a:bodyPr wrap="square" lIns="0" tIns="0" rIns="0" bIns="0" rtlCol="0" anchor="ctr"/>
+          <a:lstStyle/>
+          <a:p>
+            <a:pPr indent="0" marL="0">
+              <a:buNone/>
+            </a:pPr>
+            <a:r>
+              <a:rPr lang="en-US" sz="1400" b="1" dirty="0">
+                <a:solidFill>
+                  <a:schemeClr val="tx2"/>
+                </a:solidFill>
+              </a:rPr>
+              <a:t>Pause</a:t>
+            </a:r>
+            <a:endParaRPr lang="en-US" sz="1400" dirty="0"/>
+          </a:p>
+        </p:txBody>
+      </p:sp>
+      <p:sp>
+        <p:nvSpPr>
+          <p:cNvPr id="8" name="Text 5"/>
+          <p:cNvSpPr txBox="1"/>
+          <p:nvPr/>
+        </p:nvSpPr>
+        <p:spPr>
+          <a:xfrm>
+            <a:off x="594360" y="1828800"/>
+            <a:ext cx="1645920" cy="685800"/>
+          </a:xfrm>
+          <a:prstGeom prst="rect">
+            <a:avLst/>
+          </a:prstGeom>
+          <a:noFill/>
+          <a:ln/>
+        </p:spPr>
+        <p:txBody>
+          <a:bodyPr wrap="square" lIns="0" tIns="0" rIns="0" bIns="0" rtlCol="0" anchor="t"/>
+          <a:lstStyle/>
+          <a:p>
+            <a:pPr indent="0" marL="0">
+              <a:buNone/>
+            </a:pPr>
+            <a:r>
+              <a:rPr lang="en-US" sz="1200" dirty="0">
+                <a:solidFill>
+                  <a:schemeClr val="tx1"/>
+                </a:solidFill>
+              </a:rPr>
+              <a:t>LangGraph interrupt checkpoints the graph on escalation</a:t>
+            </a:r>
+            <a:endParaRPr lang="en-US" sz="1200" dirty="0"/>
+          </a:p>
+        </p:txBody>
+      </p:sp>
+      <p:sp>
+        <p:nvSpPr>
+          <p:cNvPr id="9" name="step card"/>
+          <p:cNvSpPr/>
+          <p:nvPr/>
+        </p:nvSpPr>
+        <p:spPr>
+          <a:xfrm>
+            <a:off x="2560320" y="1188720"/>
+            <a:ext cx="1920240" cy="1371600"/>
+          </a:xfrm>
+          <a:prstGeom prst="roundRect">
+            <a:avLst>
+              <a:gd name="adj" fmla="val 5333"/>
+            </a:avLst>
+          </a:prstGeom>
+          <a:solidFill>
+            <a:schemeClr val="bg2"/>
+          </a:solidFill>
+          <a:ln/>
+        </p:spPr>
+      </p:sp>
+      <p:sp>
+        <p:nvSpPr>
+          <p:cNvPr id="10" name="badge"/>
+          <p:cNvSpPr/>
+          <p:nvPr/>
+        </p:nvSpPr>
+        <p:spPr>
+          <a:xfrm>
+            <a:off x="2697480" y="1325880"/>
+            <a:ext cx="347472" cy="347472"/>
+          </a:xfrm>
+          <a:prstGeom prst="ellipse">
+            <a:avLst/>
+          </a:prstGeom>
+          <a:solidFill>
+            <a:schemeClr val="accent1"/>
+          </a:solidFill>
+          <a:ln/>
+        </p:spPr>
+      </p:sp>
+      <p:sp>
+        <p:nvSpPr>
+          <p:cNvPr id="11" name="Text 8"/>
+          <p:cNvSpPr txBox="1"/>
+          <p:nvPr/>
+        </p:nvSpPr>
+        <p:spPr>
+          <a:xfrm>
+            <a:off x="2697480" y="1325880"/>
+            <a:ext cx="347472" cy="347472"/>
+          </a:xfrm>
+          <a:prstGeom prst="rect">
+            <a:avLst/>
+          </a:prstGeom>
+          <a:noFill/>
+          <a:ln/>
+        </p:spPr>
+        <p:txBody>
+          <a:bodyPr wrap="square" lIns="0" tIns="0" rIns="0" bIns="0" rtlCol="0" anchor="ctr"/>
+          <a:lstStyle/>
+          <a:p>
+            <a:pPr algn="ctr" indent="0" marL="0">
+              <a:buNone/>
+            </a:pPr>
+            <a:r>
+              <a:rPr lang="en-US" sz="1400" b="1" dirty="0">
+                <a:solidFill>
+                  <a:schemeClr val="bg1"/>
+                </a:solidFill>
+              </a:rPr>
+              <a:t>2</a:t>
+            </a:r>
+            <a:endParaRPr lang="en-US" sz="1400" dirty="0"/>
+          </a:p>
+        </p:txBody>
+      </p:sp>
+      <p:sp>
+        <p:nvSpPr>
+          <p:cNvPr id="12" name="Text 9"/>
+          <p:cNvSpPr txBox="1"/>
+          <p:nvPr/>
+        </p:nvSpPr>
+        <p:spPr>
+          <a:xfrm>
+            <a:off x="3154680" y="1307592"/>
+            <a:ext cx="1234440" cy="384048"/>
+          </a:xfrm>
+          <a:prstGeom prst="rect">
+            <a:avLst/>
+          </a:prstGeom>
+          <a:noFill/>
+          <a:ln/>
+        </p:spPr>
+        <p:txBody>
+          <a:bodyPr wrap="square" lIns="0" tIns="0" rIns="0" bIns="0" rtlCol="0" anchor="ctr"/>
+          <a:lstStyle/>
+          <a:p>
+            <a:pPr indent="0" marL="0">
+              <a:buNone/>
+            </a:pPr>
+            <a:r>
+              <a:rPr lang="en-US" sz="1400" b="1" dirty="0">
+                <a:solidFill>
+                  <a:schemeClr val="tx2"/>
+                </a:solidFill>
+              </a:rPr>
+              <a:t>Review</a:t>
+            </a:r>
+            <a:endParaRPr lang="en-US" sz="1400" dirty="0"/>
+          </a:p>
+        </p:txBody>
+      </p:sp>
+      <p:sp>
+        <p:nvSpPr>
+          <p:cNvPr id="13" name="Text 10"/>
+          <p:cNvSpPr txBox="1"/>
+          <p:nvPr/>
+        </p:nvSpPr>
+        <p:spPr>
+          <a:xfrm>
+            <a:off x="2697480" y="1828800"/>
+            <a:ext cx="1645920" cy="685800"/>
+          </a:xfrm>
+          <a:prstGeom prst="rect">
+            <a:avLst/>
+          </a:prstGeom>
+          <a:noFill/>
+          <a:ln/>
+        </p:spPr>
+        <p:txBody>
+          <a:bodyPr wrap="square" lIns="0" tIns="0" rIns="0" bIns="0" rtlCol="0" anchor="t"/>
+          <a:lstStyle/>
+          <a:p>
+            <a:pPr indent="0" marL="0">
+              <a:buNone/>
+            </a:pPr>
+            <a:r>
+              <a:rPr lang="en-US" sz="1200" dirty="0">
+                <a:solidFill>
+                  <a:schemeClr val="tx1"/>
+                </a:solidFill>
+              </a:rPr>
+              <a:t>Approve, hold or reject in the Review queue</a:t>
+            </a:r>
+            <a:endParaRPr lang="en-US" sz="1200" dirty="0"/>
+          </a:p>
+        </p:txBody>
+      </p:sp>
+      <p:sp>
+        <p:nvSpPr>
+          <p:cNvPr id="14" name="step card"/>
+          <p:cNvSpPr/>
+          <p:nvPr/>
+        </p:nvSpPr>
+        <p:spPr>
+          <a:xfrm>
+            <a:off x="4663440" y="1188720"/>
+            <a:ext cx="1920240" cy="1371600"/>
+          </a:xfrm>
+          <a:prstGeom prst="roundRect">
+            <a:avLst>
+              <a:gd name="adj" fmla="val 5333"/>
+            </a:avLst>
+          </a:prstGeom>
+          <a:solidFill>
+            <a:schemeClr val="bg2"/>
+          </a:solidFill>
+          <a:ln/>
+        </p:spPr>
+      </p:sp>
+      <p:sp>
+        <p:nvSpPr>
+          <p:cNvPr id="15" name="badge"/>
+          <p:cNvSpPr/>
+          <p:nvPr/>
+        </p:nvSpPr>
+        <p:spPr>
+          <a:xfrm>
+            <a:off x="4800600" y="1325880"/>
+            <a:ext cx="347472" cy="347472"/>
+          </a:xfrm>
+          <a:prstGeom prst="ellipse">
+            <a:avLst/>
+          </a:prstGeom>
+          <a:solidFill>
+            <a:schemeClr val="accent1"/>
+          </a:solidFill>
+          <a:ln/>
+        </p:spPr>
+      </p:sp>
+      <p:sp>
+        <p:nvSpPr>
+          <p:cNvPr id="16" name="Text 13"/>
+          <p:cNvSpPr txBox="1"/>
+          <p:nvPr/>
+        </p:nvSpPr>
+        <p:spPr>
+          <a:xfrm>
+            <a:off x="4800600" y="1325880"/>
+            <a:ext cx="347472" cy="347472"/>
+          </a:xfrm>
+          <a:prstGeom prst="rect">
+            <a:avLst/>
+          </a:prstGeom>
+          <a:noFill/>
+          <a:ln/>
+        </p:spPr>
+        <p:txBody>
+          <a:bodyPr wrap="square" lIns="0" tIns="0" rIns="0" bIns="0" rtlCol="0" anchor="ctr"/>
+          <a:lstStyle/>
+          <a:p>
+            <a:pPr algn="ctr" indent="0" marL="0">
+              <a:buNone/>
+            </a:pPr>
+            <a:r>
+              <a:rPr lang="en-US" sz="1400" b="1" dirty="0">
+                <a:solidFill>
+                  <a:schemeClr val="bg1"/>
+                </a:solidFill>
+              </a:rPr>
+              <a:t>3</a:t>
+            </a:r>
+            <a:endParaRPr lang="en-US" sz="1400" dirty="0"/>
+          </a:p>
+        </p:txBody>
+      </p:sp>
+      <p:sp>
+        <p:nvSpPr>
+          <p:cNvPr id="17" name="Text 14"/>
+          <p:cNvSpPr txBox="1"/>
+          <p:nvPr/>
+        </p:nvSpPr>
+        <p:spPr>
+          <a:xfrm>
+            <a:off x="5257800" y="1307592"/>
+            <a:ext cx="1234440" cy="384048"/>
+          </a:xfrm>
+          <a:prstGeom prst="rect">
+            <a:avLst/>
+          </a:prstGeom>
+          <a:noFill/>
+          <a:ln/>
+        </p:spPr>
+        <p:txBody>
+          <a:bodyPr wrap="square" lIns="0" tIns="0" rIns="0" bIns="0" rtlCol="0" anchor="ctr"/>
+          <a:lstStyle/>
+          <a:p>
+            <a:pPr indent="0" marL="0">
+              <a:buNone/>
+            </a:pPr>
+            <a:r>
+              <a:rPr lang="en-US" sz="1400" b="1" dirty="0">
+                <a:solidFill>
+                  <a:schemeClr val="tx2"/>
+                </a:solidFill>
+              </a:rPr>
+              <a:t>Resume</a:t>
+            </a:r>
+            <a:endParaRPr lang="en-US" sz="1400" dirty="0"/>
+          </a:p>
+        </p:txBody>
+      </p:sp>
+      <p:sp>
+        <p:nvSpPr>
+          <p:cNvPr id="18" name="Text 15"/>
+          <p:cNvSpPr txBox="1"/>
+          <p:nvPr/>
+        </p:nvSpPr>
+        <p:spPr>
+          <a:xfrm>
+            <a:off x="4800600" y="1828800"/>
+            <a:ext cx="1645920" cy="685800"/>
+          </a:xfrm>
+          <a:prstGeom prst="rect">
+            <a:avLst/>
+          </a:prstGeom>
+          <a:noFill/>
+          <a:ln/>
+        </p:spPr>
+        <p:txBody>
+          <a:bodyPr wrap="square" lIns="0" tIns="0" rIns="0" bIns="0" rtlCol="0" anchor="t"/>
+          <a:lstStyle/>
+          <a:p>
+            <a:pPr indent="0" marL="0">
+              <a:buNone/>
+            </a:pPr>
+            <a:r>
+              <a:rPr lang="en-US" sz="1200" dirty="0">
+                <a:solidFill>
+                  <a:schemeClr val="tx1"/>
+                </a:solidFill>
+              </a:rPr>
+              <a:t>The graph continues from its checkpoint</a:t>
+            </a:r>
+            <a:endParaRPr lang="en-US" sz="1200" dirty="0"/>
+          </a:p>
+        </p:txBody>
+      </p:sp>
+      <p:sp>
+        <p:nvSpPr>
+          <p:cNvPr id="19" name="step card"/>
+          <p:cNvSpPr/>
+          <p:nvPr/>
+        </p:nvSpPr>
+        <p:spPr>
+          <a:xfrm>
+            <a:off x="6766560" y="1188720"/>
+            <a:ext cx="1920240" cy="1371600"/>
+          </a:xfrm>
+          <a:prstGeom prst="roundRect">
+            <a:avLst>
+              <a:gd name="adj" fmla="val 5333"/>
+            </a:avLst>
+          </a:prstGeom>
+          <a:solidFill>
+            <a:schemeClr val="bg2"/>
+          </a:solidFill>
+          <a:ln/>
+        </p:spPr>
+      </p:sp>
+      <p:sp>
+        <p:nvSpPr>
+          <p:cNvPr id="20" name="badge"/>
+          <p:cNvSpPr/>
+          <p:nvPr/>
+        </p:nvSpPr>
+        <p:spPr>
+          <a:xfrm>
+            <a:off x="6903720" y="1325880"/>
+            <a:ext cx="347472" cy="347472"/>
+          </a:xfrm>
+          <a:prstGeom prst="ellipse">
+            <a:avLst/>
+          </a:prstGeom>
+          <a:solidFill>
+            <a:schemeClr val="accent1"/>
+          </a:solidFill>
+          <a:ln/>
+        </p:spPr>
+      </p:sp>
+      <p:sp>
+        <p:nvSpPr>
+          <p:cNvPr id="21" name="Text 18"/>
+          <p:cNvSpPr txBox="1"/>
+          <p:nvPr/>
+        </p:nvSpPr>
+        <p:spPr>
+          <a:xfrm>
+            <a:off x="6903720" y="1325880"/>
+            <a:ext cx="347472" cy="347472"/>
+          </a:xfrm>
+          <a:prstGeom prst="rect">
+            <a:avLst/>
+          </a:prstGeom>
+          <a:noFill/>
+          <a:ln/>
+        </p:spPr>
+        <p:txBody>
+          <a:bodyPr wrap="square" lIns="0" tIns="0" rIns="0" bIns="0" rtlCol="0" anchor="ctr"/>
+          <a:lstStyle/>
+          <a:p>
+            <a:pPr algn="ctr" indent="0" marL="0">
+              <a:buNone/>
+            </a:pPr>
+            <a:r>
+              <a:rPr lang="en-US" sz="1400" b="1" dirty="0">
+                <a:solidFill>
+                  <a:schemeClr val="bg1"/>
+                </a:solidFill>
+              </a:rPr>
+              <a:t>4</a:t>
+            </a:r>
+            <a:endParaRPr lang="en-US" sz="1400" dirty="0"/>
+          </a:p>
+        </p:txBody>
+      </p:sp>
+      <p:sp>
+        <p:nvSpPr>
+          <p:cNvPr id="22" name="Text 19"/>
+          <p:cNvSpPr txBox="1"/>
+          <p:nvPr/>
+        </p:nvSpPr>
+        <p:spPr>
+          <a:xfrm>
+            <a:off x="7360920" y="1307592"/>
+            <a:ext cx="1234440" cy="384048"/>
+          </a:xfrm>
+          <a:prstGeom prst="rect">
+            <a:avLst/>
+          </a:prstGeom>
+          <a:noFill/>
+          <a:ln/>
+        </p:spPr>
+        <p:txBody>
+          <a:bodyPr wrap="square" lIns="0" tIns="0" rIns="0" bIns="0" rtlCol="0" anchor="ctr"/>
+          <a:lstStyle/>
+          <a:p>
+            <a:pPr indent="0" marL="0">
+              <a:buNone/>
+            </a:pPr>
+            <a:r>
+              <a:rPr lang="en-US" sz="1400" b="1" dirty="0">
+                <a:solidFill>
+                  <a:schemeClr val="tx2"/>
+                </a:solidFill>
+              </a:rPr>
+              <a:t>Learn</a:t>
+            </a:r>
+            <a:endParaRPr lang="en-US" sz="1400" dirty="0"/>
+          </a:p>
+        </p:txBody>
+      </p:sp>
+      <p:sp>
+        <p:nvSpPr>
+          <p:cNvPr id="23" name="Text 20"/>
+          <p:cNvSpPr txBox="1"/>
+          <p:nvPr/>
+        </p:nvSpPr>
+        <p:spPr>
+          <a:xfrm>
+            <a:off x="6903720" y="1828800"/>
+            <a:ext cx="1645920" cy="685800"/>
+          </a:xfrm>
+          <a:prstGeom prst="rect">
+            <a:avLst/>
+          </a:prstGeom>
+          <a:noFill/>
+          <a:ln/>
+        </p:spPr>
+        <p:txBody>
+          <a:bodyPr wrap="square" lIns="0" tIns="0" rIns="0" bIns="0" rtlCol="0" anchor="t"/>
+          <a:lstStyle/>
+          <a:p>
+            <a:pPr indent="0" marL="0">
+              <a:buNone/>
+            </a:pPr>
+            <a:r>
+              <a:rPr lang="en-US" sz="1200" dirty="0">
+                <a:solidFill>
+                  <a:schemeClr val="tx1"/>
+                </a:solidFill>
+              </a:rPr>
+              <a:t>The decision is saved to vendor memory</a:t>
+            </a:r>
+            <a:endParaRPr lang="en-US" sz="1200" dirty="0"/>
+          </a:p>
+        </p:txBody>
+      </p:sp>
+      <p:sp>
+        <p:nvSpPr>
+          <p:cNvPr id="24" name="Text 21"/>
+          <p:cNvSpPr txBox="1"/>
+          <p:nvPr/>
+        </p:nvSpPr>
+        <p:spPr>
+          <a:xfrm>
+            <a:off x="457200" y="2697480"/>
+            <a:ext cx="8229600" cy="274320"/>
+          </a:xfrm>
+          <a:prstGeom prst="rect">
+            <a:avLst/>
+          </a:prstGeom>
+          <a:noFill/>
+          <a:ln/>
+        </p:spPr>
+        <p:txBody>
+          <a:bodyPr wrap="square" lIns="0" tIns="0" rIns="0" bIns="0" rtlCol="0" anchor="t"/>
+          <a:lstStyle/>
+          <a:p>
+            <a:pPr indent="0" marL="0">
+              <a:buNone/>
+            </a:pPr>
+            <a:r>
+              <a:rPr lang="en-US" sz="1300" b="1" dirty="0">
+                <a:solidFill>
+                  <a:schemeClr val="tx2"/>
+                </a:solidFill>
+              </a:rPr>
+              <a:t>Real trace: a vendor's bank-account change, approved by a reviewer</a:t>
+            </a:r>
+            <a:endParaRPr lang="en-US" sz="1300" dirty="0"/>
+          </a:p>
+        </p:txBody>
+      </p:sp>
+      <p:sp>
+        <p:nvSpPr>
+          <p:cNvPr id="25" name="trace box"/>
+          <p:cNvSpPr/>
+          <p:nvPr/>
+        </p:nvSpPr>
+        <p:spPr>
+          <a:xfrm>
+            <a:off x="457200" y="3017520"/>
+            <a:ext cx="8229600" cy="1645920"/>
+          </a:xfrm>
+          <a:prstGeom prst="roundRect">
+            <a:avLst>
+              <a:gd name="adj" fmla="val 4444"/>
+            </a:avLst>
+          </a:prstGeom>
+          <a:solidFill>
+            <a:schemeClr val="tx2"/>
+          </a:solidFill>
+          <a:ln/>
+        </p:spPr>
+      </p:sp>
+      <p:sp>
+        <p:nvSpPr>
+          <p:cNvPr id="26" name="Text 23"/>
+          <p:cNvSpPr txBox="1"/>
+          <p:nvPr/>
+        </p:nvSpPr>
+        <p:spPr>
+          <a:xfrm>
+            <a:off x="640080" y="3127248"/>
+            <a:ext cx="7863840" cy="1417320"/>
+          </a:xfrm>
+          <a:prstGeom prst="rect">
+            <a:avLst/>
+          </a:prstGeom>
+          <a:noFill/>
+          <a:ln/>
+        </p:spPr>
+        <p:txBody>
+          <a:bodyPr wrap="square" lIns="0" tIns="0" rIns="0" bIns="0" rtlCol="0" anchor="ctr"/>
+          <a:lstStyle/>
+          <a:p>
+            <a:pPr indent="0" marL="0">
+              <a:spcAft>
+                <a:spcPts val="300"/>
+              </a:spcAft>
+              <a:buNone/>
+            </a:pPr>
+            <a:r>
+              <a:rPr lang="en-US" sz="1100" dirty="0">
+                <a:solidFill>
+                  <a:schemeClr val="bg1"/>
+                </a:solidFill>
+                <a:latin typeface="Courier New" pitchFamily="34" charset="0"/>
+                <a:ea typeface="Courier New" pitchFamily="34" charset="-122"/>
+                <a:cs typeface="Courier New" pitchFamily="34" charset="-120"/>
+              </a:rPr>
+              <a:t>Fraud Agent: BANK_CHANGE; risk score 70/100</a:t>
+            </a:r>
+            <a:endParaRPr lang="en-US" sz="1100" dirty="0"/>
+          </a:p>
+          <a:p>
+            <a:pPr indent="0" marL="0">
+              <a:spcAft>
+                <a:spcPts val="300"/>
+              </a:spcAft>
+              <a:buNone/>
+            </a:pPr>
+            <a:r>
+              <a:rPr lang="en-US" sz="1100" dirty="0">
+                <a:solidFill>
+                  <a:schemeClr val="bg1"/>
+                </a:solidFill>
+                <a:latin typeface="Courier New" pitchFamily="34" charset="0"/>
+                <a:ea typeface="Courier New" pitchFamily="34" charset="-122"/>
+                <a:cs typeface="Courier New" pitchFamily="34" charset="-120"/>
+              </a:rPr>
+              <a:t>Decision Agent: ESCALATED (fraud / control risk: BANK_CHANGE)</a:t>
+            </a:r>
+            <a:endParaRPr lang="en-US" sz="1100" dirty="0"/>
+          </a:p>
+          <a:p>
+            <a:pPr indent="0" marL="0">
+              <a:spcAft>
+                <a:spcPts val="300"/>
+              </a:spcAft>
+              <a:buNone/>
+            </a:pPr>
+            <a:r>
+              <a:rPr lang="en-US" sz="1100" dirty="0">
+                <a:solidFill>
+                  <a:schemeClr val="bg1"/>
+                </a:solidFill>
+                <a:latin typeface="Courier New" pitchFamily="34" charset="0"/>
+                <a:ea typeface="Courier New" pitchFamily="34" charset="-122"/>
+                <a:cs typeface="Courier New" pitchFamily="34" charset="-120"/>
+              </a:rPr>
+              <a:t>... graph paused at interrupt; invoice waits in the Review queue ...</a:t>
+            </a:r>
+            <a:endParaRPr lang="en-US" sz="1100" dirty="0"/>
+          </a:p>
+          <a:p>
+            <a:pPr indent="0" marL="0">
+              <a:spcAft>
+                <a:spcPts val="300"/>
+              </a:spcAft>
+              <a:buNone/>
+            </a:pPr>
+            <a:r>
+              <a:rPr lang="en-US" sz="1100" dirty="0">
+                <a:solidFill>
+                  <a:schemeClr val="bg1"/>
+                </a:solidFill>
+                <a:latin typeface="Courier New" pitchFamily="34" charset="0"/>
+                <a:ea typeface="Courier New" pitchFamily="34" charset="-122"/>
+                <a:cs typeface="Courier New" pitchFamily="34" charset="-120"/>
+              </a:rPr>
+              <a:t>Human Review: Saafalya reviewed: APPROVE -&gt; APPROVED - "new account confirmed by phone"</a:t>
+            </a:r>
+            <a:endParaRPr lang="en-US" sz="1100" dirty="0"/>
+          </a:p>
+          <a:p>
+            <a:pPr indent="0" marL="0">
+              <a:spcAft>
+                <a:spcPts val="300"/>
+              </a:spcAft>
+              <a:buNone/>
+            </a:pPr>
+            <a:r>
+              <a:rPr lang="en-US" sz="1100" dirty="0">
+                <a:solidFill>
+                  <a:schemeClr val="bg1"/>
+                </a:solidFill>
+                <a:latin typeface="Courier New" pitchFamily="34" charset="0"/>
+                <a:ea typeface="Courier New" pitchFamily="34" charset="-122"/>
+                <a:cs typeface="Courier New" pitchFamily="34" charset="-120"/>
+              </a:rPr>
+              <a:t>              new bank account saved to vendor memory: next invoice is not flagged</a:t>
+            </a:r>
+            <a:endParaRPr lang="en-US" sz="1100" dirty="0"/>
+          </a:p>
+        </p:txBody>
+      </p:sp>
+      <p:sp>
+        <p:nvSpPr>
+          <p:cNvPr id="27" name="Slide Number Placeholder 0"/>
+          <p:cNvSpPr>
+            <a:spLocks noGrp="1"/>
+          </p:cNvSpPr>
+          <p:nvPr>
+            <p:ph type="sldNum" sz="quarter" idx="4294967295"/>
+          </p:nvPr>
+        </p:nvSpPr>
+        <p:spPr>
+          <a:xfrm>
+            <a:off x="8321040" y="4754880"/>
+            <a:ext cx="457200" cy="274320"/>
+          </a:xfrm>
+          <a:prstGeom prst="rect">
+            <a:avLst/>
+          </a:prstGeom>
+          <a:extLst>
+            <a:ext uri="{C572A759-6A51-4108-AA02-DFA0A04FC94B}">
+              <ma14:wrappingTextBoxFlag xmlns:ma14="http://schemas.microsoft.com/office/mac/drawingml/2011/main" val="0"/>
+            </a:ext>
+          </a:extLst>
+        </p:spPr>
+        <p:txBody>
+          <a:bodyPr/>
+          <a:lstStyle>
+            <a:lvl1pPr>
+              <a:defRPr sz="1000">
+                <a:solidFill>
+                  <a:schemeClr val="accent5"/>
+                </a:solidFill>
+              </a:defRPr>
+            </a:lvl1pPr>
+          </a:lstStyle>
+          <a:p>
+            <a:pPr algn="l"/>
+            <a:fld id="{F7021451-1387-4CA6-816F-3879F97B5CBC}" type="slidenum">
+              <a:rPr b="0" lang="en-US"/>
+              <a:t>7</a:t>
+            </a:fld>
+            <a:endParaRPr lang="en-US"/>
+          </a:p>
+        </p:txBody>
+      </p:sp>
+    </p:spTree>
+  </p:cSld>
+  <p:clrMapOvr>
+    <a:masterClrMapping/>
+  </p:clrMapOvr>
+</p:sld>
+</file>
+
 <file path=ppt/slides/slide2.xml><?xml version="1.0" encoding="utf-8"?>
 <p:sld xmlns:a="http://schemas.openxmlformats.org/drawingml/2006/main" xmlns:r="http://schemas.openxmlformats.org/officeDocument/2006/relationships" xmlns:p="http://schemas.openxmlformats.org/presentationml/2006/main">
   <p:cSld name="Slide 2">
@@ -4575,7 +6223,7 @@
   <p:cSld name="Slide 4">
     <p:spTree>
       <p:nvGrpSpPr>
-        <p:cNvPr id="1" name=""/>
+        <p:cNvPr id="2" name=""/>
         <p:cNvGrpSpPr/>
         <p:nvPr/>
       </p:nvGrpSpPr>
@@ -4589,7 +6237,7 @@
       </p:grpSpPr>
       <p:sp>
         <p:nvSpPr>
-          <p:cNvPr id="2" name="Text 0"/>
+          <p:cNvPr id="3" name="Text 0"/>
           <p:cNvSpPr/>
           <p:nvPr>
             <p:ph idx="100" type="title" hasCustomPrompt="1"/>
@@ -4619,7 +6267,7 @@
                   <a:schemeClr val="tx2"/>
                 </a:solidFill>
               </a:rPr>
-              <a:t>Five agents, one job</a:t>
+              <a:t>Seven agents, one job</a:t>
             </a:r>
             <a:endParaRPr lang="en-US" sz="3400" dirty="0"/>
           </a:p>
@@ -4627,14 +6275,14 @@
       </p:sp>
       <p:sp>
         <p:nvSpPr>
-          <p:cNvPr id="3" name="agent row"/>
+          <p:cNvPr id="4" name="agent row"/>
           <p:cNvSpPr/>
           <p:nvPr/>
         </p:nvSpPr>
         <p:spPr>
           <a:xfrm>
-            <a:off x="457200" y="1188720"/>
-            <a:ext cx="8229600" cy="603504"/>
+            <a:off x="457200" y="1097280"/>
+            <a:ext cx="8229600" cy="457200"/>
           </a:xfrm>
           <a:prstGeom prst="roundRect">
             <a:avLst>
@@ -4649,14 +6297,14 @@
       </p:sp>
       <p:sp>
         <p:nvSpPr>
-          <p:cNvPr id="4" name="badge"/>
+          <p:cNvPr id="5" name="badge"/>
           <p:cNvSpPr/>
           <p:nvPr/>
         </p:nvSpPr>
         <p:spPr>
           <a:xfrm>
-            <a:off x="594360" y="1280160"/>
-            <a:ext cx="420624" cy="420624"/>
+            <a:off x="603504" y="1152144"/>
+            <a:ext cx="347472" cy="347472"/>
           </a:xfrm>
           <a:prstGeom prst="ellipse">
             <a:avLst/>
@@ -4669,7 +6317,7 @@
       </p:sp>
       <p:pic>
         <p:nvPicPr>
-          <p:cNvPr id="5" name="Image 0" descr="Planner">    </p:cNvPr>
+          <p:cNvPr id="6" name="Image 0" descr="Planner">    </p:cNvPr>
           <p:cNvPicPr>
             <a:picLocks noChangeAspect="1"/>
           </p:cNvPicPr>
@@ -4683,8 +6331,8 @@
         </p:blipFill>
         <p:spPr>
           <a:xfrm>
-            <a:off x="713232" y="1399032"/>
-            <a:ext cx="182880" cy="182880"/>
+            <a:off x="694944" y="1243584"/>
+            <a:ext cx="164592" cy="164592"/>
           </a:xfrm>
           <a:prstGeom prst="rect">
             <a:avLst/>
@@ -4693,14 +6341,14 @@
       </p:pic>
       <p:sp>
         <p:nvSpPr>
-          <p:cNvPr id="6" name="Text 3"/>
-          <p:cNvSpPr txBox="1"/>
-          <p:nvPr/>
-        </p:nvSpPr>
-        <p:spPr>
-          <a:xfrm>
-            <a:off x="1234440" y="1188720"/>
-            <a:ext cx="1645920" cy="603504"/>
+          <p:cNvPr id="7" name="Text 3"/>
+          <p:cNvSpPr txBox="1"/>
+          <p:nvPr/>
+        </p:nvSpPr>
+        <p:spPr>
+          <a:xfrm>
+            <a:off x="1234440" y="1097280"/>
+            <a:ext cx="1645920" cy="457200"/>
           </a:xfrm>
           <a:prstGeom prst="rect">
             <a:avLst/>
@@ -4716,27 +6364,27 @@
               <a:buNone/>
             </a:pPr>
             <a:r>
-              <a:rPr lang="en-US" sz="1600" b="1" dirty="0">
+              <a:rPr lang="en-US" sz="1500" b="1" dirty="0">
                 <a:solidFill>
                   <a:schemeClr val="tx2"/>
                 </a:solidFill>
               </a:rPr>
               <a:t>Planner</a:t>
             </a:r>
-            <a:endParaRPr lang="en-US" sz="1600" dirty="0"/>
-          </a:p>
-        </p:txBody>
-      </p:sp>
-      <p:sp>
-        <p:nvSpPr>
-          <p:cNvPr id="7" name="Text 4"/>
-          <p:cNvSpPr txBox="1"/>
-          <p:nvPr/>
-        </p:nvSpPr>
-        <p:spPr>
-          <a:xfrm>
-            <a:off x="2926080" y="1188720"/>
-            <a:ext cx="5577840" cy="603504"/>
+            <a:endParaRPr lang="en-US" sz="1500" dirty="0"/>
+          </a:p>
+        </p:txBody>
+      </p:sp>
+      <p:sp>
+        <p:nvSpPr>
+          <p:cNvPr id="8" name="Text 4"/>
+          <p:cNvSpPr txBox="1"/>
+          <p:nvPr/>
+        </p:nvSpPr>
+        <p:spPr>
+          <a:xfrm>
+            <a:off x="2926080" y="1097280"/>
+            <a:ext cx="5577840" cy="457200"/>
           </a:xfrm>
           <a:prstGeom prst="rect">
             <a:avLst/>
@@ -4752,27 +6400,27 @@
               <a:buNone/>
             </a:pPr>
             <a:r>
-              <a:rPr lang="en-US" sz="1400" dirty="0">
+              <a:rPr lang="en-US" sz="1300" dirty="0">
                 <a:solidFill>
                   <a:schemeClr val="tx1"/>
                 </a:solidFill>
               </a:rPr>
               <a:t>Sequences the batch by due date and amount; flags urgent invoices</a:t>
             </a:r>
-            <a:endParaRPr lang="en-US" sz="1400" dirty="0"/>
-          </a:p>
-        </p:txBody>
-      </p:sp>
-      <p:sp>
-        <p:nvSpPr>
-          <p:cNvPr id="8" name="agent row"/>
+            <a:endParaRPr lang="en-US" sz="1300" dirty="0"/>
+          </a:p>
+        </p:txBody>
+      </p:sp>
+      <p:sp>
+        <p:nvSpPr>
+          <p:cNvPr id="9" name="agent row"/>
           <p:cNvSpPr/>
           <p:nvPr/>
         </p:nvSpPr>
         <p:spPr>
           <a:xfrm>
-            <a:off x="457200" y="1883664"/>
-            <a:ext cx="8229600" cy="603504"/>
+            <a:off x="457200" y="1604772"/>
+            <a:ext cx="8229600" cy="457200"/>
           </a:xfrm>
           <a:prstGeom prst="roundRect">
             <a:avLst>
@@ -4787,14 +6435,14 @@
       </p:sp>
       <p:sp>
         <p:nvSpPr>
-          <p:cNvPr id="9" name="badge"/>
+          <p:cNvPr id="10" name="badge"/>
           <p:cNvSpPr/>
           <p:nvPr/>
         </p:nvSpPr>
         <p:spPr>
           <a:xfrm>
-            <a:off x="594360" y="1975104"/>
-            <a:ext cx="420624" cy="420624"/>
+            <a:off x="603504" y="1659636"/>
+            <a:ext cx="347472" cy="347472"/>
           </a:xfrm>
           <a:prstGeom prst="ellipse">
             <a:avLst/>
@@ -4807,7 +6455,7 @@
       </p:sp>
       <p:pic>
         <p:nvPicPr>
-          <p:cNvPr id="10" name="Image 1" descr="Extraction">    </p:cNvPr>
+          <p:cNvPr id="11" name="Image 1" descr="Extraction">    </p:cNvPr>
           <p:cNvPicPr>
             <a:picLocks noChangeAspect="1"/>
           </p:cNvPicPr>
@@ -4821,8 +6469,8 @@
         </p:blipFill>
         <p:spPr>
           <a:xfrm>
-            <a:off x="713232" y="2093976"/>
-            <a:ext cx="182880" cy="182880"/>
+            <a:off x="694944" y="1751076"/>
+            <a:ext cx="164592" cy="164592"/>
           </a:xfrm>
           <a:prstGeom prst="rect">
             <a:avLst/>
@@ -4831,14 +6479,14 @@
       </p:pic>
       <p:sp>
         <p:nvSpPr>
-          <p:cNvPr id="11" name="Text 7"/>
-          <p:cNvSpPr txBox="1"/>
-          <p:nvPr/>
-        </p:nvSpPr>
-        <p:spPr>
-          <a:xfrm>
-            <a:off x="1234440" y="1883664"/>
-            <a:ext cx="1645920" cy="603504"/>
+          <p:cNvPr id="12" name="Text 7"/>
+          <p:cNvSpPr txBox="1"/>
+          <p:nvPr/>
+        </p:nvSpPr>
+        <p:spPr>
+          <a:xfrm>
+            <a:off x="1234440" y="1604772"/>
+            <a:ext cx="1645920" cy="457200"/>
           </a:xfrm>
           <a:prstGeom prst="rect">
             <a:avLst/>
@@ -4854,27 +6502,27 @@
               <a:buNone/>
             </a:pPr>
             <a:r>
-              <a:rPr lang="en-US" sz="1600" b="1" dirty="0">
+              <a:rPr lang="en-US" sz="1500" b="1" dirty="0">
                 <a:solidFill>
                   <a:schemeClr val="tx2"/>
                 </a:solidFill>
               </a:rPr>
               <a:t>Extraction</a:t>
             </a:r>
-            <a:endParaRPr lang="en-US" sz="1600" dirty="0"/>
-          </a:p>
-        </p:txBody>
-      </p:sp>
-      <p:sp>
-        <p:nvSpPr>
-          <p:cNvPr id="12" name="Text 8"/>
-          <p:cNvSpPr txBox="1"/>
-          <p:nvPr/>
-        </p:nvSpPr>
-        <p:spPr>
-          <a:xfrm>
-            <a:off x="2926080" y="1883664"/>
-            <a:ext cx="5577840" cy="603504"/>
+            <a:endParaRPr lang="en-US" sz="1500" dirty="0"/>
+          </a:p>
+        </p:txBody>
+      </p:sp>
+      <p:sp>
+        <p:nvSpPr>
+          <p:cNvPr id="13" name="Text 8"/>
+          <p:cNvSpPr txBox="1"/>
+          <p:nvPr/>
+        </p:nvSpPr>
+        <p:spPr>
+          <a:xfrm>
+            <a:off x="2926080" y="1604772"/>
+            <a:ext cx="5577840" cy="457200"/>
           </a:xfrm>
           <a:prstGeom prst="rect">
             <a:avLst/>
@@ -4890,27 +6538,27 @@
               <a:buNone/>
             </a:pPr>
             <a:r>
-              <a:rPr lang="en-US" sz="1400" dirty="0">
+              <a:rPr lang="en-US" sz="1300" dirty="0">
                 <a:solidFill>
                   <a:schemeClr val="tx1"/>
                 </a:solidFill>
               </a:rPr>
               <a:t>Turns invoice text into a typed schema with an LLM or parser; retries if rejected</a:t>
             </a:r>
-            <a:endParaRPr lang="en-US" sz="1400" dirty="0"/>
-          </a:p>
-        </p:txBody>
-      </p:sp>
-      <p:sp>
-        <p:nvSpPr>
-          <p:cNvPr id="13" name="agent row"/>
+            <a:endParaRPr lang="en-US" sz="1300" dirty="0"/>
+          </a:p>
+        </p:txBody>
+      </p:sp>
+      <p:sp>
+        <p:nvSpPr>
+          <p:cNvPr id="14" name="agent row"/>
           <p:cNvSpPr/>
           <p:nvPr/>
         </p:nvSpPr>
         <p:spPr>
           <a:xfrm>
-            <a:off x="457200" y="2578608"/>
-            <a:ext cx="8229600" cy="603504"/>
+            <a:off x="457200" y="2112264"/>
+            <a:ext cx="8229600" cy="457200"/>
           </a:xfrm>
           <a:prstGeom prst="roundRect">
             <a:avLst>
@@ -4925,14 +6573,14 @@
       </p:sp>
       <p:sp>
         <p:nvSpPr>
-          <p:cNvPr id="14" name="badge"/>
+          <p:cNvPr id="15" name="badge"/>
           <p:cNvSpPr/>
           <p:nvPr/>
         </p:nvSpPr>
         <p:spPr>
           <a:xfrm>
-            <a:off x="594360" y="2670048"/>
-            <a:ext cx="420624" cy="420624"/>
+            <a:off x="603504" y="2167128"/>
+            <a:ext cx="347472" cy="347472"/>
           </a:xfrm>
           <a:prstGeom prst="ellipse">
             <a:avLst/>
@@ -4945,7 +6593,7 @@
       </p:sp>
       <p:pic>
         <p:nvPicPr>
-          <p:cNvPr id="15" name="Image 2" descr="Critic">    </p:cNvPr>
+          <p:cNvPr id="16" name="Image 2" descr="Critic">    </p:cNvPr>
           <p:cNvPicPr>
             <a:picLocks noChangeAspect="1"/>
           </p:cNvPicPr>
@@ -4959,8 +6607,8 @@
         </p:blipFill>
         <p:spPr>
           <a:xfrm>
-            <a:off x="713232" y="2788920"/>
-            <a:ext cx="182880" cy="182880"/>
+            <a:off x="694944" y="2258568"/>
+            <a:ext cx="164592" cy="164592"/>
           </a:xfrm>
           <a:prstGeom prst="rect">
             <a:avLst/>
@@ -4969,14 +6617,14 @@
       </p:pic>
       <p:sp>
         <p:nvSpPr>
-          <p:cNvPr id="16" name="Text 11"/>
-          <p:cNvSpPr txBox="1"/>
-          <p:nvPr/>
-        </p:nvSpPr>
-        <p:spPr>
-          <a:xfrm>
-            <a:off x="1234440" y="2578608"/>
-            <a:ext cx="1645920" cy="603504"/>
+          <p:cNvPr id="17" name="Text 11"/>
+          <p:cNvSpPr txBox="1"/>
+          <p:nvPr/>
+        </p:nvSpPr>
+        <p:spPr>
+          <a:xfrm>
+            <a:off x="1234440" y="2112264"/>
+            <a:ext cx="1645920" cy="457200"/>
           </a:xfrm>
           <a:prstGeom prst="rect">
             <a:avLst/>
@@ -4992,27 +6640,27 @@
               <a:buNone/>
             </a:pPr>
             <a:r>
-              <a:rPr lang="en-US" sz="1600" b="1" dirty="0">
+              <a:rPr lang="en-US" sz="1500" b="1" dirty="0">
                 <a:solidFill>
                   <a:schemeClr val="tx2"/>
                 </a:solidFill>
               </a:rPr>
               <a:t>Critic</a:t>
             </a:r>
-            <a:endParaRPr lang="en-US" sz="1600" dirty="0"/>
-          </a:p>
-        </p:txBody>
-      </p:sp>
-      <p:sp>
-        <p:nvSpPr>
-          <p:cNvPr id="17" name="Text 12"/>
-          <p:cNvSpPr txBox="1"/>
-          <p:nvPr/>
-        </p:nvSpPr>
-        <p:spPr>
-          <a:xfrm>
-            <a:off x="2926080" y="2578608"/>
-            <a:ext cx="5577840" cy="603504"/>
+            <a:endParaRPr lang="en-US" sz="1500" dirty="0"/>
+          </a:p>
+        </p:txBody>
+      </p:sp>
+      <p:sp>
+        <p:nvSpPr>
+          <p:cNvPr id="18" name="Text 12"/>
+          <p:cNvSpPr txBox="1"/>
+          <p:nvPr/>
+        </p:nvSpPr>
+        <p:spPr>
+          <a:xfrm>
+            <a:off x="2926080" y="2112264"/>
+            <a:ext cx="5577840" cy="457200"/>
           </a:xfrm>
           <a:prstGeom prst="rect">
             <a:avLst/>
@@ -5028,27 +6676,27 @@
               <a:buNone/>
             </a:pPr>
             <a:r>
-              <a:rPr lang="en-US" sz="1400" dirty="0">
+              <a:rPr lang="en-US" sz="1300" dirty="0">
                 <a:solidFill>
                   <a:schemeClr val="tx1"/>
                 </a:solidFill>
               </a:rPr>
               <a:t>Rejects extractions that fail arithmetic checks; confirms every variance is explained</a:t>
             </a:r>
-            <a:endParaRPr lang="en-US" sz="1400" dirty="0"/>
-          </a:p>
-        </p:txBody>
-      </p:sp>
-      <p:sp>
-        <p:nvSpPr>
-          <p:cNvPr id="18" name="agent row"/>
+            <a:endParaRPr lang="en-US" sz="1300" dirty="0"/>
+          </a:p>
+        </p:txBody>
+      </p:sp>
+      <p:sp>
+        <p:nvSpPr>
+          <p:cNvPr id="19" name="agent row"/>
           <p:cNvSpPr/>
           <p:nvPr/>
         </p:nvSpPr>
         <p:spPr>
           <a:xfrm>
-            <a:off x="457200" y="3273552"/>
-            <a:ext cx="8229600" cy="603504"/>
+            <a:off x="457200" y="2619756"/>
+            <a:ext cx="8229600" cy="457200"/>
           </a:xfrm>
           <a:prstGeom prst="roundRect">
             <a:avLst>
@@ -5063,14 +6711,14 @@
       </p:sp>
       <p:sp>
         <p:nvSpPr>
-          <p:cNvPr id="19" name="badge"/>
+          <p:cNvPr id="20" name="badge"/>
           <p:cNvSpPr/>
           <p:nvPr/>
         </p:nvSpPr>
         <p:spPr>
           <a:xfrm>
-            <a:off x="594360" y="3364992"/>
-            <a:ext cx="420624" cy="420624"/>
+            <a:off x="603504" y="2674620"/>
+            <a:ext cx="347472" cy="347472"/>
           </a:xfrm>
           <a:prstGeom prst="ellipse">
             <a:avLst/>
@@ -5083,7 +6731,7 @@
       </p:sp>
       <p:pic>
         <p:nvPicPr>
-          <p:cNvPr id="20" name="Image 3" descr="Matching">    </p:cNvPr>
+          <p:cNvPr id="21" name="Image 3" descr="Matching">    </p:cNvPr>
           <p:cNvPicPr>
             <a:picLocks noChangeAspect="1"/>
           </p:cNvPicPr>
@@ -5097,8 +6745,8 @@
         </p:blipFill>
         <p:spPr>
           <a:xfrm>
-            <a:off x="713232" y="3483864"/>
-            <a:ext cx="182880" cy="182880"/>
+            <a:off x="694944" y="2766060"/>
+            <a:ext cx="164592" cy="164592"/>
           </a:xfrm>
           <a:prstGeom prst="rect">
             <a:avLst/>
@@ -5107,14 +6755,14 @@
       </p:pic>
       <p:sp>
         <p:nvSpPr>
-          <p:cNvPr id="21" name="Text 15"/>
-          <p:cNvSpPr txBox="1"/>
-          <p:nvPr/>
-        </p:nvSpPr>
-        <p:spPr>
-          <a:xfrm>
-            <a:off x="1234440" y="3273552"/>
-            <a:ext cx="1645920" cy="603504"/>
+          <p:cNvPr id="22" name="Text 15"/>
+          <p:cNvSpPr txBox="1"/>
+          <p:nvPr/>
+        </p:nvSpPr>
+        <p:spPr>
+          <a:xfrm>
+            <a:off x="1234440" y="2619756"/>
+            <a:ext cx="1645920" cy="457200"/>
           </a:xfrm>
           <a:prstGeom prst="rect">
             <a:avLst/>
@@ -5130,27 +6778,27 @@
               <a:buNone/>
             </a:pPr>
             <a:r>
-              <a:rPr lang="en-US" sz="1600" b="1" dirty="0">
+              <a:rPr lang="en-US" sz="1500" b="1" dirty="0">
                 <a:solidFill>
                   <a:schemeClr val="tx2"/>
                 </a:solidFill>
               </a:rPr>
               <a:t>Matching</a:t>
             </a:r>
-            <a:endParaRPr lang="en-US" sz="1600" dirty="0"/>
-          </a:p>
-        </p:txBody>
-      </p:sp>
-      <p:sp>
-        <p:nvSpPr>
-          <p:cNvPr id="22" name="Text 16"/>
-          <p:cNvSpPr txBox="1"/>
-          <p:nvPr/>
-        </p:nvSpPr>
-        <p:spPr>
-          <a:xfrm>
-            <a:off x="2926080" y="3273552"/>
-            <a:ext cx="5577840" cy="603504"/>
+            <a:endParaRPr lang="en-US" sz="1500" dirty="0"/>
+          </a:p>
+        </p:txBody>
+      </p:sp>
+      <p:sp>
+        <p:nvSpPr>
+          <p:cNvPr id="23" name="Text 16"/>
+          <p:cNvSpPr txBox="1"/>
+          <p:nvPr/>
+        </p:nvSpPr>
+        <p:spPr>
+          <a:xfrm>
+            <a:off x="2926080" y="2619756"/>
+            <a:ext cx="5577840" cy="457200"/>
           </a:xfrm>
           <a:prstGeom prst="rect">
             <a:avLst/>
@@ -5166,27 +6814,27 @@
               <a:buNone/>
             </a:pPr>
             <a:r>
-              <a:rPr lang="en-US" sz="1400" dirty="0">
+              <a:rPr lang="en-US" sz="1300" dirty="0">
                 <a:solidFill>
                   <a:schemeClr val="tx1"/>
                 </a:solidFill>
               </a:rPr>
               <a:t>Compares invoice, PO and goods receipt on price, quantity, tax, vendor and duplicates</a:t>
             </a:r>
-            <a:endParaRPr lang="en-US" sz="1400" dirty="0"/>
-          </a:p>
-        </p:txBody>
-      </p:sp>
-      <p:sp>
-        <p:nvSpPr>
-          <p:cNvPr id="23" name="agent row"/>
+            <a:endParaRPr lang="en-US" sz="1300" dirty="0"/>
+          </a:p>
+        </p:txBody>
+      </p:sp>
+      <p:sp>
+        <p:nvSpPr>
+          <p:cNvPr id="24" name="agent row"/>
           <p:cNvSpPr/>
           <p:nvPr/>
         </p:nvSpPr>
         <p:spPr>
           <a:xfrm>
-            <a:off x="457200" y="3968496"/>
-            <a:ext cx="8229600" cy="603504"/>
+            <a:off x="457200" y="3127248"/>
+            <a:ext cx="8229600" cy="457200"/>
           </a:xfrm>
           <a:prstGeom prst="roundRect">
             <a:avLst>
@@ -5201,14 +6849,14 @@
       </p:sp>
       <p:sp>
         <p:nvSpPr>
-          <p:cNvPr id="24" name="badge"/>
+          <p:cNvPr id="25" name="badge"/>
           <p:cNvSpPr/>
           <p:nvPr/>
         </p:nvSpPr>
         <p:spPr>
           <a:xfrm>
-            <a:off x="594360" y="4059936"/>
-            <a:ext cx="420624" cy="420624"/>
+            <a:off x="603504" y="3182112"/>
+            <a:ext cx="347472" cy="347472"/>
           </a:xfrm>
           <a:prstGeom prst="ellipse">
             <a:avLst/>
@@ -5221,7 +6869,145 @@
       </p:sp>
       <p:pic>
         <p:nvPicPr>
-          <p:cNvPr id="25" name="Image 4" descr="Decision">    </p:cNvPr>
+          <p:cNvPr id="26" name="Image 4" descr="Fraud">    </p:cNvPr>
+          <p:cNvPicPr>
+            <a:picLocks noChangeAspect="1"/>
+          </p:cNvPicPr>
+          <p:nvPr/>
+        </p:nvPicPr>
+        <p:blipFill>
+          <a:blip r:embed="rId8"/>
+          <a:stretch>
+            <a:fillRect/>
+          </a:stretch>
+        </p:blipFill>
+        <p:spPr>
+          <a:xfrm>
+            <a:off x="694944" y="3273552"/>
+            <a:ext cx="164592" cy="164592"/>
+          </a:xfrm>
+          <a:prstGeom prst="rect">
+            <a:avLst/>
+          </a:prstGeom>
+        </p:spPr>
+      </p:pic>
+      <p:sp>
+        <p:nvSpPr>
+          <p:cNvPr id="27" name="Text 19"/>
+          <p:cNvSpPr txBox="1"/>
+          <p:nvPr/>
+        </p:nvSpPr>
+        <p:spPr>
+          <a:xfrm>
+            <a:off x="1234440" y="3127248"/>
+            <a:ext cx="1645920" cy="457200"/>
+          </a:xfrm>
+          <a:prstGeom prst="rect">
+            <a:avLst/>
+          </a:prstGeom>
+          <a:noFill/>
+          <a:ln/>
+        </p:spPr>
+        <p:txBody>
+          <a:bodyPr wrap="square" lIns="0" tIns="0" rIns="0" bIns="0" rtlCol="0" anchor="ctr"/>
+          <a:lstStyle/>
+          <a:p>
+            <a:pPr indent="0" marL="0">
+              <a:buNone/>
+            </a:pPr>
+            <a:r>
+              <a:rPr lang="en-US" sz="1500" b="1" dirty="0">
+                <a:solidFill>
+                  <a:schemeClr val="tx2"/>
+                </a:solidFill>
+              </a:rPr>
+              <a:t>Fraud</a:t>
+            </a:r>
+            <a:endParaRPr lang="en-US" sz="1500" dirty="0"/>
+          </a:p>
+        </p:txBody>
+      </p:sp>
+      <p:sp>
+        <p:nvSpPr>
+          <p:cNvPr id="28" name="Text 20"/>
+          <p:cNvSpPr txBox="1"/>
+          <p:nvPr/>
+        </p:nvSpPr>
+        <p:spPr>
+          <a:xfrm>
+            <a:off x="2926080" y="3127248"/>
+            <a:ext cx="5577840" cy="457200"/>
+          </a:xfrm>
+          <a:prstGeom prst="rect">
+            <a:avLst/>
+          </a:prstGeom>
+          <a:noFill/>
+          <a:ln/>
+        </p:spPr>
+        <p:txBody>
+          <a:bodyPr wrap="square" lIns="0" tIns="0" rIns="0" bIns="0" rtlCol="0" anchor="ctr"/>
+          <a:lstStyle/>
+          <a:p>
+            <a:pPr indent="0" marL="0">
+              <a:buNone/>
+            </a:pPr>
+            <a:r>
+              <a:rPr lang="en-US" sz="1300" dirty="0">
+                <a:solidFill>
+                  <a:schemeClr val="tx1"/>
+                </a:solidFill>
+              </a:rPr>
+              <a:t>Flags lookalike vendors, bank changes and amount spikes; scores risk</a:t>
+            </a:r>
+            <a:endParaRPr lang="en-US" sz="1300" dirty="0"/>
+          </a:p>
+        </p:txBody>
+      </p:sp>
+      <p:sp>
+        <p:nvSpPr>
+          <p:cNvPr id="29" name="agent row"/>
+          <p:cNvSpPr/>
+          <p:nvPr/>
+        </p:nvSpPr>
+        <p:spPr>
+          <a:xfrm>
+            <a:off x="457200" y="3634740"/>
+            <a:ext cx="8229600" cy="457200"/>
+          </a:xfrm>
+          <a:prstGeom prst="roundRect">
+            <a:avLst>
+              <a:gd name="adj" fmla="val 12121"/>
+            </a:avLst>
+          </a:prstGeom>
+          <a:solidFill>
+            <a:schemeClr val="bg2"/>
+          </a:solidFill>
+          <a:ln/>
+        </p:spPr>
+      </p:sp>
+      <p:sp>
+        <p:nvSpPr>
+          <p:cNvPr id="30" name="badge"/>
+          <p:cNvSpPr/>
+          <p:nvPr/>
+        </p:nvSpPr>
+        <p:spPr>
+          <a:xfrm>
+            <a:off x="603504" y="3689604"/>
+            <a:ext cx="347472" cy="347472"/>
+          </a:xfrm>
+          <a:prstGeom prst="ellipse">
+            <a:avLst/>
+          </a:prstGeom>
+          <a:solidFill>
+            <a:schemeClr val="accent1"/>
+          </a:solidFill>
+          <a:ln/>
+        </p:spPr>
+      </p:sp>
+      <p:pic>
+        <p:nvPicPr>
+          <p:cNvPr id="31" name="Image 4" descr="Decision">    </p:cNvPr>
           <p:cNvPicPr>
             <a:picLocks noChangeAspect="1"/>
           </p:cNvPicPr>
@@ -5235,8 +7021,8 @@
         </p:blipFill>
         <p:spPr>
           <a:xfrm>
-            <a:off x="713232" y="4178808"/>
-            <a:ext cx="182880" cy="182880"/>
+            <a:off x="694944" y="3781044"/>
+            <a:ext cx="164592" cy="164592"/>
           </a:xfrm>
           <a:prstGeom prst="rect">
             <a:avLst/>
@@ -5245,14 +7031,14 @@
       </p:pic>
       <p:sp>
         <p:nvSpPr>
-          <p:cNvPr id="26" name="Text 19"/>
-          <p:cNvSpPr txBox="1"/>
-          <p:nvPr/>
-        </p:nvSpPr>
-        <p:spPr>
-          <a:xfrm>
-            <a:off x="1234440" y="3968496"/>
-            <a:ext cx="1645920" cy="603504"/>
+          <p:cNvPr id="32" name="Text 19"/>
+          <p:cNvSpPr txBox="1"/>
+          <p:nvPr/>
+        </p:nvSpPr>
+        <p:spPr>
+          <a:xfrm>
+            <a:off x="1234440" y="3634740"/>
+            <a:ext cx="1645920" cy="457200"/>
           </a:xfrm>
           <a:prstGeom prst="rect">
             <a:avLst/>
@@ -5268,27 +7054,27 @@
               <a:buNone/>
             </a:pPr>
             <a:r>
-              <a:rPr lang="en-US" sz="1600" b="1" dirty="0">
+              <a:rPr lang="en-US" sz="1500" b="1" dirty="0">
                 <a:solidFill>
                   <a:schemeClr val="tx2"/>
                 </a:solidFill>
               </a:rPr>
               <a:t>Decision</a:t>
             </a:r>
-            <a:endParaRPr lang="en-US" sz="1600" dirty="0"/>
-          </a:p>
-        </p:txBody>
-      </p:sp>
-      <p:sp>
-        <p:nvSpPr>
-          <p:cNvPr id="27" name="Text 20"/>
-          <p:cNvSpPr txBox="1"/>
-          <p:nvPr/>
-        </p:nvSpPr>
-        <p:spPr>
-          <a:xfrm>
-            <a:off x="2926080" y="3968496"/>
-            <a:ext cx="5577840" cy="603504"/>
+            <a:endParaRPr lang="en-US" sz="1500" dirty="0"/>
+          </a:p>
+        </p:txBody>
+      </p:sp>
+      <p:sp>
+        <p:nvSpPr>
+          <p:cNvPr id="33" name="Text 20"/>
+          <p:cNvSpPr txBox="1"/>
+          <p:nvPr/>
+        </p:nvSpPr>
+        <p:spPr>
+          <a:xfrm>
+            <a:off x="2926080" y="3634740"/>
+            <a:ext cx="5577840" cy="457200"/>
           </a:xfrm>
           <a:prstGeom prst="rect">
             <a:avLst/>
@@ -5304,20 +7090,158 @@
               <a:buNone/>
             </a:pPr>
             <a:r>
-              <a:rPr lang="en-US" sz="1400" dirty="0">
+              <a:rPr lang="en-US" sz="1300" dirty="0">
                 <a:solidFill>
                   <a:schemeClr val="tx1"/>
                 </a:solidFill>
               </a:rPr>
               <a:t>Applies business rules to approve, hold or escalate, and writes the reason</a:t>
             </a:r>
-            <a:endParaRPr lang="en-US" sz="1400" dirty="0"/>
-          </a:p>
-        </p:txBody>
-      </p:sp>
-      <p:sp>
-        <p:nvSpPr>
-          <p:cNvPr id="25" name="Slide Number Placeholder 0"/>
+            <a:endParaRPr lang="en-US" sz="1300" dirty="0"/>
+          </a:p>
+        </p:txBody>
+      </p:sp>
+      <p:sp>
+        <p:nvSpPr>
+          <p:cNvPr id="34" name="agent row"/>
+          <p:cNvSpPr/>
+          <p:nvPr/>
+        </p:nvSpPr>
+        <p:spPr>
+          <a:xfrm>
+            <a:off x="457200" y="4142232"/>
+            <a:ext cx="8229600" cy="457200"/>
+          </a:xfrm>
+          <a:prstGeom prst="roundRect">
+            <a:avLst>
+              <a:gd name="adj" fmla="val 12121"/>
+            </a:avLst>
+          </a:prstGeom>
+          <a:solidFill>
+            <a:schemeClr val="bg2"/>
+          </a:solidFill>
+          <a:ln/>
+        </p:spPr>
+      </p:sp>
+      <p:sp>
+        <p:nvSpPr>
+          <p:cNvPr id="35" name="badge"/>
+          <p:cNvSpPr/>
+          <p:nvPr/>
+        </p:nvSpPr>
+        <p:spPr>
+          <a:xfrm>
+            <a:off x="603504" y="4197096"/>
+            <a:ext cx="347472" cy="347472"/>
+          </a:xfrm>
+          <a:prstGeom prst="ellipse">
+            <a:avLst/>
+          </a:prstGeom>
+          <a:solidFill>
+            <a:schemeClr val="accent1"/>
+          </a:solidFill>
+          <a:ln/>
+        </p:spPr>
+      </p:sp>
+      <p:pic>
+        <p:nvPicPr>
+          <p:cNvPr id="36" name="Image 4" descr="Human Review">    </p:cNvPr>
+          <p:cNvPicPr>
+            <a:picLocks noChangeAspect="1"/>
+          </p:cNvPicPr>
+          <p:nvPr/>
+        </p:nvPicPr>
+        <p:blipFill>
+          <a:blip r:embed="rId9"/>
+          <a:stretch>
+            <a:fillRect/>
+          </a:stretch>
+        </p:blipFill>
+        <p:spPr>
+          <a:xfrm>
+            <a:off x="694944" y="4288536"/>
+            <a:ext cx="164592" cy="164592"/>
+          </a:xfrm>
+          <a:prstGeom prst="rect">
+            <a:avLst/>
+          </a:prstGeom>
+        </p:spPr>
+      </p:pic>
+      <p:sp>
+        <p:nvSpPr>
+          <p:cNvPr id="37" name="Text 19"/>
+          <p:cNvSpPr txBox="1"/>
+          <p:nvPr/>
+        </p:nvSpPr>
+        <p:spPr>
+          <a:xfrm>
+            <a:off x="1234440" y="4142232"/>
+            <a:ext cx="1645920" cy="457200"/>
+          </a:xfrm>
+          <a:prstGeom prst="rect">
+            <a:avLst/>
+          </a:prstGeom>
+          <a:noFill/>
+          <a:ln/>
+        </p:spPr>
+        <p:txBody>
+          <a:bodyPr wrap="square" lIns="0" tIns="0" rIns="0" bIns="0" rtlCol="0" anchor="ctr"/>
+          <a:lstStyle/>
+          <a:p>
+            <a:pPr indent="0" marL="0">
+              <a:buNone/>
+            </a:pPr>
+            <a:r>
+              <a:rPr lang="en-US" sz="1500" b="1" dirty="0">
+                <a:solidFill>
+                  <a:schemeClr val="tx2"/>
+                </a:solidFill>
+              </a:rPr>
+              <a:t>Human Review</a:t>
+            </a:r>
+            <a:endParaRPr lang="en-US" sz="1500" dirty="0"/>
+          </a:p>
+        </p:txBody>
+      </p:sp>
+      <p:sp>
+        <p:nvSpPr>
+          <p:cNvPr id="38" name="Text 20"/>
+          <p:cNvSpPr txBox="1"/>
+          <p:nvPr/>
+        </p:nvSpPr>
+        <p:spPr>
+          <a:xfrm>
+            <a:off x="2926080" y="4142232"/>
+            <a:ext cx="5577840" cy="457200"/>
+          </a:xfrm>
+          <a:prstGeom prst="rect">
+            <a:avLst/>
+          </a:prstGeom>
+          <a:noFill/>
+          <a:ln/>
+        </p:spPr>
+        <p:txBody>
+          <a:bodyPr wrap="square" lIns="0" tIns="0" rIns="0" bIns="0" rtlCol="0" anchor="ctr"/>
+          <a:lstStyle/>
+          <a:p>
+            <a:pPr indent="0" marL="0">
+              <a:buNone/>
+            </a:pPr>
+            <a:r>
+              <a:rPr lang="en-US" sz="1300" dirty="0">
+                <a:solidFill>
+                  <a:schemeClr val="tx1"/>
+                </a:solidFill>
+              </a:rPr>
+              <a:t>Pauses escalations for a person, then updates vendor memory</a:t>
+            </a:r>
+            <a:endParaRPr lang="en-US" sz="1300" dirty="0"/>
+          </a:p>
+        </p:txBody>
+      </p:sp>
+      <p:sp>
+        <p:nvSpPr>
+          <p:cNvPr id="39" name="Slide Number Placeholder 0"/>
           <p:cNvSpPr>
             <a:spLocks noGrp="1"/>
           </p:cNvSpPr>
@@ -5373,7 +7297,7 @@
   <p:cSld name="Slide 5">
     <p:spTree>
       <p:nvGrpSpPr>
-        <p:cNvPr id="1" name=""/>
+        <p:cNvPr id="2" name=""/>
         <p:cNvGrpSpPr/>
         <p:nvPr/>
       </p:nvGrpSpPr>
@@ -5387,7 +7311,7 @@
       </p:grpSpPr>
       <p:sp>
         <p:nvSpPr>
-          <p:cNvPr id="2" name="Text 0"/>
+          <p:cNvPr id="3" name="Text 0"/>
           <p:cNvSpPr/>
           <p:nvPr>
             <p:ph idx="100" type="title" hasCustomPrompt="1"/>
@@ -5425,14 +7349,14 @@
       </p:sp>
       <p:sp>
         <p:nvSpPr>
-          <p:cNvPr id="3" name="agent step"/>
+          <p:cNvPr id="4" name="agent step"/>
           <p:cNvSpPr txBox="1"/>
           <p:nvPr/>
         </p:nvSpPr>
         <p:spPr>
           <a:xfrm>
             <a:off x="457200" y="1828800"/>
-            <a:ext cx="1188720" cy="914400"/>
+            <a:ext cx="987552" cy="914400"/>
           </a:xfrm>
           <a:prstGeom prst="roundRect">
             <a:avLst>
@@ -5479,13 +7403,13 @@
       </p:sp>
       <p:sp>
         <p:nvSpPr>
-          <p:cNvPr id="4" name="Shape 2"/>
+          <p:cNvPr id="5" name="Shape 2"/>
           <p:cNvSpPr/>
           <p:nvPr/>
         </p:nvSpPr>
         <p:spPr>
           <a:xfrm>
-            <a:off x="1645920" y="2286000"/>
+            <a:off x="1444752" y="2286000"/>
             <a:ext cx="219456" cy="0"/>
           </a:xfrm>
           <a:prstGeom prst="line">
@@ -5503,14 +7427,14 @@
       </p:sp>
       <p:sp>
         <p:nvSpPr>
-          <p:cNvPr id="5" name="agent step"/>
-          <p:cNvSpPr txBox="1"/>
-          <p:nvPr/>
-        </p:nvSpPr>
-        <p:spPr>
-          <a:xfrm>
-            <a:off x="1865376" y="1828800"/>
-            <a:ext cx="1188720" cy="914400"/>
+          <p:cNvPr id="6" name="agent step"/>
+          <p:cNvSpPr txBox="1"/>
+          <p:nvPr/>
+        </p:nvSpPr>
+        <p:spPr>
+          <a:xfrm>
+            <a:off x="1664208" y="1828800"/>
+            <a:ext cx="987552" cy="914400"/>
           </a:xfrm>
           <a:prstGeom prst="roundRect">
             <a:avLst>
@@ -5557,13 +7481,13 @@
       </p:sp>
       <p:sp>
         <p:nvSpPr>
-          <p:cNvPr id="6" name="Shape 4"/>
+          <p:cNvPr id="7" name="Shape 4"/>
           <p:cNvSpPr/>
           <p:nvPr/>
         </p:nvSpPr>
         <p:spPr>
           <a:xfrm>
-            <a:off x="3054096" y="2286000"/>
+            <a:off x="2651760" y="2286000"/>
             <a:ext cx="219456" cy="0"/>
           </a:xfrm>
           <a:prstGeom prst="line">
@@ -5581,14 +7505,14 @@
       </p:sp>
       <p:sp>
         <p:nvSpPr>
-          <p:cNvPr id="7" name="agent step"/>
-          <p:cNvSpPr txBox="1"/>
-          <p:nvPr/>
-        </p:nvSpPr>
-        <p:spPr>
-          <a:xfrm>
-            <a:off x="3273552" y="1828800"/>
-            <a:ext cx="1188720" cy="914400"/>
+          <p:cNvPr id="8" name="agent step"/>
+          <p:cNvSpPr txBox="1"/>
+          <p:nvPr/>
+        </p:nvSpPr>
+        <p:spPr>
+          <a:xfrm>
+            <a:off x="2871216" y="1828800"/>
+            <a:ext cx="987552" cy="914400"/>
           </a:xfrm>
           <a:prstGeom prst="roundRect">
             <a:avLst>
@@ -5635,13 +7559,13 @@
       </p:sp>
       <p:sp>
         <p:nvSpPr>
-          <p:cNvPr id="8" name="Shape 6"/>
+          <p:cNvPr id="9" name="Shape 6"/>
           <p:cNvSpPr/>
           <p:nvPr/>
         </p:nvSpPr>
         <p:spPr>
           <a:xfrm>
-            <a:off x="4462272" y="2286000"/>
+            <a:off x="3858768" y="2286000"/>
             <a:ext cx="219456" cy="0"/>
           </a:xfrm>
           <a:prstGeom prst="line">
@@ -5659,14 +7583,14 @@
       </p:sp>
       <p:sp>
         <p:nvSpPr>
-          <p:cNvPr id="9" name="agent step"/>
-          <p:cNvSpPr txBox="1"/>
-          <p:nvPr/>
-        </p:nvSpPr>
-        <p:spPr>
-          <a:xfrm>
-            <a:off x="4681728" y="1828800"/>
-            <a:ext cx="1188720" cy="914400"/>
+          <p:cNvPr id="10" name="agent step"/>
+          <p:cNvSpPr txBox="1"/>
+          <p:nvPr/>
+        </p:nvSpPr>
+        <p:spPr>
+          <a:xfrm>
+            <a:off x="4078224" y="1828800"/>
+            <a:ext cx="987552" cy="914400"/>
           </a:xfrm>
           <a:prstGeom prst="roundRect">
             <a:avLst>
@@ -5713,13 +7637,67 @@
       </p:sp>
       <p:sp>
         <p:nvSpPr>
-          <p:cNvPr id="10" name="Shape 8"/>
+          <p:cNvPr id="11" name="agent step"/>
+          <p:cNvSpPr txBox="1"/>
+          <p:nvPr/>
+        </p:nvSpPr>
+        <p:spPr>
+          <a:xfrm>
+            <a:off x="5285232" y="1828800"/>
+            <a:ext cx="987552" cy="914400"/>
+          </a:xfrm>
+          <a:prstGeom prst="roundRect">
+            <a:avLst>
+              <a:gd name="adj" fmla="val 8000"/>
+            </a:avLst>
+          </a:prstGeom>
+          <a:solidFill>
+            <a:schemeClr val="accent3"/>
+          </a:solidFill>
+          <a:ln/>
+        </p:spPr>
+        <p:txBody>
+          <a:bodyPr wrap="square" lIns="635" tIns="635" rIns="635" bIns="635" rtlCol="0" anchor="ctr"/>
+          <a:lstStyle/>
+          <a:p>
+            <a:pPr algn="ctr" indent="0" marL="0">
+              <a:buNone/>
+            </a:pPr>
+            <a:r>
+              <a:rPr lang="en-US" sz="1400" b="1" dirty="0">
+                <a:solidFill>
+                  <a:schemeClr val="bg1"/>
+                </a:solidFill>
+              </a:rPr>
+              <a:t>Fraud</a:t>
+            </a:r>
+            <a:endParaRPr lang="en-US" sz="1400" dirty="0"/>
+          </a:p>
+          <a:p>
+            <a:pPr algn="ctr" indent="0" marL="0">
+              <a:buNone/>
+            </a:pPr>
+            <a:r>
+              <a:rPr lang="en-US" sz="1200" dirty="0">
+                <a:solidFill>
+                  <a:schemeClr val="bg1"/>
+                </a:solidFill>
+              </a:rPr>
+              <a:t>risk score</a:t>
+            </a:r>
+            <a:endParaRPr lang="en-US" sz="1400" dirty="0"/>
+          </a:p>
+        </p:txBody>
+      </p:sp>
+      <p:sp>
+        <p:nvSpPr>
+          <p:cNvPr id="12" name="Shape 8"/>
           <p:cNvSpPr/>
           <p:nvPr/>
         </p:nvSpPr>
         <p:spPr>
           <a:xfrm>
-            <a:off x="5870448" y="2286000"/>
+            <a:off x="5065776" y="2286000"/>
             <a:ext cx="219456" cy="0"/>
           </a:xfrm>
           <a:prstGeom prst="line">
@@ -5737,14 +7715,14 @@
       </p:sp>
       <p:sp>
         <p:nvSpPr>
-          <p:cNvPr id="11" name="agent step"/>
-          <p:cNvSpPr txBox="1"/>
-          <p:nvPr/>
-        </p:nvSpPr>
-        <p:spPr>
-          <a:xfrm>
-            <a:off x="6089904" y="1828800"/>
-            <a:ext cx="1188720" cy="914400"/>
+          <p:cNvPr id="13" name="agent step"/>
+          <p:cNvSpPr txBox="1"/>
+          <p:nvPr/>
+        </p:nvSpPr>
+        <p:spPr>
+          <a:xfrm>
+            <a:off x="6492240" y="1828800"/>
+            <a:ext cx="987552" cy="914400"/>
           </a:xfrm>
           <a:prstGeom prst="roundRect">
             <a:avLst>
@@ -5791,13 +7769,13 @@
       </p:sp>
       <p:sp>
         <p:nvSpPr>
-          <p:cNvPr id="12" name="Shape 10"/>
+          <p:cNvPr id="14" name="Shape 10"/>
           <p:cNvSpPr/>
           <p:nvPr/>
         </p:nvSpPr>
         <p:spPr>
           <a:xfrm>
-            <a:off x="7278624" y="2286000"/>
+            <a:off x="6272784" y="2286000"/>
             <a:ext cx="219456" cy="0"/>
           </a:xfrm>
           <a:prstGeom prst="line">
@@ -5815,14 +7793,38 @@
       </p:sp>
       <p:sp>
         <p:nvSpPr>
-          <p:cNvPr id="13" name="agent step"/>
-          <p:cNvSpPr txBox="1"/>
-          <p:nvPr/>
-        </p:nvSpPr>
-        <p:spPr>
-          <a:xfrm>
-            <a:off x="7498080" y="1828800"/>
-            <a:ext cx="1188720" cy="914400"/>
+          <p:cNvPr id="15" name="Shape 10"/>
+          <p:cNvSpPr/>
+          <p:nvPr/>
+        </p:nvSpPr>
+        <p:spPr>
+          <a:xfrm>
+            <a:off x="7479792" y="2286000"/>
+            <a:ext cx="219456" cy="0"/>
+          </a:xfrm>
+          <a:prstGeom prst="line">
+            <a:avLst/>
+          </a:prstGeom>
+          <a:noFill/>
+          <a:ln w="22225">
+            <a:solidFill>
+              <a:schemeClr val="accent5"/>
+            </a:solidFill>
+            <a:prstDash val="solid"/>
+            <a:tailEnd type="triangle"/>
+          </a:ln>
+        </p:spPr>
+      </p:sp>
+      <p:sp>
+        <p:nvSpPr>
+          <p:cNvPr id="16" name="agent step"/>
+          <p:cNvSpPr txBox="1"/>
+          <p:nvPr/>
+        </p:nvSpPr>
+        <p:spPr>
+          <a:xfrm>
+            <a:off x="7699248" y="1828800"/>
+            <a:ext cx="987552" cy="914400"/>
           </a:xfrm>
           <a:prstGeom prst="roundRect">
             <a:avLst>
@@ -5869,13 +7871,13 @@
       </p:sp>
       <p:sp>
         <p:nvSpPr>
-          <p:cNvPr id="14" name="Shape 12"/>
+          <p:cNvPr id="17" name="Shape 12"/>
           <p:cNvSpPr/>
           <p:nvPr/>
         </p:nvSpPr>
         <p:spPr>
           <a:xfrm>
-            <a:off x="3867912" y="1600200"/>
+            <a:off x="3364992" y="1600200"/>
             <a:ext cx="0" cy="228600"/>
           </a:xfrm>
           <a:prstGeom prst="line">
@@ -5892,14 +7894,14 @@
       </p:sp>
       <p:sp>
         <p:nvSpPr>
-          <p:cNvPr id="15" name="Shape 13"/>
+          <p:cNvPr id="18" name="Shape 13"/>
           <p:cNvSpPr/>
           <p:nvPr/>
         </p:nvSpPr>
         <p:spPr>
           <a:xfrm>
-            <a:off x="2459736" y="1600200"/>
-            <a:ext cx="1408176" cy="0"/>
+            <a:off x="2157984" y="1600200"/>
+            <a:ext cx="1207008" cy="0"/>
           </a:xfrm>
           <a:prstGeom prst="line">
             <a:avLst/>
@@ -5915,13 +7917,13 @@
       </p:sp>
       <p:sp>
         <p:nvSpPr>
-          <p:cNvPr id="16" name="Shape 14"/>
+          <p:cNvPr id="19" name="Shape 14"/>
           <p:cNvSpPr/>
           <p:nvPr/>
         </p:nvSpPr>
         <p:spPr>
           <a:xfrm>
-            <a:off x="2459736" y="1600200"/>
+            <a:off x="2157984" y="1600200"/>
             <a:ext cx="0" cy="228600"/>
           </a:xfrm>
           <a:prstGeom prst="line">
@@ -5939,13 +7941,13 @@
       </p:sp>
       <p:sp>
         <p:nvSpPr>
-          <p:cNvPr id="17" name="Text 15"/>
-          <p:cNvSpPr txBox="1"/>
-          <p:nvPr/>
-        </p:nvSpPr>
-        <p:spPr>
-          <a:xfrm>
-            <a:off x="1828800" y="1280160"/>
+          <p:cNvPr id="20" name="Text 15"/>
+          <p:cNvSpPr txBox="1"/>
+          <p:nvPr/>
+        </p:nvSpPr>
+        <p:spPr>
+          <a:xfrm>
+            <a:off x="1609344" y="1280160"/>
             <a:ext cx="3474720" cy="274320"/>
           </a:xfrm>
           <a:prstGeom prst="rect">
@@ -5975,13 +7977,13 @@
       </p:sp>
       <p:sp>
         <p:nvSpPr>
-          <p:cNvPr id="18" name="Shape 16"/>
+          <p:cNvPr id="21" name="Shape 16"/>
           <p:cNvSpPr/>
           <p:nvPr/>
         </p:nvSpPr>
         <p:spPr>
           <a:xfrm>
-            <a:off x="8092440" y="2743200"/>
+            <a:off x="8193024" y="2743200"/>
             <a:ext cx="0" cy="457200"/>
           </a:xfrm>
           <a:prstGeom prst="line">
@@ -5999,7 +8001,7 @@
       </p:sp>
       <p:sp>
         <p:nvSpPr>
-          <p:cNvPr id="19" name="outcome"/>
+          <p:cNvPr id="22" name="outcome"/>
           <p:cNvSpPr/>
           <p:nvPr/>
         </p:nvSpPr>
@@ -6021,7 +8023,7 @@
       </p:sp>
       <p:sp>
         <p:nvSpPr>
-          <p:cNvPr id="20" name="Text 18"/>
+          <p:cNvPr id="23" name="Text 18"/>
           <p:cNvSpPr txBox="1"/>
           <p:nvPr/>
         </p:nvSpPr>
@@ -6057,7 +8059,7 @@
       </p:sp>
       <p:sp>
         <p:nvSpPr>
-          <p:cNvPr id="21" name="Text 19"/>
+          <p:cNvPr id="24" name="Text 19"/>
           <p:cNvSpPr txBox="1"/>
           <p:nvPr/>
         </p:nvSpPr>
@@ -6093,7 +8095,7 @@
       </p:sp>
       <p:sp>
         <p:nvSpPr>
-          <p:cNvPr id="22" name="outcome"/>
+          <p:cNvPr id="25" name="outcome"/>
           <p:cNvSpPr/>
           <p:nvPr/>
         </p:nvSpPr>
@@ -6115,7 +8117,7 @@
       </p:sp>
       <p:sp>
         <p:nvSpPr>
-          <p:cNvPr id="23" name="Text 21"/>
+          <p:cNvPr id="26" name="Text 21"/>
           <p:cNvSpPr txBox="1"/>
           <p:nvPr/>
         </p:nvSpPr>
@@ -6151,7 +8153,7 @@
       </p:sp>
       <p:sp>
         <p:nvSpPr>
-          <p:cNvPr id="24" name="Text 22"/>
+          <p:cNvPr id="27" name="Text 22"/>
           <p:cNvSpPr txBox="1"/>
           <p:nvPr/>
         </p:nvSpPr>
@@ -6187,7 +8189,7 @@
       </p:sp>
       <p:sp>
         <p:nvSpPr>
-          <p:cNvPr id="25" name="outcome"/>
+          <p:cNvPr id="28" name="outcome"/>
           <p:cNvSpPr/>
           <p:nvPr/>
         </p:nvSpPr>
@@ -6209,7 +8211,7 @@
       </p:sp>
       <p:sp>
         <p:nvSpPr>
-          <p:cNvPr id="26" name="Text 24"/>
+          <p:cNvPr id="29" name="Text 24"/>
           <p:cNvSpPr txBox="1"/>
           <p:nvPr/>
         </p:nvSpPr>
@@ -6245,7 +8247,7 @@
       </p:sp>
       <p:sp>
         <p:nvSpPr>
-          <p:cNvPr id="27" name="Text 25"/>
+          <p:cNvPr id="30" name="Text 25"/>
           <p:cNvSpPr txBox="1"/>
           <p:nvPr/>
         </p:nvSpPr>
@@ -6273,7 +8275,7 @@
                   <a:schemeClr val="bg1"/>
                 </a:solidFill>
               </a:rPr>
-              <a:t>Duplicate, unknown vendor or INR 10,000+ at risk. A human reviews.</a:t>
+              <a:t>Fraud signal, duplicate, unknown vendor or INR 10,000+ at risk. Paused for a human.</a:t>
             </a:r>
             <a:endParaRPr lang="en-US" sz="1300" dirty="0"/>
           </a:p>
@@ -6281,7 +8283,7 @@
       </p:sp>
       <p:sp>
         <p:nvSpPr>
-          <p:cNvPr id="25" name="Slide Number Placeholder 0"/>
+          <p:cNvPr id="31" name="Slide Number Placeholder 0"/>
           <p:cNvSpPr>
             <a:spLocks noGrp="1"/>
           </p:cNvSpPr>
@@ -6337,7 +8339,7 @@
   <p:cSld name="Slide 6">
     <p:spTree>
       <p:nvGrpSpPr>
-        <p:cNvPr id="1" name=""/>
+        <p:cNvPr id="2" name=""/>
         <p:cNvGrpSpPr/>
         <p:nvPr/>
       </p:nvGrpSpPr>
@@ -6351,7 +8353,7 @@
       </p:grpSpPr>
       <p:sp>
         <p:nvSpPr>
-          <p:cNvPr id="2" name="Text 0"/>
+          <p:cNvPr id="3" name="Text 0"/>
           <p:cNvSpPr/>
           <p:nvPr>
             <p:ph idx="100" type="title" hasCustomPrompt="1"/>
@@ -6389,7 +8391,7 @@
       </p:sp>
       <p:sp>
         <p:nvSpPr>
-          <p:cNvPr id="3" name="layer ui"/>
+          <p:cNvPr id="4" name="layer ui"/>
           <p:cNvSpPr/>
           <p:nvPr/>
         </p:nvSpPr>
@@ -6411,7 +8413,7 @@
       </p:sp>
       <p:sp>
         <p:nvSpPr>
-          <p:cNvPr id="4" name="Text 2"/>
+          <p:cNvPr id="5" name="Text 2"/>
           <p:cNvSpPr txBox="1"/>
           <p:nvPr/>
         </p:nvSpPr>
@@ -6453,7 +8455,7 @@
                   <a:schemeClr val="bg1"/>
                 </a:solidFill>
               </a:rPr>
-              <a:t>controls, live agent trace, results dashboard</a:t>
+              <a:t>live agent trace, review queue, PDF upload, results, vendor memory</a:t>
             </a:r>
             <a:endParaRPr lang="en-US" sz="1500" dirty="0"/>
           </a:p>
@@ -6461,7 +8463,7 @@
       </p:sp>
       <p:sp>
         <p:nvSpPr>
-          <p:cNvPr id="5" name="layer graph"/>
+          <p:cNvPr id="6" name="layer graph"/>
           <p:cNvSpPr/>
           <p:nvPr/>
         </p:nvSpPr>
@@ -6483,7 +8485,7 @@
       </p:sp>
       <p:sp>
         <p:nvSpPr>
-          <p:cNvPr id="6" name="Text 4"/>
+          <p:cNvPr id="7" name="Text 4"/>
           <p:cNvSpPr txBox="1"/>
           <p:nvPr/>
         </p:nvSpPr>
@@ -6525,7 +8527,7 @@
                   <a:schemeClr val="bg1"/>
                 </a:solidFill>
               </a:rPr>
-              <a:t>shared state, conditional retry edge, plain-Python fallback</a:t>
+              <a:t>shared state, retry edge, interrupt + checkpointer for human review</a:t>
             </a:r>
             <a:endParaRPr lang="en-US" sz="1500" dirty="0"/>
           </a:p>
@@ -6533,7 +8535,7 @@
       </p:sp>
       <p:sp>
         <p:nvSpPr>
-          <p:cNvPr id="7" name="layer agents"/>
+          <p:cNvPr id="8" name="layer agents"/>
           <p:cNvSpPr/>
           <p:nvPr/>
         </p:nvSpPr>
@@ -6555,7 +8557,7 @@
       </p:sp>
       <p:sp>
         <p:nvSpPr>
-          <p:cNvPr id="8" name="Text 6"/>
+          <p:cNvPr id="9" name="Text 6"/>
           <p:cNvSpPr txBox="1"/>
           <p:nvPr/>
         </p:nvSpPr>
@@ -6591,14 +8593,14 @@
       </p:sp>
       <p:sp>
         <p:nvSpPr>
-          <p:cNvPr id="9" name="agent chip"/>
+          <p:cNvPr id="10" name="agent chip"/>
           <p:cNvSpPr txBox="1"/>
           <p:nvPr/>
         </p:nvSpPr>
         <p:spPr>
           <a:xfrm>
             <a:off x="594360" y="3200400"/>
-            <a:ext cx="950976" cy="411480"/>
+            <a:ext cx="694944" cy="411480"/>
           </a:xfrm>
           <a:prstGeom prst="roundRect">
             <a:avLst>
@@ -6618,27 +8620,27 @@
               <a:buNone/>
             </a:pPr>
             <a:r>
-              <a:rPr lang="en-US" sz="1100" b="1" dirty="0">
+              <a:rPr lang="en-US" sz="1000" b="1" dirty="0">
                 <a:solidFill>
                   <a:schemeClr val="bg1"/>
                 </a:solidFill>
               </a:rPr>
               <a:t>Planner</a:t>
             </a:r>
-            <a:endParaRPr lang="en-US" sz="1100" dirty="0"/>
-          </a:p>
-        </p:txBody>
-      </p:sp>
-      <p:sp>
-        <p:nvSpPr>
-          <p:cNvPr id="10" name="agent chip"/>
-          <p:cNvSpPr txBox="1"/>
-          <p:nvPr/>
-        </p:nvSpPr>
-        <p:spPr>
-          <a:xfrm>
-            <a:off x="1636776" y="3200400"/>
-            <a:ext cx="950976" cy="411480"/>
+            <a:endParaRPr lang="en-US" sz="1000" dirty="0"/>
+          </a:p>
+        </p:txBody>
+      </p:sp>
+      <p:sp>
+        <p:nvSpPr>
+          <p:cNvPr id="11" name="agent chip"/>
+          <p:cNvSpPr txBox="1"/>
+          <p:nvPr/>
+        </p:nvSpPr>
+        <p:spPr>
+          <a:xfrm>
+            <a:off x="1335024" y="3200400"/>
+            <a:ext cx="694944" cy="411480"/>
           </a:xfrm>
           <a:prstGeom prst="roundRect">
             <a:avLst>
@@ -6658,27 +8660,27 @@
               <a:buNone/>
             </a:pPr>
             <a:r>
-              <a:rPr lang="en-US" sz="1100" b="1" dirty="0">
+              <a:rPr lang="en-US" sz="1000" b="1" dirty="0">
                 <a:solidFill>
                   <a:schemeClr val="bg1"/>
                 </a:solidFill>
               </a:rPr>
               <a:t>Extraction</a:t>
             </a:r>
-            <a:endParaRPr lang="en-US" sz="1100" dirty="0"/>
-          </a:p>
-        </p:txBody>
-      </p:sp>
-      <p:sp>
-        <p:nvSpPr>
-          <p:cNvPr id="11" name="agent chip"/>
-          <p:cNvSpPr txBox="1"/>
-          <p:nvPr/>
-        </p:nvSpPr>
-        <p:spPr>
-          <a:xfrm>
-            <a:off x="2679192" y="3200400"/>
-            <a:ext cx="950976" cy="411480"/>
+            <a:endParaRPr lang="en-US" sz="1000" dirty="0"/>
+          </a:p>
+        </p:txBody>
+      </p:sp>
+      <p:sp>
+        <p:nvSpPr>
+          <p:cNvPr id="12" name="agent chip"/>
+          <p:cNvSpPr txBox="1"/>
+          <p:nvPr/>
+        </p:nvSpPr>
+        <p:spPr>
+          <a:xfrm>
+            <a:off x="2075688" y="3200400"/>
+            <a:ext cx="694944" cy="411480"/>
           </a:xfrm>
           <a:prstGeom prst="roundRect">
             <a:avLst>
@@ -6698,27 +8700,27 @@
               <a:buNone/>
             </a:pPr>
             <a:r>
-              <a:rPr lang="en-US" sz="1100" b="1" dirty="0">
+              <a:rPr lang="en-US" sz="1000" b="1" dirty="0">
                 <a:solidFill>
                   <a:schemeClr val="tx1"/>
                 </a:solidFill>
               </a:rPr>
               <a:t>Critic</a:t>
             </a:r>
-            <a:endParaRPr lang="en-US" sz="1100" dirty="0"/>
-          </a:p>
-        </p:txBody>
-      </p:sp>
-      <p:sp>
-        <p:nvSpPr>
-          <p:cNvPr id="12" name="agent chip"/>
-          <p:cNvSpPr txBox="1"/>
-          <p:nvPr/>
-        </p:nvSpPr>
-        <p:spPr>
-          <a:xfrm>
-            <a:off x="3721608" y="3200400"/>
-            <a:ext cx="950976" cy="411480"/>
+            <a:endParaRPr lang="en-US" sz="1000" dirty="0"/>
+          </a:p>
+        </p:txBody>
+      </p:sp>
+      <p:sp>
+        <p:nvSpPr>
+          <p:cNvPr id="13" name="agent chip"/>
+          <p:cNvSpPr txBox="1"/>
+          <p:nvPr/>
+        </p:nvSpPr>
+        <p:spPr>
+          <a:xfrm>
+            <a:off x="2816352" y="3200400"/>
+            <a:ext cx="694944" cy="411480"/>
           </a:xfrm>
           <a:prstGeom prst="roundRect">
             <a:avLst>
@@ -6738,27 +8740,27 @@
               <a:buNone/>
             </a:pPr>
             <a:r>
-              <a:rPr lang="en-US" sz="1100" b="1" dirty="0">
+              <a:rPr lang="en-US" sz="1000" b="1" dirty="0">
                 <a:solidFill>
                   <a:schemeClr val="bg1"/>
                 </a:solidFill>
               </a:rPr>
               <a:t>Matching</a:t>
             </a:r>
-            <a:endParaRPr lang="en-US" sz="1100" dirty="0"/>
-          </a:p>
-        </p:txBody>
-      </p:sp>
-      <p:sp>
-        <p:nvSpPr>
-          <p:cNvPr id="13" name="agent chip"/>
-          <p:cNvSpPr txBox="1"/>
-          <p:nvPr/>
-        </p:nvSpPr>
-        <p:spPr>
-          <a:xfrm>
-            <a:off x="4764024" y="3200400"/>
-            <a:ext cx="950976" cy="411480"/>
+            <a:endParaRPr lang="en-US" sz="1000" dirty="0"/>
+          </a:p>
+        </p:txBody>
+      </p:sp>
+      <p:sp>
+        <p:nvSpPr>
+          <p:cNvPr id="14" name="agent chip"/>
+          <p:cNvSpPr txBox="1"/>
+          <p:nvPr/>
+        </p:nvSpPr>
+        <p:spPr>
+          <a:xfrm>
+            <a:off x="4297680" y="3200400"/>
+            <a:ext cx="694944" cy="411480"/>
           </a:xfrm>
           <a:prstGeom prst="roundRect">
             <a:avLst>
@@ -6778,20 +8780,100 @@
               <a:buNone/>
             </a:pPr>
             <a:r>
-              <a:rPr lang="en-US" sz="1100" b="1" dirty="0">
+              <a:rPr lang="en-US" sz="1000" b="1" dirty="0">
                 <a:solidFill>
                   <a:schemeClr val="bg1"/>
                 </a:solidFill>
               </a:rPr>
               <a:t>Decision</a:t>
             </a:r>
-            <a:endParaRPr lang="en-US" sz="1100" dirty="0"/>
-          </a:p>
-        </p:txBody>
-      </p:sp>
-      <p:sp>
-        <p:nvSpPr>
-          <p:cNvPr id="14" name="layer data"/>
+            <a:endParaRPr lang="en-US" sz="1000" dirty="0"/>
+          </a:p>
+        </p:txBody>
+      </p:sp>
+      <p:sp>
+        <p:nvSpPr>
+          <p:cNvPr id="15" name="agent chip"/>
+          <p:cNvSpPr txBox="1"/>
+          <p:nvPr/>
+        </p:nvSpPr>
+        <p:spPr>
+          <a:xfrm>
+            <a:off x="3557016" y="3200400"/>
+            <a:ext cx="694944" cy="411480"/>
+          </a:xfrm>
+          <a:prstGeom prst="roundRect">
+            <a:avLst>
+              <a:gd name="adj" fmla="val 13333"/>
+            </a:avLst>
+          </a:prstGeom>
+          <a:solidFill>
+            <a:schemeClr val="accent1"/>
+          </a:solidFill>
+          <a:ln/>
+        </p:spPr>
+        <p:txBody>
+          <a:bodyPr wrap="square" lIns="254" tIns="254" rIns="254" bIns="254" rtlCol="0" anchor="ctr"/>
+          <a:lstStyle/>
+          <a:p>
+            <a:pPr algn="ctr" indent="0" marL="0">
+              <a:buNone/>
+            </a:pPr>
+            <a:r>
+              <a:rPr lang="en-US" sz="1000" b="1" dirty="0">
+                <a:solidFill>
+                  <a:schemeClr val="bg1"/>
+                </a:solidFill>
+              </a:rPr>
+              <a:t>Fraud</a:t>
+            </a:r>
+            <a:endParaRPr lang="en-US" sz="1000" dirty="0"/>
+          </a:p>
+        </p:txBody>
+      </p:sp>
+      <p:sp>
+        <p:nvSpPr>
+          <p:cNvPr id="16" name="agent chip"/>
+          <p:cNvSpPr txBox="1"/>
+          <p:nvPr/>
+        </p:nvSpPr>
+        <p:spPr>
+          <a:xfrm>
+            <a:off x="5038344" y="3200400"/>
+            <a:ext cx="694944" cy="411480"/>
+          </a:xfrm>
+          <a:prstGeom prst="roundRect">
+            <a:avLst>
+              <a:gd name="adj" fmla="val 13333"/>
+            </a:avLst>
+          </a:prstGeom>
+          <a:solidFill>
+            <a:schemeClr val="accent1"/>
+          </a:solidFill>
+          <a:ln/>
+        </p:spPr>
+        <p:txBody>
+          <a:bodyPr wrap="square" lIns="254" tIns="254" rIns="254" bIns="254" rtlCol="0" anchor="ctr"/>
+          <a:lstStyle/>
+          <a:p>
+            <a:pPr algn="ctr" indent="0" marL="0">
+              <a:buNone/>
+            </a:pPr>
+            <a:r>
+              <a:rPr lang="en-US" sz="1000" b="1" dirty="0">
+                <a:solidFill>
+                  <a:schemeClr val="bg1"/>
+                </a:solidFill>
+              </a:rPr>
+              <a:t>Human</a:t>
+            </a:r>
+            <a:endParaRPr lang="en-US" sz="1000" dirty="0"/>
+          </a:p>
+        </p:txBody>
+      </p:sp>
+      <p:sp>
+        <p:nvSpPr>
+          <p:cNvPr id="17" name="layer data"/>
           <p:cNvSpPr/>
           <p:nvPr/>
         </p:nvSpPr>
@@ -6813,7 +8895,7 @@
       </p:sp>
       <p:sp>
         <p:nvSpPr>
-          <p:cNvPr id="15" name="Text 13"/>
+          <p:cNvPr id="18" name="Text 13"/>
           <p:cNvSpPr txBox="1"/>
           <p:nvPr/>
         </p:nvSpPr>
@@ -6855,7 +8937,7 @@
                   <a:schemeClr val="tx1"/>
                 </a:solidFill>
               </a:rPr>
-              <a:t>PO DB, GRN DB, vendor master, duplicate registry, rules</a:t>
+              <a:t>PO DB, GRN DB, vendor master, duplicate registry, vendor memory, rules</a:t>
             </a:r>
             <a:endParaRPr lang="en-US" sz="1400" dirty="0"/>
           </a:p>
@@ -6863,7 +8945,7 @@
       </p:sp>
       <p:sp>
         <p:nvSpPr>
-          <p:cNvPr id="16" name="layer llm"/>
+          <p:cNvPr id="19" name="layer llm"/>
           <p:cNvSpPr/>
           <p:nvPr/>
         </p:nvSpPr>
@@ -6885,7 +8967,7 @@
       </p:sp>
       <p:sp>
         <p:nvSpPr>
-          <p:cNvPr id="17" name="Text 15"/>
+          <p:cNvPr id="20" name="Text 15"/>
           <p:cNvSpPr txBox="1"/>
           <p:nvPr/>
         </p:nvSpPr>
@@ -6935,7 +9017,7 @@
       </p:sp>
       <p:sp>
         <p:nvSpPr>
-          <p:cNvPr id="18" name="flow panel"/>
+          <p:cNvPr id="21" name="flow panel"/>
           <p:cNvSpPr/>
           <p:nvPr/>
         </p:nvSpPr>
@@ -6957,7 +9039,7 @@
       </p:sp>
       <p:sp>
         <p:nvSpPr>
-          <p:cNvPr id="19" name="Text 17"/>
+          <p:cNvPr id="22" name="Text 17"/>
           <p:cNvSpPr txBox="1"/>
           <p:nvPr/>
         </p:nvSpPr>
@@ -6993,7 +9075,7 @@
       </p:sp>
       <p:sp>
         <p:nvSpPr>
-          <p:cNvPr id="20" name="Text 18"/>
+          <p:cNvPr id="23" name="Text 18"/>
           <p:cNvSpPr txBox="1"/>
           <p:nvPr/>
         </p:nvSpPr>
@@ -7026,7 +9108,7 @@
                   <a:schemeClr val="tx1"/>
                 </a:solidFill>
               </a:rPr>
-              <a:t>Batch enters the UI</a:t>
+              <a:t>Batch or PDF enters</a:t>
             </a:r>
             <a:endParaRPr lang="en-US" sz="1400" dirty="0"/>
           </a:p>
@@ -7045,7 +9127,7 @@
                   <a:schemeClr val="tx1"/>
                 </a:solidFill>
               </a:rPr>
-              <a:t>Graph passes shared state</a:t>
+              <a:t>Graph shares state</a:t>
             </a:r>
             <a:endParaRPr lang="en-US" sz="1400" dirty="0"/>
           </a:p>
@@ -7064,7 +9146,7 @@
                   <a:schemeClr val="tx1"/>
                 </a:solidFill>
               </a:rPr>
-              <a:t>Agents call tools and data</a:t>
+              <a:t>Agents use tools and memory</a:t>
             </a:r>
             <a:endParaRPr lang="en-US" sz="1400" dirty="0"/>
           </a:p>
@@ -7083,15 +9165,34 @@
                   <a:schemeClr val="tx1"/>
                 </a:solidFill>
               </a:rPr>
-              <a:t>Decision returns to the UI</a:t>
+              <a:t>Escalations pause for a human</a:t>
             </a:r>
             <a:endParaRPr lang="en-US" sz="1400" dirty="0"/>
           </a:p>
-        </p:txBody>
-      </p:sp>
-      <p:sp>
-        <p:nvSpPr>
-          <p:cNvPr id="25" name="Slide Number Placeholder 0"/>
+          <a:p>
+            <a:pPr marL="342900" indent="-342900">
+              <a:spcAft>
+                <a:spcPts val="1000"/>
+              </a:spcAft>
+              <a:buSzPct val="100000"/>
+              <a:buFont typeface="+mj-lt"/>
+              <a:buAutoNum type="arabicPeriod" startAt="1"/>
+            </a:pPr>
+            <a:r>
+              <a:rPr lang="en-US" sz="1400" dirty="0">
+                <a:solidFill>
+                  <a:schemeClr val="tx1"/>
+                </a:solidFill>
+              </a:rPr>
+              <a:t>Decision goes to the UI</a:t>
+            </a:r>
+            <a:endParaRPr lang="en-US" sz="1400" dirty="0"/>
+          </a:p>
+        </p:txBody>
+      </p:sp>
+      <p:sp>
+        <p:nvSpPr>
+          <p:cNvPr id="24" name="Slide Number Placeholder 0"/>
           <p:cNvSpPr>
             <a:spLocks noGrp="1"/>
           </p:cNvSpPr>
@@ -7147,7 +9248,7 @@
   <p:cSld name="Slide 7">
     <p:spTree>
       <p:nvGrpSpPr>
-        <p:cNvPr id="1" name=""/>
+        <p:cNvPr id="2" name=""/>
         <p:cNvGrpSpPr/>
         <p:nvPr/>
       </p:nvGrpSpPr>
@@ -7161,7 +9262,7 @@
       </p:grpSpPr>
       <p:sp>
         <p:nvSpPr>
-          <p:cNvPr id="2" name="Text 0"/>
+          <p:cNvPr id="3" name="Text 0"/>
           <p:cNvSpPr/>
           <p:nvPr>
             <p:ph idx="100" type="title" hasCustomPrompt="1"/>
@@ -7199,7 +9300,7 @@
       </p:sp>
       <p:sp>
         <p:nvSpPr>
-          <p:cNvPr id="3" name="step card"/>
+          <p:cNvPr id="4" name="step card"/>
           <p:cNvSpPr/>
           <p:nvPr/>
         </p:nvSpPr>
@@ -7221,7 +9322,7 @@
       </p:sp>
       <p:sp>
         <p:nvSpPr>
-          <p:cNvPr id="4" name="badge"/>
+          <p:cNvPr id="5" name="badge"/>
           <p:cNvSpPr/>
           <p:nvPr/>
         </p:nvSpPr>
@@ -7241,7 +9342,7 @@
       </p:sp>
       <p:sp>
         <p:nvSpPr>
-          <p:cNvPr id="5" name="Text 3"/>
+          <p:cNvPr id="6" name="Text 3"/>
           <p:cNvSpPr txBox="1"/>
           <p:nvPr/>
         </p:nvSpPr>
@@ -7277,7 +9378,7 @@
       </p:sp>
       <p:sp>
         <p:nvSpPr>
-          <p:cNvPr id="6" name="Text 4"/>
+          <p:cNvPr id="7" name="Text 4"/>
           <p:cNvSpPr txBox="1"/>
           <p:nvPr/>
         </p:nvSpPr>
@@ -7313,7 +9414,7 @@
       </p:sp>
       <p:sp>
         <p:nvSpPr>
-          <p:cNvPr id="7" name="Text 5"/>
+          <p:cNvPr id="8" name="Text 5"/>
           <p:cNvSpPr txBox="1"/>
           <p:nvPr/>
         </p:nvSpPr>
@@ -7341,7 +9442,7 @@
                   <a:schemeClr val="tx1"/>
                 </a:solidFill>
               </a:rPr>
-              <a:t>24 synthetic invoices, 8 with seeded errors</a:t>
+              <a:t>24 synthetic invoices, 8 seeded errors, 3 of them fraud</a:t>
             </a:r>
             <a:endParaRPr lang="en-US" sz="1200" dirty="0"/>
           </a:p>
@@ -7349,7 +9450,7 @@
       </p:sp>
       <p:sp>
         <p:nvSpPr>
-          <p:cNvPr id="8" name="step card"/>
+          <p:cNvPr id="9" name="step card"/>
           <p:cNvSpPr/>
           <p:nvPr/>
         </p:nvSpPr>
@@ -7371,7 +9472,7 @@
       </p:sp>
       <p:sp>
         <p:nvSpPr>
-          <p:cNvPr id="9" name="badge"/>
+          <p:cNvPr id="10" name="badge"/>
           <p:cNvSpPr/>
           <p:nvPr/>
         </p:nvSpPr>
@@ -7391,7 +9492,7 @@
       </p:sp>
       <p:sp>
         <p:nvSpPr>
-          <p:cNvPr id="10" name="Text 8"/>
+          <p:cNvPr id="11" name="Text 8"/>
           <p:cNvSpPr txBox="1"/>
           <p:nvPr/>
         </p:nvSpPr>
@@ -7427,7 +9528,7 @@
       </p:sp>
       <p:sp>
         <p:nvSpPr>
-          <p:cNvPr id="11" name="Text 9"/>
+          <p:cNvPr id="12" name="Text 9"/>
           <p:cNvSpPr txBox="1"/>
           <p:nvPr/>
         </p:nvSpPr>
@@ -7463,7 +9564,7 @@
       </p:sp>
       <p:sp>
         <p:nvSpPr>
-          <p:cNvPr id="12" name="Text 10"/>
+          <p:cNvPr id="13" name="Text 10"/>
           <p:cNvSpPr txBox="1"/>
           <p:nvPr/>
         </p:nvSpPr>
@@ -7499,7 +9600,7 @@
       </p:sp>
       <p:sp>
         <p:nvSpPr>
-          <p:cNvPr id="13" name="step card"/>
+          <p:cNvPr id="14" name="step card"/>
           <p:cNvSpPr/>
           <p:nvPr/>
         </p:nvSpPr>
@@ -7521,7 +9622,7 @@
       </p:sp>
       <p:sp>
         <p:nvSpPr>
-          <p:cNvPr id="14" name="badge"/>
+          <p:cNvPr id="15" name="badge"/>
           <p:cNvSpPr/>
           <p:nvPr/>
         </p:nvSpPr>
@@ -7541,7 +9642,7 @@
       </p:sp>
       <p:sp>
         <p:nvSpPr>
-          <p:cNvPr id="15" name="Text 13"/>
+          <p:cNvPr id="16" name="Text 13"/>
           <p:cNvSpPr txBox="1"/>
           <p:nvPr/>
         </p:nvSpPr>
@@ -7577,7 +9678,7 @@
       </p:sp>
       <p:sp>
         <p:nvSpPr>
-          <p:cNvPr id="16" name="Text 14"/>
+          <p:cNvPr id="17" name="Text 14"/>
           <p:cNvSpPr txBox="1"/>
           <p:nvPr/>
         </p:nvSpPr>
@@ -7605,7 +9706,7 @@
                   <a:schemeClr val="tx2"/>
                 </a:solidFill>
               </a:rPr>
-              <a:t>Review decisions</a:t>
+              <a:t>Review queue</a:t>
             </a:r>
             <a:endParaRPr lang="en-US" sz="1400" dirty="0"/>
           </a:p>
@@ -7613,7 +9714,7 @@
       </p:sp>
       <p:sp>
         <p:nvSpPr>
-          <p:cNvPr id="17" name="Text 15"/>
+          <p:cNvPr id="18" name="Text 15"/>
           <p:cNvSpPr txBox="1"/>
           <p:nvPr/>
         </p:nvSpPr>
@@ -7641,7 +9742,7 @@
                   <a:schemeClr val="tx1"/>
                 </a:solidFill>
               </a:rPr>
-              <a:t>Approved, held or escalated, colour-coded</a:t>
+              <a:t>Approve, hold or reject paused invoices</a:t>
             </a:r>
             <a:endParaRPr lang="en-US" sz="1200" dirty="0"/>
           </a:p>
@@ -7649,7 +9750,7 @@
       </p:sp>
       <p:sp>
         <p:nvSpPr>
-          <p:cNvPr id="18" name="step card"/>
+          <p:cNvPr id="19" name="step card"/>
           <p:cNvSpPr/>
           <p:nvPr/>
         </p:nvSpPr>
@@ -7671,7 +9772,7 @@
       </p:sp>
       <p:sp>
         <p:nvSpPr>
-          <p:cNvPr id="19" name="badge"/>
+          <p:cNvPr id="20" name="badge"/>
           <p:cNvSpPr/>
           <p:nvPr/>
         </p:nvSpPr>
@@ -7691,7 +9792,7 @@
       </p:sp>
       <p:sp>
         <p:nvSpPr>
-          <p:cNvPr id="20" name="Text 18"/>
+          <p:cNvPr id="21" name="Text 18"/>
           <p:cNvSpPr txBox="1"/>
           <p:nvPr/>
         </p:nvSpPr>
@@ -7727,7 +9828,7 @@
       </p:sp>
       <p:sp>
         <p:nvSpPr>
-          <p:cNvPr id="21" name="Text 19"/>
+          <p:cNvPr id="22" name="Text 19"/>
           <p:cNvSpPr txBox="1"/>
           <p:nvPr/>
         </p:nvSpPr>
@@ -7755,7 +9856,7 @@
                   <a:schemeClr val="tx2"/>
                 </a:solidFill>
               </a:rPr>
-              <a:t>Inspect</a:t>
+              <a:t>Upload PDF</a:t>
             </a:r>
             <a:endParaRPr lang="en-US" sz="1400" dirty="0"/>
           </a:p>
@@ -7763,7 +9864,7 @@
       </p:sp>
       <p:sp>
         <p:nvSpPr>
-          <p:cNvPr id="22" name="Text 20"/>
+          <p:cNvPr id="23" name="Text 20"/>
           <p:cNvSpPr txBox="1"/>
           <p:nvPr/>
         </p:nvSpPr>
@@ -7791,7 +9892,7 @@
                   <a:schemeClr val="tx1"/>
                 </a:solidFill>
               </a:rPr>
-              <a:t>Raw invoice, trace, reason and metrics</a:t>
+              <a:t>Run the agents on a PDF invoice</a:t>
             </a:r>
             <a:endParaRPr lang="en-US" sz="1200" dirty="0"/>
           </a:p>
@@ -7799,7 +9900,7 @@
       </p:sp>
       <p:sp>
         <p:nvSpPr>
-          <p:cNvPr id="23" name="Text 21"/>
+          <p:cNvPr id="24" name="Text 21"/>
           <p:cNvSpPr txBox="1"/>
           <p:nvPr/>
         </p:nvSpPr>
@@ -7835,7 +9936,7 @@
       </p:sp>
       <p:sp>
         <p:nvSpPr>
-          <p:cNvPr id="24" name="trace box"/>
+          <p:cNvPr id="25" name="trace box"/>
           <p:cNvSpPr/>
           <p:nvPr/>
         </p:nvSpPr>
@@ -7857,7 +9958,7 @@
       </p:sp>
       <p:sp>
         <p:nvSpPr>
-          <p:cNvPr id="25" name="Text 23"/>
+          <p:cNvPr id="26" name="Text 23"/>
           <p:cNvSpPr txBox="1"/>
           <p:nvPr/>
         </p:nvSpPr>
@@ -7891,7 +9992,7 @@
                 <a:ea typeface="Courier New" pitchFamily="34" charset="-122"/>
                 <a:cs typeface="Courier New" pitchFamily="34" charset="-120"/>
               </a:rPr>
-              <a:t>Extraction Agent: attempt 1 via fast parser: INV-7015 | total 34.00</a:t>
+              <a:t>Extraction Agent: attempt 1 via fast parser: INV-7009 | total 1.00</a:t>
             </a:r>
             <a:endParaRPr lang="en-US" sz="1100" dirty="0"/>
           </a:p>
@@ -7931,7 +10032,7 @@
                 <a:ea typeface="Courier New" pitchFamily="34" charset="-122"/>
                 <a:cs typeface="Courier New" pitchFamily="34" charset="-120"/>
               </a:rPr>
-              <a:t>Extraction Agent: attempt 2 via robust parser: INV-7015 | total 34,673.17</a:t>
+              <a:t>Extraction Agent: attempt 2 via robust parser: INV-7009 | total 1,734,135.13</a:t>
             </a:r>
             <a:endParaRPr lang="en-US" sz="1100" dirty="0"/>
           </a:p>
@@ -7951,7 +10052,7 @@
                 <a:ea typeface="Courier New" pitchFamily="34" charset="-122"/>
                 <a:cs typeface="Courier New" pitchFamily="34" charset="-120"/>
               </a:rPr>
-              <a:t>Matching Agent: 3-way match done -&gt; 1 issue(s): PRICE_MISMATCH</a:t>
+              <a:t>Fraud Agent: AMOUNT_SPIKE (8.1x vendor's largest invoice); risk score 40/100</a:t>
             </a:r>
             <a:endParaRPr lang="en-US" sz="1100" dirty="0"/>
           </a:p>
@@ -7971,7 +10072,7 @@
                 <a:ea typeface="Courier New" pitchFamily="34" charset="-122"/>
                 <a:cs typeface="Courier New" pitchFamily="34" charset="-120"/>
               </a:rPr>
-              <a:t>Decision Agent: HOLD (low-value mismatch: return to vendor for correction)</a:t>
+              <a:t>Decision Agent: ESCALATED (fraud risk score 40 &gt;= 40) -&gt; Review queue</a:t>
             </a:r>
             <a:endParaRPr lang="en-US" sz="1100" dirty="0"/>
           </a:p>
@@ -7979,7 +10080,7 @@
       </p:sp>
       <p:sp>
         <p:nvSpPr>
-          <p:cNvPr id="25" name="Slide Number Placeholder 0"/>
+          <p:cNvPr id="27" name="Slide Number Placeholder 0"/>
           <p:cNvSpPr>
             <a:spLocks noGrp="1"/>
           </p:cNvSpPr>
@@ -8035,7 +10136,7 @@
   <p:cSld name="Slide 8">
     <p:spTree>
       <p:nvGrpSpPr>
-        <p:cNvPr id="1" name=""/>
+        <p:cNvPr id="2" name=""/>
         <p:cNvGrpSpPr/>
         <p:nvPr/>
       </p:nvGrpSpPr>
@@ -8049,7 +10150,7 @@
       </p:grpSpPr>
       <p:sp>
         <p:nvSpPr>
-          <p:cNvPr id="2" name="Text 0"/>
+          <p:cNvPr id="3" name="Text 0"/>
           <p:cNvSpPr/>
           <p:nvPr>
             <p:ph idx="100" type="title" hasCustomPrompt="1"/>
@@ -8087,7 +10188,7 @@
       </p:sp>
       <p:sp>
         <p:nvSpPr>
-          <p:cNvPr id="3" name="stat card"/>
+          <p:cNvPr id="4" name="stat card"/>
           <p:cNvSpPr/>
           <p:nvPr/>
         </p:nvSpPr>
@@ -8109,7 +10210,7 @@
       </p:sp>
       <p:sp>
         <p:nvSpPr>
-          <p:cNvPr id="4" name="Text 2"/>
+          <p:cNvPr id="5" name="Text 2"/>
           <p:cNvSpPr txBox="1"/>
           <p:nvPr/>
         </p:nvSpPr>
@@ -8145,7 +10246,7 @@
       </p:sp>
       <p:sp>
         <p:nvSpPr>
-          <p:cNvPr id="5" name="Text 3"/>
+          <p:cNvPr id="6" name="Text 3"/>
           <p:cNvSpPr txBox="1"/>
           <p:nvPr/>
         </p:nvSpPr>
@@ -8181,7 +10282,7 @@
       </p:sp>
       <p:sp>
         <p:nvSpPr>
-          <p:cNvPr id="6" name="stat card"/>
+          <p:cNvPr id="7" name="stat card"/>
           <p:cNvSpPr/>
           <p:nvPr/>
         </p:nvSpPr>
@@ -8203,7 +10304,7 @@
       </p:sp>
       <p:sp>
         <p:nvSpPr>
-          <p:cNvPr id="7" name="Text 5"/>
+          <p:cNvPr id="8" name="Text 5"/>
           <p:cNvSpPr txBox="1"/>
           <p:nvPr/>
         </p:nvSpPr>
@@ -8231,7 +10332,7 @@
                   <a:schemeClr val="accent1"/>
                 </a:solidFill>
               </a:rPr>
-              <a:t>8/8</a:t>
+              <a:t>3/3</a:t>
             </a:r>
             <a:endParaRPr lang="en-US" sz="4000" dirty="0"/>
           </a:p>
@@ -8239,7 +10340,7 @@
       </p:sp>
       <p:sp>
         <p:nvSpPr>
-          <p:cNvPr id="8" name="Text 6"/>
+          <p:cNvPr id="9" name="Text 6"/>
           <p:cNvSpPr txBox="1"/>
           <p:nvPr/>
         </p:nvSpPr>
@@ -8267,7 +10368,7 @@
                   <a:schemeClr val="tx1"/>
                 </a:solidFill>
               </a:rPr>
-              <a:t>issue types identified correctly</a:t>
+              <a:t>fraud cases escalated</a:t>
             </a:r>
             <a:endParaRPr lang="en-US" sz="1400" dirty="0"/>
           </a:p>
@@ -8275,7 +10376,7 @@
       </p:sp>
       <p:sp>
         <p:nvSpPr>
-          <p:cNvPr id="9" name="stat card"/>
+          <p:cNvPr id="10" name="stat card"/>
           <p:cNvSpPr/>
           <p:nvPr/>
         </p:nvSpPr>
@@ -8297,7 +10398,7 @@
       </p:sp>
       <p:sp>
         <p:nvSpPr>
-          <p:cNvPr id="10" name="Text 8"/>
+          <p:cNvPr id="11" name="Text 8"/>
           <p:cNvSpPr txBox="1"/>
           <p:nvPr/>
         </p:nvSpPr>
@@ -8333,7 +10434,7 @@
       </p:sp>
       <p:sp>
         <p:nvSpPr>
-          <p:cNvPr id="11" name="Text 9"/>
+          <p:cNvPr id="12" name="Text 9"/>
           <p:cNvSpPr txBox="1"/>
           <p:nvPr/>
         </p:nvSpPr>
@@ -8369,7 +10470,7 @@
       </p:sp>
       <p:sp>
         <p:nvSpPr>
-          <p:cNvPr id="12" name="stat card"/>
+          <p:cNvPr id="13" name="stat card"/>
           <p:cNvSpPr/>
           <p:nvPr/>
         </p:nvSpPr>
@@ -8391,7 +10492,7 @@
       </p:sp>
       <p:sp>
         <p:nvSpPr>
-          <p:cNvPr id="13" name="Text 11"/>
+          <p:cNvPr id="14" name="Text 11"/>
           <p:cNvSpPr txBox="1"/>
           <p:nvPr/>
         </p:nvSpPr>
@@ -8419,7 +10520,7 @@
                   <a:schemeClr val="accent1"/>
                 </a:solidFill>
               </a:rPr>
-              <a:t>1.77L</a:t>
+              <a:t>99.98%</a:t>
             </a:r>
             <a:endParaRPr lang="en-US" sz="4000" dirty="0"/>
           </a:p>
@@ -8427,7 +10528,7 @@
       </p:sp>
       <p:sp>
         <p:nvSpPr>
-          <p:cNvPr id="14" name="Text 12"/>
+          <p:cNvPr id="15" name="Text 12"/>
           <p:cNvSpPr txBox="1"/>
           <p:nvPr/>
         </p:nvSpPr>
@@ -8455,7 +10556,7 @@
                   <a:schemeClr val="tx1"/>
                 </a:solidFill>
               </a:rPr>
-              <a:t>INR at risk flagged, equal to the seeded total</a:t>
+              <a:t>decided correctly across 37,200 generated invoices</a:t>
             </a:r>
             <a:endParaRPr lang="en-US" sz="1400" dirty="0"/>
           </a:p>
@@ -8463,7 +10564,7 @@
       </p:sp>
       <p:sp>
         <p:nvSpPr>
-          <p:cNvPr id="15" name="notes panel"/>
+          <p:cNvPr id="16" name="notes panel"/>
           <p:cNvSpPr/>
           <p:nvPr/>
         </p:nvSpPr>
@@ -8485,7 +10586,7 @@
       </p:sp>
       <p:sp>
         <p:nvSpPr>
-          <p:cNvPr id="16" name="Text 14"/>
+          <p:cNvPr id="17" name="Text 14"/>
           <p:cNvSpPr txBox="1"/>
           <p:nvPr/>
         </p:nvSpPr>
@@ -8517,7 +10618,7 @@
                   <a:schemeClr val="tx1"/>
                 </a:solidFill>
               </a:rPr>
-              <a:t>Measured on 24 synthetic invoices: 8 seeded errors and 16 clean.</a:t>
+              <a:t>Default batch: 24 invoices, 8 seeded errors (3 fraud) and 16 clean; INR 0.99L at risk flagged, equal to the seeded total.</a:t>
             </a:r>
             <a:endParaRPr lang="en-US" sz="1400" dirty="0"/>
           </a:p>
@@ -8535,7 +10636,7 @@
                   <a:schemeClr val="tx1"/>
                 </a:solidFill>
               </a:rPr>
-              <a:t>The Critic loop caught misread amounts; the retry fixed them before matching.</a:t>
+              <a:t>The Critic loop fixed misread amounts before matching. 15 automated tests pass.</a:t>
             </a:r>
             <a:endParaRPr lang="en-US" sz="1400" dirty="0"/>
           </a:p>
@@ -8561,7 +10662,7 @@
       </p:sp>
       <p:sp>
         <p:nvSpPr>
-          <p:cNvPr id="25" name="Slide Number Placeholder 0"/>
+          <p:cNvPr id="18" name="Slide Number Placeholder 0"/>
           <p:cNvSpPr>
             <a:spLocks noGrp="1"/>
           </p:cNvSpPr>
@@ -8617,7 +10718,7 @@
   <p:cSld name="Slide 9">
     <p:spTree>
       <p:nvGrpSpPr>
-        <p:cNvPr id="1" name=""/>
+        <p:cNvPr id="2" name=""/>
         <p:cNvGrpSpPr/>
         <p:nvPr/>
       </p:nvGrpSpPr>
@@ -8631,7 +10732,7 @@
       </p:grpSpPr>
       <p:sp>
         <p:nvSpPr>
-          <p:cNvPr id="2" name="Text 0"/>
+          <p:cNvPr id="3" name="Text 0"/>
           <p:cNvSpPr/>
           <p:nvPr>
             <p:ph idx="100" type="title" hasCustomPrompt="1"/>
@@ -8669,7 +10770,7 @@
       </p:sp>
       <p:sp>
         <p:nvSpPr>
-          <p:cNvPr id="3" name="panel"/>
+          <p:cNvPr id="4" name="panel"/>
           <p:cNvSpPr/>
           <p:nvPr/>
         </p:nvSpPr>
@@ -8691,7 +10792,7 @@
       </p:sp>
       <p:sp>
         <p:nvSpPr>
-          <p:cNvPr id="4" name="Text 2"/>
+          <p:cNvPr id="5" name="Text 2"/>
           <p:cNvSpPr txBox="1"/>
           <p:nvPr/>
         </p:nvSpPr>
@@ -8727,7 +10828,7 @@
       </p:sp>
       <p:sp>
         <p:nvSpPr>
-          <p:cNvPr id="5" name="badge"/>
+          <p:cNvPr id="6" name="badge"/>
           <p:cNvSpPr/>
           <p:nvPr/>
         </p:nvSpPr>
@@ -8747,7 +10848,7 @@
       </p:sp>
       <p:pic>
         <p:nvPicPr>
-          <p:cNvPr id="6" name="Image 0" descr="preencoded.png">    </p:cNvPr>
+          <p:cNvPr id="7" name="Image 0" descr="preencoded.png">    </p:cNvPr>
           <p:cNvPicPr>
             <a:picLocks noChangeAspect="1"/>
           </p:cNvPicPr>
@@ -8771,7 +10872,7 @@
       </p:pic>
       <p:sp>
         <p:nvSpPr>
-          <p:cNvPr id="7" name="Text 4"/>
+          <p:cNvPr id="8" name="Text 4"/>
           <p:cNvSpPr txBox="1"/>
           <p:nvPr/>
         </p:nvSpPr>
@@ -8807,7 +10908,7 @@
       </p:sp>
       <p:sp>
         <p:nvSpPr>
-          <p:cNvPr id="8" name="badge"/>
+          <p:cNvPr id="9" name="badge"/>
           <p:cNvSpPr/>
           <p:nvPr/>
         </p:nvSpPr>
@@ -8827,7 +10928,7 @@
       </p:sp>
       <p:pic>
         <p:nvPicPr>
-          <p:cNvPr id="9" name="Image 1" descr="preencoded.png">    </p:cNvPr>
+          <p:cNvPr id="10" name="Image 1" descr="preencoded.png">    </p:cNvPr>
           <p:cNvPicPr>
             <a:picLocks noChangeAspect="1"/>
           </p:cNvPicPr>
@@ -8851,7 +10952,7 @@
       </p:pic>
       <p:sp>
         <p:nvSpPr>
-          <p:cNvPr id="10" name="Text 6"/>
+          <p:cNvPr id="11" name="Text 6"/>
           <p:cNvSpPr txBox="1"/>
           <p:nvPr/>
         </p:nvSpPr>
@@ -8887,7 +10988,7 @@
       </p:sp>
       <p:sp>
         <p:nvSpPr>
-          <p:cNvPr id="11" name="badge"/>
+          <p:cNvPr id="12" name="badge"/>
           <p:cNvSpPr/>
           <p:nvPr/>
         </p:nvSpPr>
@@ -8907,7 +11008,7 @@
       </p:sp>
       <p:pic>
         <p:nvPicPr>
-          <p:cNvPr id="12" name="Image 2" descr="preencoded.png">    </p:cNvPr>
+          <p:cNvPr id="13" name="Image 2" descr="preencoded.png">    </p:cNvPr>
           <p:cNvPicPr>
             <a:picLocks noChangeAspect="1"/>
           </p:cNvPicPr>
@@ -8931,7 +11032,7 @@
       </p:pic>
       <p:sp>
         <p:nvSpPr>
-          <p:cNvPr id="13" name="Text 8"/>
+          <p:cNvPr id="14" name="Text 8"/>
           <p:cNvSpPr txBox="1"/>
           <p:nvPr/>
         </p:nvSpPr>
@@ -8959,7 +11060,7 @@
                   <a:schemeClr val="tx1"/>
                 </a:solidFill>
               </a:rPr>
-              <a:t>No OCR, ERP link or user login</a:t>
+              <a:t>No OCR for scanned PDFs, no ERP link or login</a:t>
             </a:r>
             <a:endParaRPr lang="en-US" sz="1400" dirty="0"/>
           </a:p>
@@ -8967,7 +11068,7 @@
       </p:sp>
       <p:sp>
         <p:nvSpPr>
-          <p:cNvPr id="14" name="badge"/>
+          <p:cNvPr id="15" name="badge"/>
           <p:cNvSpPr/>
           <p:nvPr/>
         </p:nvSpPr>
@@ -8987,7 +11088,7 @@
       </p:sp>
       <p:pic>
         <p:nvPicPr>
-          <p:cNvPr id="15" name="Image 3" descr="preencoded.png">    </p:cNvPr>
+          <p:cNvPr id="16" name="Image 3" descr="preencoded.png">    </p:cNvPr>
           <p:cNvPicPr>
             <a:picLocks noChangeAspect="1"/>
           </p:cNvPicPr>
@@ -9011,7 +11112,7 @@
       </p:pic>
       <p:sp>
         <p:nvSpPr>
-          <p:cNvPr id="16" name="Text 10"/>
+          <p:cNvPr id="17" name="Text 10"/>
           <p:cNvSpPr txBox="1"/>
           <p:nvPr/>
         </p:nvSpPr>
@@ -9047,7 +11148,7 @@
       </p:sp>
       <p:sp>
         <p:nvSpPr>
-          <p:cNvPr id="17" name="panel"/>
+          <p:cNvPr id="18" name="panel"/>
           <p:cNvSpPr/>
           <p:nvPr/>
         </p:nvSpPr>
@@ -9069,7 +11170,7 @@
       </p:sp>
       <p:sp>
         <p:nvSpPr>
-          <p:cNvPr id="18" name="Text 12"/>
+          <p:cNvPr id="19" name="Text 12"/>
           <p:cNvSpPr txBox="1"/>
           <p:nvPr/>
         </p:nvSpPr>
@@ -9105,7 +11206,7 @@
       </p:sp>
       <p:sp>
         <p:nvSpPr>
-          <p:cNvPr id="19" name="badge"/>
+          <p:cNvPr id="20" name="badge"/>
           <p:cNvSpPr/>
           <p:nvPr/>
         </p:nvSpPr>
@@ -9125,7 +11226,7 @@
       </p:sp>
       <p:pic>
         <p:nvPicPr>
-          <p:cNvPr id="20" name="Image 4" descr="preencoded.png">    </p:cNvPr>
+          <p:cNvPr id="21" name="Image 4" descr="preencoded.png">    </p:cNvPr>
           <p:cNvPicPr>
             <a:picLocks noChangeAspect="1"/>
           </p:cNvPicPr>
@@ -9149,7 +11250,7 @@
       </p:pic>
       <p:sp>
         <p:nvSpPr>
-          <p:cNvPr id="21" name="Text 14"/>
+          <p:cNvPr id="22" name="Text 14"/>
           <p:cNvSpPr txBox="1"/>
           <p:nvPr/>
         </p:nvSpPr>
@@ -9185,7 +11286,7 @@
       </p:sp>
       <p:sp>
         <p:nvSpPr>
-          <p:cNvPr id="22" name="badge"/>
+          <p:cNvPr id="23" name="badge"/>
           <p:cNvSpPr/>
           <p:nvPr/>
         </p:nvSpPr>
@@ -9205,7 +11306,7 @@
       </p:sp>
       <p:pic>
         <p:nvPicPr>
-          <p:cNvPr id="23" name="Image 5" descr="preencoded.png">    </p:cNvPr>
+          <p:cNvPr id="24" name="Image 5" descr="preencoded.png">    </p:cNvPr>
           <p:cNvPicPr>
             <a:picLocks noChangeAspect="1"/>
           </p:cNvPicPr>
@@ -9229,7 +11330,7 @@
       </p:pic>
       <p:sp>
         <p:nvSpPr>
-          <p:cNvPr id="24" name="Text 16"/>
+          <p:cNvPr id="25" name="Text 16"/>
           <p:cNvSpPr txBox="1"/>
           <p:nvPr/>
         </p:nvSpPr>
@@ -9265,7 +11366,7 @@
       </p:sp>
       <p:sp>
         <p:nvSpPr>
-          <p:cNvPr id="25" name="badge"/>
+          <p:cNvPr id="26" name="badge"/>
           <p:cNvSpPr/>
           <p:nvPr/>
         </p:nvSpPr>
@@ -9285,7 +11386,7 @@
       </p:sp>
       <p:pic>
         <p:nvPicPr>
-          <p:cNvPr id="26" name="Image 6" descr="preencoded.png">    </p:cNvPr>
+          <p:cNvPr id="27" name="Image 6" descr="preencoded.png">    </p:cNvPr>
           <p:cNvPicPr>
             <a:picLocks noChangeAspect="1"/>
           </p:cNvPicPr>
@@ -9309,7 +11410,7 @@
       </p:pic>
       <p:sp>
         <p:nvSpPr>
-          <p:cNvPr id="27" name="Text 18"/>
+          <p:cNvPr id="28" name="Text 18"/>
           <p:cNvSpPr txBox="1"/>
           <p:nvPr/>
         </p:nvSpPr>
@@ -9345,7 +11446,7 @@
       </p:sp>
       <p:sp>
         <p:nvSpPr>
-          <p:cNvPr id="28" name="badge"/>
+          <p:cNvPr id="29" name="badge"/>
           <p:cNvSpPr/>
           <p:nvPr/>
         </p:nvSpPr>
@@ -9365,7 +11466,7 @@
       </p:sp>
       <p:pic>
         <p:nvPicPr>
-          <p:cNvPr id="29" name="Image 7" descr="preencoded.png">    </p:cNvPr>
+          <p:cNvPr id="30" name="Image 7" descr="preencoded.png">    </p:cNvPr>
           <p:cNvPicPr>
             <a:picLocks noChangeAspect="1"/>
           </p:cNvPicPr>
@@ -9389,7 +11490,7 @@
       </p:pic>
       <p:sp>
         <p:nvSpPr>
-          <p:cNvPr id="30" name="Text 20"/>
+          <p:cNvPr id="31" name="Text 20"/>
           <p:cNvSpPr txBox="1"/>
           <p:nvPr/>
         </p:nvSpPr>
@@ -9417,7 +11518,7 @@
                   <a:schemeClr val="tx1"/>
                 </a:solidFill>
               </a:rPr>
-              <a:t>Vendor fraud pattern detection</a:t>
+              <a:t>Learn fraud weights from reviewer decisions</a:t>
             </a:r>
             <a:endParaRPr lang="en-US" sz="1400" dirty="0"/>
           </a:p>
@@ -9425,7 +11526,7 @@
       </p:sp>
       <p:sp>
         <p:nvSpPr>
-          <p:cNvPr id="31" name="badge"/>
+          <p:cNvPr id="32" name="badge"/>
           <p:cNvSpPr/>
           <p:nvPr/>
         </p:nvSpPr>
@@ -9445,7 +11546,7 @@
       </p:sp>
       <p:pic>
         <p:nvPicPr>
-          <p:cNvPr id="32" name="Image 8" descr="preencoded.png">    </p:cNvPr>
+          <p:cNvPr id="33" name="Image 8" descr="preencoded.png">    </p:cNvPr>
           <p:cNvPicPr>
             <a:picLocks noChangeAspect="1"/>
           </p:cNvPicPr>
@@ -9469,7 +11570,7 @@
       </p:pic>
       <p:sp>
         <p:nvSpPr>
-          <p:cNvPr id="33" name="Text 22"/>
+          <p:cNvPr id="34" name="Text 22"/>
           <p:cNvSpPr txBox="1"/>
           <p:nvPr/>
         </p:nvSpPr>
@@ -9497,7 +11598,7 @@
                   <a:schemeClr val="tx1"/>
                 </a:solidFill>
               </a:rPr>
-              <a:t>Human approval screen and MCP tools</a:t>
+              <a:t>Role-based approvals and MCP tools</a:t>
             </a:r>
             <a:endParaRPr lang="en-US" sz="1400" dirty="0"/>
           </a:p>
@@ -9505,7 +11606,7 @@
       </p:sp>
       <p:sp>
         <p:nvSpPr>
-          <p:cNvPr id="25" name="Slide Number Placeholder 0"/>
+          <p:cNvPr id="35" name="Slide Number Placeholder 0"/>
           <p:cNvSpPr>
             <a:spLocks noGrp="1"/>
           </p:cNvSpPr>

</xml_diff>

<commit_message>
Update report and slides for the latest features
Covers the local-model guardrails (Critic grounding check and second opinion,
Fraud risk note, case summary), the ledger-style interface with new
screenshots, Ollama setup help, and 24 passing tests.

Co-Authored-By: Claude Opus 5.5 <noreply@anthropic.com>
Claude-Session: https://claude.ai/code/session_01PUPfqHi3Xjn2BDBEBK3buH
</commit_message>
<xml_diff>
--- a/docs/FAAISaafalyaSengupta158.pptx
+++ b/docs/FAAISaafalyaSengupta158.pptx
@@ -12,6 +12,8 @@
     <p:sldId id="260" r:id="rId6"/>
     <p:sldId id="266" r:id="rId17"/>
     <p:sldId id="267" r:id="rId18"/>
+    <p:sldId id="268" r:id="rId19"/>
+    <p:sldId id="269" r:id="rId20"/>
     <p:sldId id="261" r:id="rId7"/>
     <p:sldId id="262" r:id="rId8"/>
     <p:sldId id="263" r:id="rId9"/>
@@ -850,6 +852,134 @@
 </p:notes>
 </file>
 
+<file path=ppt/notesSlides/notesSlide13.xml><?xml version="1.0" encoding="utf-8"?>
+<p:notes xmlns:a="http://schemas.openxmlformats.org/drawingml/2006/main" xmlns:r="http://schemas.openxmlformats.org/officeDocument/2006/relationships" xmlns:p="http://schemas.openxmlformats.org/presentationml/2006/main">
+  <p:cSld>
+    <p:spTree>
+      <p:nvGrpSpPr>
+        <p:cNvPr id="1" name=""/>
+        <p:cNvGrpSpPr/>
+        <p:nvPr/>
+      </p:nvGrpSpPr>
+      <p:grpSpPr>
+        <a:xfrm>
+          <a:off x="0" y="0"/>
+          <a:ext cx="0" cy="0"/>
+          <a:chOff x="0" y="0"/>
+          <a:chExt cx="0" cy="0"/>
+        </a:xfrm>
+      </p:grpSpPr>
+      <p:sp>
+        <p:nvSpPr>
+          <p:cNvPr id="2" name="Slide Image Placeholder 1"/>
+          <p:cNvSpPr>
+            <a:spLocks noGrp="1" noRot="1" noChangeAspect="1"/>
+          </p:cNvSpPr>
+          <p:nvPr>
+            <p:ph type="sldImg"/>
+          </p:nvPr>
+        </p:nvSpPr>
+        <p:spPr/>
+      </p:sp>
+      <p:sp>
+        <p:nvSpPr>
+          <p:cNvPr id="3" name="Notes Placeholder 2"/>
+          <p:cNvSpPr>
+            <a:spLocks noGrp="1"/>
+          </p:cNvSpPr>
+          <p:nvPr>
+            <p:ph type="body" idx="1"/>
+          </p:nvPr>
+        </p:nvSpPr>
+        <p:spPr/>
+        <p:txBody>
+          <a:bodyPr/>
+          <a:lstStyle/>
+          <a:p>
+            <a:r>
+              <a:rPr lang="en-US" dirty="0"/>
+              <a:t>The rules decide; the model explains. The local model (Ollama) helps in four places, and each has a hard check behind it. Its extraction must pass the Critic's arithmetic and grounding checks. Its second opinion can cause one more retry but never escalates an invoice on its own. Its risk note and case summary are rejected if they contain any number that is not in the facts, and the rule-based text is shown instead. Without Ollama, the same rule-based texts are used, so the demo always works.</a:t>
+            </a:r>
+          </a:p>
+        </p:txBody>
+      </p:sp>
+    </p:spTree>
+    <p:extLst>
+      <p:ext uri="{BB962C8B-B14F-4D97-AF65-F5344CB8AC3E}">
+        <p14:creationId xmlns:p14="http://schemas.microsoft.com/office/powerpoint/2010/main" val="1024086991"/>
+      </p:ext>
+    </p:extLst>
+  </p:cSld>
+  <p:clrMapOvr>
+    <a:masterClrMapping/>
+  </p:clrMapOvr>
+</p:notes>
+</file>
+
+<file path=ppt/notesSlides/notesSlide14.xml><?xml version="1.0" encoding="utf-8"?>
+<p:notes xmlns:a="http://schemas.openxmlformats.org/drawingml/2006/main" xmlns:r="http://schemas.openxmlformats.org/officeDocument/2006/relationships" xmlns:p="http://schemas.openxmlformats.org/presentationml/2006/main">
+  <p:cSld>
+    <p:spTree>
+      <p:nvGrpSpPr>
+        <p:cNvPr id="1" name=""/>
+        <p:cNvGrpSpPr/>
+        <p:nvPr/>
+      </p:nvGrpSpPr>
+      <p:grpSpPr>
+        <a:xfrm>
+          <a:off x="0" y="0"/>
+          <a:ext cx="0" cy="0"/>
+          <a:chOff x="0" y="0"/>
+          <a:chExt cx="0" cy="0"/>
+        </a:xfrm>
+      </p:grpSpPr>
+      <p:sp>
+        <p:nvSpPr>
+          <p:cNvPr id="2" name="Slide Image Placeholder 1"/>
+          <p:cNvSpPr>
+            <a:spLocks noGrp="1" noRot="1" noChangeAspect="1"/>
+          </p:cNvSpPr>
+          <p:nvPr>
+            <p:ph type="sldImg"/>
+          </p:nvPr>
+        </p:nvSpPr>
+        <p:spPr/>
+      </p:sp>
+      <p:sp>
+        <p:nvSpPr>
+          <p:cNvPr id="3" name="Notes Placeholder 2"/>
+          <p:cNvSpPr>
+            <a:spLocks noGrp="1"/>
+          </p:cNvSpPr>
+          <p:nvPr>
+            <p:ph type="body" idx="1"/>
+          </p:nvPr>
+        </p:nvSpPr>
+        <p:spPr/>
+        <p:txBody>
+          <a:bodyPr/>
+          <a:lstStyle/>
+          <a:p>
+            <a:r>
+              <a:rPr lang="en-US" dirty="0"/>
+              <a:t>This is the new interface. It is designed like an accounts ledger: decisions appear as rubber stamps, and a pipeline strip ticks off each agent as it runs. For an escalated invoice the reviewer reads the case summary first, opens the details only if needed, and then decides. The three buttons look the same on purpose, so nobody is nudged into paying a risky invoice. Only the presentation changed; the agent logic is the same.</a:t>
+            </a:r>
+          </a:p>
+        </p:txBody>
+      </p:sp>
+    </p:spTree>
+    <p:extLst>
+      <p:ext uri="{BB962C8B-B14F-4D97-AF65-F5344CB8AC3E}">
+        <p14:creationId xmlns:p14="http://schemas.microsoft.com/office/powerpoint/2010/main" val="1024086991"/>
+      </p:ext>
+    </p:extLst>
+  </p:cSld>
+  <p:clrMapOvr>
+    <a:masterClrMapping/>
+  </p:clrMapOvr>
+</p:notes>
+</file>
+
 <file path=ppt/notesSlides/notesSlide2.xml><?xml version="1.0" encoding="utf-8"?>
 <p:notes xmlns:a="http://schemas.openxmlformats.org/drawingml/2006/main" xmlns:r="http://schemas.openxmlformats.org/officeDocument/2006/relationships" xmlns:p="http://schemas.openxmlformats.org/presentationml/2006/main">
   <p:cSld>
@@ -1072,32 +1202,8 @@
           <a:p>
             <a:r>
               <a:rPr lang="en-US" dirty="0"/>
-              <a:t>Walk down the list. Each agent has one job; the Critic appears twice. The two new ones are the Fraud Agent and the Human Review step.</a:t>
-            </a:r>
-            <a:endParaRPr lang="en-US" dirty="0"/>
-          </a:p>
-        </p:txBody>
-      </p:sp>
-      <p:sp>
-        <p:nvSpPr>
-          <p:cNvPr id="4" name="Slide Number Placeholder 3"/>
-          <p:cNvSpPr>
-            <a:spLocks noGrp="1"/>
-          </p:cNvSpPr>
-          <p:nvPr>
-            <p:ph type="sldNum" sz="quarter" idx="10"/>
-          </p:nvPr>
-        </p:nvSpPr>
-        <p:spPr/>
-        <p:txBody>
-          <a:bodyPr/>
-          <a:lstStyle/>
-          <a:p>
-            <a:fld id="{F7021451-1387-4CA6-816F-3879F97B5CBC}" type="slidenum">
-              <a:rPr lang="en-US"/>
-              <a:t>4</a:t>
-            </a:fld>
-            <a:endParaRPr lang="en-US"/>
+              <a:t>Walk down the list. Each agent has one job; the Critic appears twice. New in this version: the Critic also checks that key fields really appear in the invoice and can ask the local model for a second opinion, the Fraud Agent explains its score in plain words, and the Decision Agent writes a case summary for every escalated invoice.</a:t>
+            </a:r>
           </a:p>
         </p:txBody>
       </p:sp>
@@ -1248,32 +1354,8 @@
           <a:p>
             <a:r>
               <a:rPr lang="en-US" dirty="0"/>
-              <a:t>Top to bottom: UI, orchestration, agents, then tools, data and memory. Decisions are rule-based in tools.decide; the LLM only extracts and explains. Escalations pause in the graph until a reviewer answers.</a:t>
-            </a:r>
-            <a:endParaRPr lang="en-US" dirty="0"/>
-          </a:p>
-        </p:txBody>
-      </p:sp>
-      <p:sp>
-        <p:nvSpPr>
-          <p:cNvPr id="4" name="Slide Number Placeholder 3"/>
-          <p:cNvSpPr>
-            <a:spLocks noGrp="1"/>
-          </p:cNvSpPr>
-          <p:nvPr>
-            <p:ph type="sldNum" sz="quarter" idx="10"/>
-          </p:nvPr>
-        </p:nvSpPr>
-        <p:spPr/>
-        <p:txBody>
-          <a:bodyPr/>
-          <a:lstStyle/>
-          <a:p>
-            <a:fld id="{F7021451-1387-4CA6-816F-3879F97B5CBC}" type="slidenum">
-              <a:rPr lang="en-US"/>
-              <a:t>6</a:t>
-            </a:fld>
-            <a:endParaRPr lang="en-US"/>
+              <a:t>Top to bottom: UI, orchestration, agents, then tools, data and memory. Decisions are rule-based in tools.decide. The LLM only reads and explains: it extracts, gives the Critic a second opinion, and writes the risk note and the case summary. Escalations pause in the graph until a reviewer answers.</a:t>
+            </a:r>
           </a:p>
         </p:txBody>
       </p:sp>
@@ -1336,32 +1418,8 @@
           <a:p>
             <a:r>
               <a:rPr lang="en-US" dirty="0"/>
-              <a:t>Run the live app. Show the Critic retry, then open the Review queue and approve or reject an invoice. Finish by downloading a sample PDF and uploading it: the agents catch it as a duplicate.</a:t>
-            </a:r>
-            <a:endParaRPr lang="en-US" dirty="0"/>
-          </a:p>
-        </p:txBody>
-      </p:sp>
-      <p:sp>
-        <p:nvSpPr>
-          <p:cNvPr id="4" name="Slide Number Placeholder 3"/>
-          <p:cNvSpPr>
-            <a:spLocks noGrp="1"/>
-          </p:cNvSpPr>
-          <p:nvPr>
-            <p:ph type="sldNum" sz="quarter" idx="10"/>
-          </p:nvPr>
-        </p:nvSpPr>
-        <p:spPr/>
-        <p:txBody>
-          <a:bodyPr/>
-          <a:lstStyle/>
-          <a:p>
-            <a:fld id="{F7021451-1387-4CA6-816F-3879F97B5CBC}" type="slidenum">
-              <a:rPr lang="en-US"/>
-              <a:t>7</a:t>
-            </a:fld>
-            <a:endParaRPr lang="en-US"/>
+              <a:t>Run the live app. Show the Critic retry in the trace, then open the Review queue, read a case summary and approve or reject the invoice. Finish by downloading a sample PDF and uploading it: the agents catch it as a duplicate. If Ollama is installed, switch the engine to show the model-written notes.</a:t>
+            </a:r>
           </a:p>
         </p:txBody>
       </p:sp>
@@ -1512,32 +1570,8 @@
           <a:p>
             <a:r>
               <a:rPr lang="en-US" dirty="0"/>
-              <a:t>Be honest about limitations; it shows judgement. The biggest next step is real invoices via OCR plus an LLM extractor, then learning the fraud weights from reviewer decisions.</a:t>
-            </a:r>
-            <a:endParaRPr lang="en-US" dirty="0"/>
-          </a:p>
-        </p:txBody>
-      </p:sp>
-      <p:sp>
-        <p:nvSpPr>
-          <p:cNvPr id="4" name="Slide Number Placeholder 3"/>
-          <p:cNvSpPr>
-            <a:spLocks noGrp="1"/>
-          </p:cNvSpPr>
-          <p:nvPr>
-            <p:ph type="sldNum" sz="quarter" idx="10"/>
-          </p:nvPr>
-        </p:nvSpPr>
-        <p:spPr/>
-        <p:txBody>
-          <a:bodyPr/>
-          <a:lstStyle/>
-          <a:p>
-            <a:fld id="{F7021451-1387-4CA6-816F-3879F97B5CBC}" type="slidenum">
-              <a:rPr lang="en-US"/>
-              <a:t>9</a:t>
-            </a:fld>
-            <a:endParaRPr lang="en-US"/>
+              <a:t>Be honest about limitations; it shows judgement. With Ollama, runs are slower and a small model can misread fields, which is why the Critic checks are always on. The biggest next step is real invoices via OCR plus an LLM extractor, then learning the fraud weights from reviewer decisions.</a:t>
+            </a:r>
           </a:p>
         </p:txBody>
       </p:sp>
@@ -3591,7 +3625,7 @@
             <a:pPr algn="l"/>
             <a:fld id="{F7021451-1387-4CA6-816F-3879F97B5CBC}" type="slidenum">
               <a:rPr b="0" lang="en-US"/>
-              <a:t>8</a:t>
+              <a:t>6</a:t>
             </a:fld>
             <a:endParaRPr lang="en-US"/>
           </a:p>
@@ -3954,7 +3988,7 @@
                   <a:schemeClr val="tx1"/>
                 </a:solidFill>
               </a:rPr>
-              <a:t>Approve, hold or reject in the Review queue</a:t>
+              <a:t>Read the case summary, then approve, hold or reject</a:t>
             </a:r>
             <a:endParaRPr lang="en-US" sz="1200" dirty="0"/>
           </a:p>
@@ -4480,6 +4514,1163 @@
             <a:fld id="{F7021451-1387-4CA6-816F-3879F97B5CBC}" type="slidenum">
               <a:rPr b="0" lang="en-US"/>
               <a:t>7</a:t>
+            </a:fld>
+            <a:endParaRPr lang="en-US"/>
+          </a:p>
+        </p:txBody>
+      </p:sp>
+    </p:spTree>
+  </p:cSld>
+  <p:clrMapOvr>
+    <a:masterClrMapping/>
+  </p:clrMapOvr>
+</p:sld>
+</file>
+
+<file path=ppt/slides/slide13.xml><?xml version="1.0" encoding="utf-8"?>
+<p:sld xmlns:a="http://schemas.openxmlformats.org/drawingml/2006/main" xmlns:r="http://schemas.openxmlformats.org/officeDocument/2006/relationships" xmlns:p="http://schemas.openxmlformats.org/presentationml/2006/main">
+  <p:cSld name="Slide 7">
+    <p:spTree>
+      <p:nvGrpSpPr>
+        <p:cNvPr id="2" name=""/>
+        <p:cNvGrpSpPr/>
+        <p:nvPr/>
+      </p:nvGrpSpPr>
+      <p:grpSpPr>
+        <a:xfrm>
+          <a:off x="0" y="0"/>
+          <a:ext cx="0" cy="0"/>
+          <a:chOff x="0" y="0"/>
+          <a:chExt cx="0" cy="0"/>
+        </a:xfrm>
+      </p:grpSpPr>
+      <p:sp>
+        <p:nvSpPr>
+          <p:cNvPr id="3" name="Text 0"/>
+          <p:cNvSpPr/>
+          <p:nvPr>
+            <p:ph idx="100" type="title" hasCustomPrompt="1"/>
+          </p:nvPr>
+        </p:nvSpPr>
+        <p:spPr>
+          <a:xfrm>
+            <a:off x="457200" y="274320"/>
+            <a:ext cx="8229600" cy="731520"/>
+          </a:xfrm>
+          <a:prstGeom prst="rect">
+            <a:avLst/>
+          </a:prstGeom>
+          <a:noFill/>
+          <a:ln/>
+        </p:spPr>
+        <p:txBody>
+          <a:bodyPr wrap="square" lIns="0" tIns="0" rIns="0" bIns="0" rtlCol="0" anchor="ctr"/>
+          <a:lstStyle/>
+          <a:p>
+            <a:pPr algn="l" indent="0" marL="0">
+              <a:buNone/>
+            </a:pPr>
+            <a:r>
+              <a:rPr lang="en-US" sz="3400" b="1" dirty="0">
+                <a:solidFill>
+                  <a:schemeClr val="tx2"/>
+                </a:solidFill>
+              </a:rPr>
+              <a:t>The local model, with guardrails</a:t>
+            </a:r>
+            <a:endParaRPr lang="en-US" sz="3400" dirty="0"/>
+          </a:p>
+        </p:txBody>
+      </p:sp>
+      <p:sp>
+        <p:nvSpPr>
+          <p:cNvPr id="4" name="step card"/>
+          <p:cNvSpPr/>
+          <p:nvPr/>
+        </p:nvSpPr>
+        <p:spPr>
+          <a:xfrm>
+            <a:off x="457200" y="1188720"/>
+            <a:ext cx="1920240" cy="1371600"/>
+          </a:xfrm>
+          <a:prstGeom prst="roundRect">
+            <a:avLst>
+              <a:gd name="adj" fmla="val 5333"/>
+            </a:avLst>
+          </a:prstGeom>
+          <a:solidFill>
+            <a:schemeClr val="bg2"/>
+          </a:solidFill>
+          <a:ln/>
+        </p:spPr>
+      </p:sp>
+      <p:sp>
+        <p:nvSpPr>
+          <p:cNvPr id="5" name="badge"/>
+          <p:cNvSpPr/>
+          <p:nvPr/>
+        </p:nvSpPr>
+        <p:spPr>
+          <a:xfrm>
+            <a:off x="594360" y="1325880"/>
+            <a:ext cx="347472" cy="347472"/>
+          </a:xfrm>
+          <a:prstGeom prst="ellipse">
+            <a:avLst/>
+          </a:prstGeom>
+          <a:solidFill>
+            <a:schemeClr val="accent1"/>
+          </a:solidFill>
+          <a:ln/>
+        </p:spPr>
+      </p:sp>
+      <p:sp>
+        <p:nvSpPr>
+          <p:cNvPr id="6" name="Text 3"/>
+          <p:cNvSpPr txBox="1"/>
+          <p:nvPr/>
+        </p:nvSpPr>
+        <p:spPr>
+          <a:xfrm>
+            <a:off x="594360" y="1325880"/>
+            <a:ext cx="347472" cy="347472"/>
+          </a:xfrm>
+          <a:prstGeom prst="rect">
+            <a:avLst/>
+          </a:prstGeom>
+          <a:noFill/>
+          <a:ln/>
+        </p:spPr>
+        <p:txBody>
+          <a:bodyPr wrap="square" lIns="0" tIns="0" rIns="0" bIns="0" rtlCol="0" anchor="ctr"/>
+          <a:lstStyle/>
+          <a:p>
+            <a:pPr algn="ctr" indent="0" marL="0">
+              <a:buNone/>
+            </a:pPr>
+            <a:r>
+              <a:rPr lang="en-US" sz="1400" b="1" dirty="0">
+                <a:solidFill>
+                  <a:schemeClr val="bg1"/>
+                </a:solidFill>
+              </a:rPr>
+              <a:t>1</a:t>
+            </a:r>
+            <a:endParaRPr lang="en-US" sz="1400" dirty="0"/>
+          </a:p>
+        </p:txBody>
+      </p:sp>
+      <p:sp>
+        <p:nvSpPr>
+          <p:cNvPr id="7" name="Text 4"/>
+          <p:cNvSpPr txBox="1"/>
+          <p:nvPr/>
+        </p:nvSpPr>
+        <p:spPr>
+          <a:xfrm>
+            <a:off x="1051560" y="1307592"/>
+            <a:ext cx="1234440" cy="384048"/>
+          </a:xfrm>
+          <a:prstGeom prst="rect">
+            <a:avLst/>
+          </a:prstGeom>
+          <a:noFill/>
+          <a:ln/>
+        </p:spPr>
+        <p:txBody>
+          <a:bodyPr wrap="square" lIns="0" tIns="0" rIns="0" bIns="0" rtlCol="0" anchor="ctr"/>
+          <a:lstStyle/>
+          <a:p>
+            <a:pPr indent="0" marL="0">
+              <a:buNone/>
+            </a:pPr>
+            <a:r>
+              <a:rPr lang="en-US" sz="1400" b="1" dirty="0">
+                <a:solidFill>
+                  <a:schemeClr val="tx2"/>
+                </a:solidFill>
+              </a:rPr>
+              <a:t>Extract</a:t>
+            </a:r>
+            <a:endParaRPr lang="en-US" sz="1400" dirty="0"/>
+          </a:p>
+        </p:txBody>
+      </p:sp>
+      <p:sp>
+        <p:nvSpPr>
+          <p:cNvPr id="8" name="Text 5"/>
+          <p:cNvSpPr txBox="1"/>
+          <p:nvPr/>
+        </p:nvSpPr>
+        <p:spPr>
+          <a:xfrm>
+            <a:off x="594360" y="1828800"/>
+            <a:ext cx="1645920" cy="685800"/>
+          </a:xfrm>
+          <a:prstGeom prst="rect">
+            <a:avLst/>
+          </a:prstGeom>
+          <a:noFill/>
+          <a:ln/>
+        </p:spPr>
+        <p:txBody>
+          <a:bodyPr wrap="square" lIns="0" tIns="0" rIns="0" bIns="0" rtlCol="0" anchor="t"/>
+          <a:lstStyle/>
+          <a:p>
+            <a:pPr indent="0" marL="0">
+              <a:buNone/>
+            </a:pPr>
+            <a:r>
+              <a:rPr lang="en-US" sz="1200" dirty="0">
+                <a:solidFill>
+                  <a:schemeClr val="tx1"/>
+                </a:solidFill>
+              </a:rPr>
+              <a:t>Reads the invoice; every key field must appear in it</a:t>
+            </a:r>
+            <a:endParaRPr lang="en-US" sz="1200" dirty="0"/>
+          </a:p>
+        </p:txBody>
+      </p:sp>
+      <p:sp>
+        <p:nvSpPr>
+          <p:cNvPr id="9" name="step card"/>
+          <p:cNvSpPr/>
+          <p:nvPr/>
+        </p:nvSpPr>
+        <p:spPr>
+          <a:xfrm>
+            <a:off x="2560320" y="1188720"/>
+            <a:ext cx="1920240" cy="1371600"/>
+          </a:xfrm>
+          <a:prstGeom prst="roundRect">
+            <a:avLst>
+              <a:gd name="adj" fmla="val 5333"/>
+            </a:avLst>
+          </a:prstGeom>
+          <a:solidFill>
+            <a:schemeClr val="bg2"/>
+          </a:solidFill>
+          <a:ln/>
+        </p:spPr>
+      </p:sp>
+      <p:sp>
+        <p:nvSpPr>
+          <p:cNvPr id="10" name="badge"/>
+          <p:cNvSpPr/>
+          <p:nvPr/>
+        </p:nvSpPr>
+        <p:spPr>
+          <a:xfrm>
+            <a:off x="2697480" y="1325880"/>
+            <a:ext cx="347472" cy="347472"/>
+          </a:xfrm>
+          <a:prstGeom prst="ellipse">
+            <a:avLst/>
+          </a:prstGeom>
+          <a:solidFill>
+            <a:schemeClr val="accent1"/>
+          </a:solidFill>
+          <a:ln/>
+        </p:spPr>
+      </p:sp>
+      <p:sp>
+        <p:nvSpPr>
+          <p:cNvPr id="11" name="Text 8"/>
+          <p:cNvSpPr txBox="1"/>
+          <p:nvPr/>
+        </p:nvSpPr>
+        <p:spPr>
+          <a:xfrm>
+            <a:off x="2697480" y="1325880"/>
+            <a:ext cx="347472" cy="347472"/>
+          </a:xfrm>
+          <a:prstGeom prst="rect">
+            <a:avLst/>
+          </a:prstGeom>
+          <a:noFill/>
+          <a:ln/>
+        </p:spPr>
+        <p:txBody>
+          <a:bodyPr wrap="square" lIns="0" tIns="0" rIns="0" bIns="0" rtlCol="0" anchor="ctr"/>
+          <a:lstStyle/>
+          <a:p>
+            <a:pPr algn="ctr" indent="0" marL="0">
+              <a:buNone/>
+            </a:pPr>
+            <a:r>
+              <a:rPr lang="en-US" sz="1400" b="1" dirty="0">
+                <a:solidFill>
+                  <a:schemeClr val="bg1"/>
+                </a:solidFill>
+              </a:rPr>
+              <a:t>2</a:t>
+            </a:r>
+            <a:endParaRPr lang="en-US" sz="1400" dirty="0"/>
+          </a:p>
+        </p:txBody>
+      </p:sp>
+      <p:sp>
+        <p:nvSpPr>
+          <p:cNvPr id="12" name="Text 9"/>
+          <p:cNvSpPr txBox="1"/>
+          <p:nvPr/>
+        </p:nvSpPr>
+        <p:spPr>
+          <a:xfrm>
+            <a:off x="3154680" y="1307592"/>
+            <a:ext cx="1234440" cy="384048"/>
+          </a:xfrm>
+          <a:prstGeom prst="rect">
+            <a:avLst/>
+          </a:prstGeom>
+          <a:noFill/>
+          <a:ln/>
+        </p:spPr>
+        <p:txBody>
+          <a:bodyPr wrap="square" lIns="0" tIns="0" rIns="0" bIns="0" rtlCol="0" anchor="ctr"/>
+          <a:lstStyle/>
+          <a:p>
+            <a:pPr indent="0" marL="0">
+              <a:buNone/>
+            </a:pPr>
+            <a:r>
+              <a:rPr lang="en-US" sz="1400" b="1" dirty="0">
+                <a:solidFill>
+                  <a:schemeClr val="tx2"/>
+                </a:solidFill>
+              </a:rPr>
+              <a:t>2nd opinion</a:t>
+            </a:r>
+            <a:endParaRPr lang="en-US" sz="1400" dirty="0"/>
+          </a:p>
+        </p:txBody>
+      </p:sp>
+      <p:sp>
+        <p:nvSpPr>
+          <p:cNvPr id="13" name="Text 10"/>
+          <p:cNvSpPr txBox="1"/>
+          <p:nvPr/>
+        </p:nvSpPr>
+        <p:spPr>
+          <a:xfrm>
+            <a:off x="2697480" y="1828800"/>
+            <a:ext cx="1645920" cy="685800"/>
+          </a:xfrm>
+          <a:prstGeom prst="rect">
+            <a:avLst/>
+          </a:prstGeom>
+          <a:noFill/>
+          <a:ln/>
+        </p:spPr>
+        <p:txBody>
+          <a:bodyPr wrap="square" lIns="0" tIns="0" rIns="0" bIns="0" rtlCol="0" anchor="t"/>
+          <a:lstStyle/>
+          <a:p>
+            <a:pPr indent="0" marL="0">
+              <a:buNone/>
+            </a:pPr>
+            <a:r>
+              <a:rPr lang="en-US" sz="1200" dirty="0">
+                <a:solidFill>
+                  <a:schemeClr val="tx1"/>
+                </a:solidFill>
+              </a:rPr>
+              <a:t>Doubts trigger a retry, never an escalation</a:t>
+            </a:r>
+            <a:endParaRPr lang="en-US" sz="1200" dirty="0"/>
+          </a:p>
+        </p:txBody>
+      </p:sp>
+      <p:sp>
+        <p:nvSpPr>
+          <p:cNvPr id="14" name="step card"/>
+          <p:cNvSpPr/>
+          <p:nvPr/>
+        </p:nvSpPr>
+        <p:spPr>
+          <a:xfrm>
+            <a:off x="4663440" y="1188720"/>
+            <a:ext cx="1920240" cy="1371600"/>
+          </a:xfrm>
+          <a:prstGeom prst="roundRect">
+            <a:avLst>
+              <a:gd name="adj" fmla="val 5333"/>
+            </a:avLst>
+          </a:prstGeom>
+          <a:solidFill>
+            <a:schemeClr val="bg2"/>
+          </a:solidFill>
+          <a:ln/>
+        </p:spPr>
+      </p:sp>
+      <p:sp>
+        <p:nvSpPr>
+          <p:cNvPr id="15" name="badge"/>
+          <p:cNvSpPr/>
+          <p:nvPr/>
+        </p:nvSpPr>
+        <p:spPr>
+          <a:xfrm>
+            <a:off x="4800600" y="1325880"/>
+            <a:ext cx="347472" cy="347472"/>
+          </a:xfrm>
+          <a:prstGeom prst="ellipse">
+            <a:avLst/>
+          </a:prstGeom>
+          <a:solidFill>
+            <a:schemeClr val="accent1"/>
+          </a:solidFill>
+          <a:ln/>
+        </p:spPr>
+      </p:sp>
+      <p:sp>
+        <p:nvSpPr>
+          <p:cNvPr id="16" name="Text 13"/>
+          <p:cNvSpPr txBox="1"/>
+          <p:nvPr/>
+        </p:nvSpPr>
+        <p:spPr>
+          <a:xfrm>
+            <a:off x="4800600" y="1325880"/>
+            <a:ext cx="347472" cy="347472"/>
+          </a:xfrm>
+          <a:prstGeom prst="rect">
+            <a:avLst/>
+          </a:prstGeom>
+          <a:noFill/>
+          <a:ln/>
+        </p:spPr>
+        <p:txBody>
+          <a:bodyPr wrap="square" lIns="0" tIns="0" rIns="0" bIns="0" rtlCol="0" anchor="ctr"/>
+          <a:lstStyle/>
+          <a:p>
+            <a:pPr algn="ctr" indent="0" marL="0">
+              <a:buNone/>
+            </a:pPr>
+            <a:r>
+              <a:rPr lang="en-US" sz="1400" b="1" dirty="0">
+                <a:solidFill>
+                  <a:schemeClr val="bg1"/>
+                </a:solidFill>
+              </a:rPr>
+              <a:t>3</a:t>
+            </a:r>
+            <a:endParaRPr lang="en-US" sz="1400" dirty="0"/>
+          </a:p>
+        </p:txBody>
+      </p:sp>
+      <p:sp>
+        <p:nvSpPr>
+          <p:cNvPr id="17" name="Text 14"/>
+          <p:cNvSpPr txBox="1"/>
+          <p:nvPr/>
+        </p:nvSpPr>
+        <p:spPr>
+          <a:xfrm>
+            <a:off x="5257800" y="1307592"/>
+            <a:ext cx="1234440" cy="384048"/>
+          </a:xfrm>
+          <a:prstGeom prst="rect">
+            <a:avLst/>
+          </a:prstGeom>
+          <a:noFill/>
+          <a:ln/>
+        </p:spPr>
+        <p:txBody>
+          <a:bodyPr wrap="square" lIns="0" tIns="0" rIns="0" bIns="0" rtlCol="0" anchor="ctr"/>
+          <a:lstStyle/>
+          <a:p>
+            <a:pPr indent="0" marL="0">
+              <a:buNone/>
+            </a:pPr>
+            <a:r>
+              <a:rPr lang="en-US" sz="1400" b="1" dirty="0">
+                <a:solidFill>
+                  <a:schemeClr val="tx2"/>
+                </a:solidFill>
+              </a:rPr>
+              <a:t>Risk note</a:t>
+            </a:r>
+            <a:endParaRPr lang="en-US" sz="1400" dirty="0"/>
+          </a:p>
+        </p:txBody>
+      </p:sp>
+      <p:sp>
+        <p:nvSpPr>
+          <p:cNvPr id="18" name="Text 15"/>
+          <p:cNvSpPr txBox="1"/>
+          <p:nvPr/>
+        </p:nvSpPr>
+        <p:spPr>
+          <a:xfrm>
+            <a:off x="4800600" y="1828800"/>
+            <a:ext cx="1645920" cy="685800"/>
+          </a:xfrm>
+          <a:prstGeom prst="rect">
+            <a:avLst/>
+          </a:prstGeom>
+          <a:noFill/>
+          <a:ln/>
+        </p:spPr>
+        <p:txBody>
+          <a:bodyPr wrap="square" lIns="0" tIns="0" rIns="0" bIns="0" rtlCol="0" anchor="t"/>
+          <a:lstStyle/>
+          <a:p>
+            <a:pPr indent="0" marL="0">
+              <a:buNone/>
+            </a:pPr>
+            <a:r>
+              <a:rPr lang="en-US" sz="1200" dirty="0">
+                <a:solidFill>
+                  <a:schemeClr val="tx1"/>
+                </a:solidFill>
+              </a:rPr>
+              <a:t>Explains the rules' score in plain words</a:t>
+            </a:r>
+            <a:endParaRPr lang="en-US" sz="1200" dirty="0"/>
+          </a:p>
+        </p:txBody>
+      </p:sp>
+      <p:sp>
+        <p:nvSpPr>
+          <p:cNvPr id="19" name="step card"/>
+          <p:cNvSpPr/>
+          <p:nvPr/>
+        </p:nvSpPr>
+        <p:spPr>
+          <a:xfrm>
+            <a:off x="6766560" y="1188720"/>
+            <a:ext cx="1920240" cy="1371600"/>
+          </a:xfrm>
+          <a:prstGeom prst="roundRect">
+            <a:avLst>
+              <a:gd name="adj" fmla="val 5333"/>
+            </a:avLst>
+          </a:prstGeom>
+          <a:solidFill>
+            <a:schemeClr val="bg2"/>
+          </a:solidFill>
+          <a:ln/>
+        </p:spPr>
+      </p:sp>
+      <p:sp>
+        <p:nvSpPr>
+          <p:cNvPr id="20" name="badge"/>
+          <p:cNvSpPr/>
+          <p:nvPr/>
+        </p:nvSpPr>
+        <p:spPr>
+          <a:xfrm>
+            <a:off x="6903720" y="1325880"/>
+            <a:ext cx="347472" cy="347472"/>
+          </a:xfrm>
+          <a:prstGeom prst="ellipse">
+            <a:avLst/>
+          </a:prstGeom>
+          <a:solidFill>
+            <a:schemeClr val="accent1"/>
+          </a:solidFill>
+          <a:ln/>
+        </p:spPr>
+      </p:sp>
+      <p:sp>
+        <p:nvSpPr>
+          <p:cNvPr id="21" name="Text 18"/>
+          <p:cNvSpPr txBox="1"/>
+          <p:nvPr/>
+        </p:nvSpPr>
+        <p:spPr>
+          <a:xfrm>
+            <a:off x="6903720" y="1325880"/>
+            <a:ext cx="347472" cy="347472"/>
+          </a:xfrm>
+          <a:prstGeom prst="rect">
+            <a:avLst/>
+          </a:prstGeom>
+          <a:noFill/>
+          <a:ln/>
+        </p:spPr>
+        <p:txBody>
+          <a:bodyPr wrap="square" lIns="0" tIns="0" rIns="0" bIns="0" rtlCol="0" anchor="ctr"/>
+          <a:lstStyle/>
+          <a:p>
+            <a:pPr algn="ctr" indent="0" marL="0">
+              <a:buNone/>
+            </a:pPr>
+            <a:r>
+              <a:rPr lang="en-US" sz="1400" b="1" dirty="0">
+                <a:solidFill>
+                  <a:schemeClr val="bg1"/>
+                </a:solidFill>
+              </a:rPr>
+              <a:t>4</a:t>
+            </a:r>
+            <a:endParaRPr lang="en-US" sz="1400" dirty="0"/>
+          </a:p>
+        </p:txBody>
+      </p:sp>
+      <p:sp>
+        <p:nvSpPr>
+          <p:cNvPr id="22" name="Text 19"/>
+          <p:cNvSpPr txBox="1"/>
+          <p:nvPr/>
+        </p:nvSpPr>
+        <p:spPr>
+          <a:xfrm>
+            <a:off x="7360920" y="1307592"/>
+            <a:ext cx="1234440" cy="384048"/>
+          </a:xfrm>
+          <a:prstGeom prst="rect">
+            <a:avLst/>
+          </a:prstGeom>
+          <a:noFill/>
+          <a:ln/>
+        </p:spPr>
+        <p:txBody>
+          <a:bodyPr wrap="square" lIns="0" tIns="0" rIns="0" bIns="0" rtlCol="0" anchor="ctr"/>
+          <a:lstStyle/>
+          <a:p>
+            <a:pPr indent="0" marL="0">
+              <a:buNone/>
+            </a:pPr>
+            <a:r>
+              <a:rPr lang="en-US" sz="1400" b="1" dirty="0">
+                <a:solidFill>
+                  <a:schemeClr val="tx2"/>
+                </a:solidFill>
+              </a:rPr>
+              <a:t>Case brief</a:t>
+            </a:r>
+            <a:endParaRPr lang="en-US" sz="1400" dirty="0"/>
+          </a:p>
+        </p:txBody>
+      </p:sp>
+      <p:sp>
+        <p:nvSpPr>
+          <p:cNvPr id="23" name="Text 20"/>
+          <p:cNvSpPr txBox="1"/>
+          <p:nvPr/>
+        </p:nvSpPr>
+        <p:spPr>
+          <a:xfrm>
+            <a:off x="6903720" y="1828800"/>
+            <a:ext cx="1645920" cy="685800"/>
+          </a:xfrm>
+          <a:prstGeom prst="rect">
+            <a:avLst/>
+          </a:prstGeom>
+          <a:noFill/>
+          <a:ln/>
+        </p:spPr>
+        <p:txBody>
+          <a:bodyPr wrap="square" lIns="0" tIns="0" rIns="0" bIns="0" rtlCol="0" anchor="t"/>
+          <a:lstStyle/>
+          <a:p>
+            <a:pPr indent="0" marL="0">
+              <a:buNone/>
+            </a:pPr>
+            <a:r>
+              <a:rPr lang="en-US" sz="1200" dirty="0">
+                <a:solidFill>
+                  <a:schemeClr val="tx1"/>
+                </a:solidFill>
+              </a:rPr>
+              <a:t>Briefs the reviewer on each escalated invoice</a:t>
+            </a:r>
+            <a:endParaRPr lang="en-US" sz="1200" dirty="0"/>
+          </a:p>
+        </p:txBody>
+      </p:sp>
+      <p:sp>
+        <p:nvSpPr>
+          <p:cNvPr id="24" name="Text 21"/>
+          <p:cNvSpPr txBox="1"/>
+          <p:nvPr/>
+        </p:nvSpPr>
+        <p:spPr>
+          <a:xfrm>
+            <a:off x="457200" y="2697480"/>
+            <a:ext cx="8229600" cy="274320"/>
+          </a:xfrm>
+          <a:prstGeom prst="rect">
+            <a:avLst/>
+          </a:prstGeom>
+          <a:noFill/>
+          <a:ln/>
+        </p:spPr>
+        <p:txBody>
+          <a:bodyPr wrap="square" lIns="0" tIns="0" rIns="0" bIns="0" rtlCol="0" anchor="t"/>
+          <a:lstStyle/>
+          <a:p>
+            <a:pPr indent="0" marL="0">
+              <a:buNone/>
+            </a:pPr>
+            <a:r>
+              <a:rPr lang="en-US" sz="1300" b="1" dirty="0">
+                <a:solidFill>
+                  <a:schemeClr val="tx2"/>
+                </a:solidFill>
+              </a:rPr>
+              <a:t>Real case summary for a bank-change invoice. Any number the model adds is rejected.</a:t>
+            </a:r>
+            <a:endParaRPr lang="en-US" sz="1300" dirty="0"/>
+          </a:p>
+        </p:txBody>
+      </p:sp>
+      <p:sp>
+        <p:nvSpPr>
+          <p:cNvPr id="25" name="trace box"/>
+          <p:cNvSpPr/>
+          <p:nvPr/>
+        </p:nvSpPr>
+        <p:spPr>
+          <a:xfrm>
+            <a:off x="457200" y="3017520"/>
+            <a:ext cx="8229600" cy="1645920"/>
+          </a:xfrm>
+          <a:prstGeom prst="roundRect">
+            <a:avLst>
+              <a:gd name="adj" fmla="val 4444"/>
+            </a:avLst>
+          </a:prstGeom>
+          <a:solidFill>
+            <a:schemeClr val="tx2"/>
+          </a:solidFill>
+          <a:ln/>
+        </p:spPr>
+      </p:sp>
+      <p:sp>
+        <p:nvSpPr>
+          <p:cNvPr id="26" name="Text 23"/>
+          <p:cNvSpPr txBox="1"/>
+          <p:nvPr/>
+        </p:nvSpPr>
+        <p:spPr>
+          <a:xfrm>
+            <a:off x="640080" y="3127248"/>
+            <a:ext cx="7863840" cy="1417320"/>
+          </a:xfrm>
+          <a:prstGeom prst="rect">
+            <a:avLst/>
+          </a:prstGeom>
+          <a:noFill/>
+          <a:ln/>
+        </p:spPr>
+        <p:txBody>
+          <a:bodyPr wrap="square" lIns="0" tIns="0" rIns="0" bIns="0" rtlCol="0" anchor="ctr"/>
+          <a:lstStyle/>
+          <a:p>
+            <a:pPr indent="0" marL="0">
+              <a:spcAft>
+                <a:spcPts val="300"/>
+              </a:spcAft>
+              <a:buNone/>
+            </a:pPr>
+            <a:r>
+              <a:rPr lang="en-US" sz="1100" dirty="0">
+                <a:solidFill>
+                  <a:schemeClr val="bg1"/>
+                </a:solidFill>
+                <a:latin typeface="Courier New" pitchFamily="34" charset="0"/>
+                <a:ea typeface="Courier New" pitchFamily="34" charset="-122"/>
+                <a:cs typeface="Courier New" pitchFamily="34" charset="-120"/>
+              </a:rPr>
+              <a:t>Problem: pay-to account 50100990490278 differs from account on file 50100341316475.</a:t>
+            </a:r>
+            <a:endParaRPr lang="en-US" sz="1100" dirty="0"/>
+          </a:p>
+          <a:p>
+            <a:pPr indent="0" marL="0">
+              <a:spcAft>
+                <a:spcPts val="300"/>
+              </a:spcAft>
+              <a:buNone/>
+            </a:pPr>
+            <a:r>
+              <a:rPr lang="en-US" sz="1100" dirty="0">
+                <a:solidFill>
+                  <a:schemeClr val="bg1"/>
+                </a:solidFill>
+                <a:latin typeface="Courier New" pitchFamily="34" charset="0"/>
+                <a:ea typeface="Courier New" pitchFamily="34" charset="-122"/>
+                <a:cs typeface="Courier New" pitchFamily="34" charset="-120"/>
+              </a:rPr>
+              <a:t>Stake: INR 12,358.99 at risk, risk score 70/100.</a:t>
+            </a:r>
+            <a:endParaRPr lang="en-US" sz="1100" dirty="0"/>
+          </a:p>
+          <a:p>
+            <a:pPr indent="0" marL="0">
+              <a:spcAft>
+                <a:spcPts val="300"/>
+              </a:spcAft>
+              <a:buNone/>
+            </a:pPr>
+            <a:r>
+              <a:rPr lang="en-US" sz="1100" dirty="0">
+                <a:solidFill>
+                  <a:schemeClr val="bg1"/>
+                </a:solidFill>
+                <a:latin typeface="Courier New" pitchFamily="34" charset="0"/>
+                <a:ea typeface="Courier New" pitchFamily="34" charset="-122"/>
+                <a:cs typeface="Courier New" pitchFamily="34" charset="-120"/>
+              </a:rPr>
+              <a:t>Vendor history: 14 past approved invoices, largest INR 213,993.83.</a:t>
+            </a:r>
+            <a:endParaRPr lang="en-US" sz="1100" dirty="0"/>
+          </a:p>
+          <a:p>
+            <a:pPr indent="0" marL="0">
+              <a:spcAft>
+                <a:spcPts val="300"/>
+              </a:spcAft>
+              <a:buNone/>
+            </a:pPr>
+            <a:r>
+              <a:rPr lang="en-US" sz="1100" dirty="0">
+                <a:solidFill>
+                  <a:schemeClr val="bg1"/>
+                </a:solidFill>
+                <a:latin typeface="Courier New" pitchFamily="34" charset="0"/>
+                <a:ea typeface="Courier New" pitchFamily="34" charset="-122"/>
+                <a:cs typeface="Courier New" pitchFamily="34" charset="-120"/>
+              </a:rPr>
+              <a:t>Check: call the vendor on the number in the vendor master to confirm the new account.</a:t>
+            </a:r>
+            <a:endParaRPr lang="en-US" sz="1100" dirty="0"/>
+          </a:p>
+        </p:txBody>
+      </p:sp>
+      <p:sp>
+        <p:nvSpPr>
+          <p:cNvPr id="27" name="Slide Number Placeholder 0"/>
+          <p:cNvSpPr>
+            <a:spLocks noGrp="1"/>
+          </p:cNvSpPr>
+          <p:nvPr>
+            <p:ph type="sldNum" sz="quarter" idx="4294967295"/>
+          </p:nvPr>
+        </p:nvSpPr>
+        <p:spPr>
+          <a:xfrm>
+            <a:off x="8321040" y="4754880"/>
+            <a:ext cx="457200" cy="274320"/>
+          </a:xfrm>
+          <a:prstGeom prst="rect">
+            <a:avLst/>
+          </a:prstGeom>
+          <a:extLst>
+            <a:ext uri="{C572A759-6A51-4108-AA02-DFA0A04FC94B}">
+              <ma14:wrappingTextBoxFlag xmlns:ma14="http://schemas.microsoft.com/office/mac/drawingml/2011/main" val="0"/>
+            </a:ext>
+          </a:extLst>
+        </p:spPr>
+        <p:txBody>
+          <a:bodyPr/>
+          <a:lstStyle>
+            <a:lvl1pPr>
+              <a:defRPr sz="1000">
+                <a:solidFill>
+                  <a:schemeClr val="accent5"/>
+                </a:solidFill>
+              </a:defRPr>
+            </a:lvl1pPr>
+          </a:lstStyle>
+          <a:p>
+            <a:pPr algn="l"/>
+            <a:fld id="{F7021451-1387-4CA6-816F-3879F97B5CBC}" type="slidenum">
+              <a:rPr b="0" lang="en-US"/>
+              <a:t>8</a:t>
+            </a:fld>
+            <a:endParaRPr lang="en-US"/>
+          </a:p>
+        </p:txBody>
+      </p:sp>
+    </p:spTree>
+  </p:cSld>
+  <p:clrMapOvr>
+    <a:masterClrMapping/>
+  </p:clrMapOvr>
+</p:sld>
+</file>
+
+<file path=ppt/slides/slide14.xml><?xml version="1.0" encoding="utf-8"?>
+<p:sld xmlns:a="http://schemas.openxmlformats.org/drawingml/2006/main" xmlns:r="http://schemas.openxmlformats.org/officeDocument/2006/relationships" xmlns:p="http://schemas.openxmlformats.org/presentationml/2006/main">
+  <p:cSld name="Slide 8">
+    <p:spTree>
+      <p:nvGrpSpPr>
+        <p:cNvPr id="2" name=""/>
+        <p:cNvGrpSpPr/>
+        <p:nvPr/>
+      </p:nvGrpSpPr>
+      <p:grpSpPr>
+        <a:xfrm>
+          <a:off x="0" y="0"/>
+          <a:ext cx="0" cy="0"/>
+          <a:chOff x="0" y="0"/>
+          <a:chExt cx="0" cy="0"/>
+        </a:xfrm>
+      </p:grpSpPr>
+      <p:sp>
+        <p:nvSpPr>
+          <p:cNvPr id="3" name="Text 0"/>
+          <p:cNvSpPr/>
+          <p:nvPr>
+            <p:ph idx="100" type="title" hasCustomPrompt="1"/>
+          </p:nvPr>
+        </p:nvSpPr>
+        <p:spPr>
+          <a:xfrm>
+            <a:off x="457200" y="274320"/>
+            <a:ext cx="8229600" cy="731520"/>
+          </a:xfrm>
+          <a:prstGeom prst="rect">
+            <a:avLst/>
+          </a:prstGeom>
+          <a:noFill/>
+          <a:ln/>
+        </p:spPr>
+        <p:txBody>
+          <a:bodyPr wrap="square" lIns="0" tIns="0" rIns="0" bIns="0" rtlCol="0" anchor="ctr"/>
+          <a:lstStyle/>
+          <a:p>
+            <a:pPr algn="l" indent="0" marL="0">
+              <a:buNone/>
+            </a:pPr>
+            <a:r>
+              <a:rPr lang="en-US" sz="3400" b="1" dirty="0">
+                <a:solidFill>
+                  <a:schemeClr val="tx2"/>
+                </a:solidFill>
+              </a:rPr>
+              <a:t>The reviewer's view</a:t>
+            </a:r>
+            <a:endParaRPr lang="en-US" sz="3400" dirty="0"/>
+          </a:p>
+        </p:txBody>
+      </p:sp>
+      <p:sp>
+        <p:nvSpPr>
+          <p:cNvPr id="16" name="notes panel"/>
+          <p:cNvSpPr/>
+          <p:nvPr/>
+        </p:nvSpPr>
+        <p:spPr>
+          <a:xfrm>
+            <a:off x="5715000" y="1188720"/>
+            <a:ext cx="2971800" cy="3520440"/>
+          </a:xfrm>
+          <a:prstGeom prst="roundRect">
+            <a:avLst>
+              <a:gd name="adj" fmla="val 5161"/>
+            </a:avLst>
+          </a:prstGeom>
+          <a:solidFill>
+            <a:schemeClr val="bg2"/>
+          </a:solidFill>
+          <a:ln/>
+        </p:spPr>
+      </p:sp>
+      <p:sp>
+        <p:nvSpPr>
+          <p:cNvPr id="17" name="Text 14"/>
+          <p:cNvSpPr txBox="1"/>
+          <p:nvPr/>
+        </p:nvSpPr>
+        <p:spPr>
+          <a:xfrm>
+            <a:off x="5897880" y="1371600"/>
+            <a:ext cx="2651760" cy="3154680"/>
+          </a:xfrm>
+          <a:prstGeom prst="rect">
+            <a:avLst/>
+          </a:prstGeom>
+          <a:noFill/>
+          <a:ln/>
+        </p:spPr>
+        <p:txBody>
+          <a:bodyPr wrap="square" lIns="0" tIns="0" rIns="0" bIns="0" rtlCol="0" anchor="ctr"/>
+          <a:lstStyle/>
+          <a:p>
+            <a:pPr marL="342900" indent="-342900">
+              <a:spcAft>
+                <a:spcPts val="600"/>
+              </a:spcAft>
+              <a:buSzPct val="100000"/>
+              <a:buChar char="•"/>
+            </a:pPr>
+            <a:r>
+              <a:rPr lang="en-US" sz="1400" dirty="0">
+                <a:solidFill>
+                  <a:schemeClr val="tx1"/>
+                </a:solidFill>
+              </a:rPr>
+              <a:t>Ledger-style app with rubber-stamp decisions and a seven-step pipeline strip</a:t>
+            </a:r>
+            <a:endParaRPr lang="en-US" sz="1400" dirty="0"/>
+          </a:p>
+          <a:p>
+            <a:pPr marL="342900" indent="-342900">
+              <a:spcAft>
+                <a:spcPts val="600"/>
+              </a:spcAft>
+              <a:buSzPct val="100000"/>
+              <a:buChar char="•"/>
+            </a:pPr>
+            <a:r>
+              <a:rPr lang="en-US" sz="1400" dirty="0">
+                <a:solidFill>
+                  <a:schemeClr val="tx1"/>
+                </a:solidFill>
+              </a:rPr>
+              <a:t>Case summary up front; findings and trace one click away</a:t>
+            </a:r>
+            <a:endParaRPr lang="en-US" sz="1400" dirty="0"/>
+          </a:p>
+          <a:p>
+            <a:pPr marL="342900" indent="-342900">
+              <a:spcAft>
+                <a:spcPts val="600"/>
+              </a:spcAft>
+              <a:buSzPct val="100000"/>
+              <a:buChar char="•"/>
+            </a:pPr>
+            <a:r>
+              <a:rPr lang="en-US" sz="1400" dirty="0">
+                <a:solidFill>
+                  <a:schemeClr val="tx1"/>
+                </a:solidFill>
+              </a:rPr>
+              <a:t>Approve, hold and reject carry equal weight</a:t>
+            </a:r>
+            <a:endParaRPr lang="en-US" sz="1400" dirty="0"/>
+          </a:p>
+          <a:p>
+            <a:pPr marL="342900" indent="-342900">
+              <a:spcAft>
+                <a:spcPts val="600"/>
+              </a:spcAft>
+              <a:buSzPct val="100000"/>
+              <a:buChar char="•"/>
+            </a:pPr>
+            <a:r>
+              <a:rPr lang="en-US" sz="1400" dirty="0">
+                <a:solidFill>
+                  <a:schemeClr val="tx1"/>
+                </a:solidFill>
+              </a:rPr>
+              <a:t>Every decision goes to the audit trail and vendor memory</a:t>
+            </a:r>
+            <a:endParaRPr lang="en-US" sz="1400" dirty="0"/>
+          </a:p>
+        </p:txBody>
+      </p:sp>
+      <p:pic>
+        <p:nvPicPr>
+          <p:cNvPr id="90" name="Review card screenshot" descr="Review queue case card for an escalated invoice from a lookalike vendor, fraud risk 90 of 100, with its case summary"/>
+          <p:cNvPicPr>
+            <a:picLocks noChangeAspect="1"/>
+          </p:cNvPicPr>
+          <p:nvPr/>
+        </p:nvPicPr>
+        <p:blipFill>
+          <a:blip r:embed="rId80"/>
+          <a:stretch>
+            <a:fillRect/>
+          </a:stretch>
+        </p:blipFill>
+        <p:spPr>
+          <a:xfrm>
+            <a:off x="457200" y="1188720"/>
+            <a:ext cx="5074920" cy="2562834"/>
+          </a:xfrm>
+          <a:prstGeom prst="rect">
+            <a:avLst/>
+          </a:prstGeom>
+          <a:ln w="9525">
+            <a:solidFill>
+              <a:schemeClr val="bg2"/>
+            </a:solidFill>
+          </a:ln>
+        </p:spPr>
+      </p:pic>
+      <p:sp>
+        <p:nvSpPr>
+          <p:cNvPr id="91" name="Caption"/>
+          <p:cNvSpPr txBox="1"/>
+          <p:nvPr/>
+        </p:nvSpPr>
+        <p:spPr>
+          <a:xfrm>
+            <a:off x="457200" y="3861282"/>
+            <a:ext cx="5074920" cy="320040"/>
+          </a:xfrm>
+          <a:prstGeom prst="rect">
+            <a:avLst/>
+          </a:prstGeom>
+          <a:noFill/>
+          <a:ln/>
+        </p:spPr>
+        <p:txBody>
+          <a:bodyPr wrap="square" lIns="0" tIns="0" rIns="0" bIns="0" rtlCol="0" anchor="t"/>
+          <a:lstStyle/>
+          <a:p>
+            <a:pPr indent="0" marL="0">
+              <a:buNone/>
+            </a:pPr>
+            <a:r>
+              <a:rPr lang="en-US" sz="1100" dirty="0">
+                <a:solidFill>
+                  <a:schemeClr val="tx1"/>
+                </a:solidFill>
+              </a:rPr>
+              <a:t>Review queue case card (real screenshot)</a:t>
+            </a:r>
+            <a:endParaRPr lang="en-US" sz="1100" dirty="0"/>
+          </a:p>
+        </p:txBody>
+      </p:sp>
+      <p:sp>
+        <p:nvSpPr>
+          <p:cNvPr id="18" name="Slide Number Placeholder 0"/>
+          <p:cNvSpPr>
+            <a:spLocks noGrp="1"/>
+          </p:cNvSpPr>
+          <p:nvPr>
+            <p:ph type="sldNum" sz="quarter" idx="4294967295"/>
+          </p:nvPr>
+        </p:nvSpPr>
+        <p:spPr>
+          <a:xfrm>
+            <a:off x="8321040" y="4754880"/>
+            <a:ext cx="457200" cy="274320"/>
+          </a:xfrm>
+          <a:prstGeom prst="rect">
+            <a:avLst/>
+          </a:prstGeom>
+          <a:extLst>
+            <a:ext uri="{C572A759-6A51-4108-AA02-DFA0A04FC94B}">
+              <ma14:wrappingTextBoxFlag xmlns:ma14="http://schemas.microsoft.com/office/mac/drawingml/2011/main" val="0"/>
+            </a:ext>
+          </a:extLst>
+        </p:spPr>
+        <p:txBody>
+          <a:bodyPr/>
+          <a:lstStyle>
+            <a:lvl1pPr>
+              <a:defRPr sz="1000">
+                <a:solidFill>
+                  <a:schemeClr val="accent5"/>
+                </a:solidFill>
+              </a:defRPr>
+            </a:lvl1pPr>
+          </a:lstStyle>
+          <a:p>
+            <a:pPr algn="l"/>
+            <a:fld id="{F7021451-1387-4CA6-816F-3879F97B5CBC}" type="slidenum">
+              <a:rPr b="0" lang="en-US"/>
+              <a:t>9</a:t>
             </a:fld>
             <a:endParaRPr lang="en-US"/>
           </a:p>
@@ -6681,7 +7872,7 @@
                   <a:schemeClr val="tx1"/>
                 </a:solidFill>
               </a:rPr>
-              <a:t>Rejects extractions that fail arithmetic checks; confirms every variance is explained</a:t>
+              <a:t>Rejects bad arithmetic or invented values; gets a model second opinion; checks every variance</a:t>
             </a:r>
             <a:endParaRPr lang="en-US" sz="1300" dirty="0"/>
           </a:p>
@@ -6957,7 +8148,7 @@
                   <a:schemeClr val="tx1"/>
                 </a:solidFill>
               </a:rPr>
-              <a:t>Flags lookalike vendors, bank changes and amount spikes; scores risk</a:t>
+              <a:t>Flags lookalike vendors, bank changes and spikes; scores and explains risk</a:t>
             </a:r>
             <a:endParaRPr lang="en-US" sz="1300" dirty="0"/>
           </a:p>
@@ -7095,7 +8286,7 @@
                   <a:schemeClr val="tx1"/>
                 </a:solidFill>
               </a:rPr>
-              <a:t>Applies business rules to approve, hold or escalate, and writes the reason</a:t>
+              <a:t>Applies rules to approve, hold or escalate; writes the reason and a case summary</a:t>
             </a:r>
             <a:endParaRPr lang="en-US" sz="1300" dirty="0"/>
           </a:p>
@@ -8455,7 +9646,7 @@
                   <a:schemeClr val="bg1"/>
                 </a:solidFill>
               </a:rPr>
-              <a:t>live agent trace, review queue, PDF upload, results, vendor memory</a:t>
+              <a:t>ledger-style app: live trace, pipeline strip, review queue, PDF upload, results</a:t>
             </a:r>
             <a:endParaRPr lang="en-US" sz="1500" dirty="0"/>
           </a:p>
@@ -9009,7 +10200,7 @@
                   <a:schemeClr val="tx1"/>
                 </a:solidFill>
               </a:rPr>
-              <a:t>Ollama local model or mock</a:t>
+              <a:t>Ollama local model (guarded) or rule-based mock</a:t>
             </a:r>
             <a:endParaRPr lang="en-US" sz="1400" dirty="0"/>
           </a:p>
@@ -9229,7 +10420,7 @@
             <a:pPr algn="l"/>
             <a:fld id="{F7021451-1387-4CA6-816F-3879F97B5CBC}" type="slidenum">
               <a:rPr b="0" lang="en-US"/>
-              <a:t>6</a:t>
+              <a:t>10</a:t>
             </a:fld>
             <a:endParaRPr lang="en-US"/>
           </a:p>
@@ -9592,7 +10783,7 @@
                   <a:schemeClr val="tx1"/>
                 </a:solidFill>
               </a:rPr>
-              <a:t>Watch each agent step live</a:t>
+              <a:t>Watch the pipeline strip and live trace</a:t>
             </a:r>
             <a:endParaRPr lang="en-US" sz="1200" dirty="0"/>
           </a:p>
@@ -9742,7 +10933,7 @@
                   <a:schemeClr val="tx1"/>
                 </a:solidFill>
               </a:rPr>
-              <a:t>Approve, hold or reject paused invoices</a:t>
+              <a:t>Read the case summary, then decide</a:t>
             </a:r>
             <a:endParaRPr lang="en-US" sz="1200" dirty="0"/>
           </a:p>
@@ -10117,7 +11308,7 @@
             <a:pPr algn="l"/>
             <a:fld id="{F7021451-1387-4CA6-816F-3879F97B5CBC}" type="slidenum">
               <a:rPr b="0" lang="en-US"/>
-              <a:t>7</a:t>
+              <a:t>11</a:t>
             </a:fld>
             <a:endParaRPr lang="en-US"/>
           </a:p>
@@ -10636,7 +11827,7 @@
                   <a:schemeClr val="tx1"/>
                 </a:solidFill>
               </a:rPr>
-              <a:t>The Critic loop fixed misread amounts before matching. 15 automated tests pass.</a:t>
+              <a:t>The Critic loop fixed misread amounts before matching. 24 automated tests pass.</a:t>
             </a:r>
             <a:endParaRPr lang="en-US" sz="1400" dirty="0"/>
           </a:p>
@@ -10699,7 +11890,7 @@
             <a:pPr algn="l"/>
             <a:fld id="{F7021451-1387-4CA6-816F-3879F97B5CBC}" type="slidenum">
               <a:rPr b="0" lang="en-US"/>
-              <a:t>8</a:t>
+              <a:t>12</a:t>
             </a:fld>
             <a:endParaRPr lang="en-US"/>
           </a:p>
@@ -11148,6 +12339,86 @@
       </p:sp>
       <p:sp>
         <p:nvSpPr>
+          <p:cNvPr id="95" name="badge"/>
+          <p:cNvSpPr/>
+          <p:nvPr/>
+        </p:nvSpPr>
+        <p:spPr>
+          <a:xfrm>
+            <a:off x="731520" y="4142232"/>
+            <a:ext cx="256032" cy="256032"/>
+          </a:xfrm>
+          <a:prstGeom prst="ellipse">
+            <a:avLst/>
+          </a:prstGeom>
+          <a:solidFill>
+            <a:schemeClr val="accent3"/>
+          </a:solidFill>
+          <a:ln/>
+        </p:spPr>
+      </p:sp>
+      <p:pic>
+        <p:nvPicPr>
+          <p:cNvPr id="96" name="Image 3b" descr="preencoded.png">    </p:cNvPr>
+          <p:cNvPicPr>
+            <a:picLocks noChangeAspect="1"/>
+          </p:cNvPicPr>
+          <p:nvPr/>
+        </p:nvPicPr>
+        <p:blipFill>
+          <a:blip r:embed="rId4"/>
+          <a:stretch>
+            <a:fillRect/>
+          </a:stretch>
+        </p:blipFill>
+        <p:spPr>
+          <a:xfrm>
+            <a:off x="795528" y="4206240"/>
+            <a:ext cx="128016" cy="128016"/>
+          </a:xfrm>
+          <a:prstGeom prst="rect">
+            <a:avLst/>
+          </a:prstGeom>
+        </p:spPr>
+      </p:pic>
+      <p:sp>
+        <p:nvSpPr>
+          <p:cNvPr id="97" name="Text 10b"/>
+          <p:cNvSpPr txBox="1"/>
+          <p:nvPr/>
+        </p:nvSpPr>
+        <p:spPr>
+          <a:xfrm>
+            <a:off x="1143000" y="4087368"/>
+            <a:ext cx="3108960" cy="457200"/>
+          </a:xfrm>
+          <a:prstGeom prst="rect">
+            <a:avLst/>
+          </a:prstGeom>
+          <a:noFill/>
+          <a:ln/>
+        </p:spPr>
+        <p:txBody>
+          <a:bodyPr wrap="square" lIns="0" tIns="0" rIns="0" bIns="0" rtlCol="0" anchor="ctr"/>
+          <a:lstStyle/>
+          <a:p>
+            <a:pPr indent="0" marL="0">
+              <a:buNone/>
+            </a:pPr>
+            <a:r>
+              <a:rPr lang="en-US" sz="1400" dirty="0">
+                <a:solidFill>
+                  <a:schemeClr val="tx1"/>
+                </a:solidFill>
+              </a:rPr>
+              <a:t>Ollama runs are slower; small models can misread fields</a:t>
+            </a:r>
+            <a:endParaRPr lang="en-US" sz="1400" dirty="0"/>
+          </a:p>
+        </p:txBody>
+      </p:sp>
+      <p:sp>
+        <p:nvSpPr>
           <p:cNvPr id="18" name="panel"/>
           <p:cNvSpPr/>
           <p:nvPr/>
@@ -11643,7 +12914,7 @@
             <a:pPr algn="l"/>
             <a:fld id="{F7021451-1387-4CA6-816F-3879F97B5CBC}" type="slidenum">
               <a:rPr b="0" lang="en-US"/>
-              <a:t>9</a:t>
+              <a:t>13</a:t>
             </a:fld>
             <a:endParaRPr lang="en-US"/>
           </a:p>

</xml_diff>